<commit_message>
am261x: endat/tamagawa: Update the documentation for examples
Fixes: PINDSW-7772

Signed-off-by: Dhaval Khandla <dhavaljk@ti.com>
</commit_message>
<xml_diff>
--- a/docs_src/docs/api_guide/images/images.pptx
+++ b/docs_src/docs/api_guide/images/images.pptx
@@ -7,8 +7,9 @@
   <p:sldIdLst>
     <p:sldId id="284" r:id="rId2"/>
     <p:sldId id="287" r:id="rId3"/>
-    <p:sldId id="288" r:id="rId4"/>
-    <p:sldId id="289" r:id="rId5"/>
+    <p:sldId id="290" r:id="rId4"/>
+    <p:sldId id="288" r:id="rId5"/>
+    <p:sldId id="289" r:id="rId6"/>
   </p:sldIdLst>
   <p:sldSz cx="14630400" cy="8229600"/>
   <p:notesSz cx="7559675" cy="10691813"/>
@@ -9685,10 +9686,886 @@
       </p:sp>
       <p:sp>
         <p:nvSpPr>
-          <p:cNvPr id="44" name="CustomShape 8">
+          <p:cNvPr id="76" name="CustomShape 4">
             <a:extLst>
               <a:ext uri="{FF2B5EF4-FFF2-40B4-BE49-F238E27FC236}">
-                <a16:creationId xmlns:a16="http://schemas.microsoft.com/office/drawing/2014/main" id="{64360DD5-025B-4378-8504-C84B4FA5AF28}"/>
+                <a16:creationId xmlns:a16="http://schemas.microsoft.com/office/drawing/2014/main" id="{1B024EA3-0E43-445D-BF88-EC0D5B5DFFBA}"/>
+              </a:ext>
+            </a:extLst>
+          </p:cNvPr>
+          <p:cNvSpPr/>
+          <p:nvPr/>
+        </p:nvSpPr>
+        <p:spPr>
+          <a:xfrm>
+            <a:off x="3815786" y="4256573"/>
+            <a:ext cx="1030713" cy="497783"/>
+          </a:xfrm>
+          <a:prstGeom prst="rect">
+            <a:avLst/>
+          </a:prstGeom>
+          <a:solidFill>
+            <a:schemeClr val="bg2"/>
+          </a:solidFill>
+          <a:ln>
+            <a:noFill/>
+          </a:ln>
+          <a:effectLst>
+            <a:outerShdw blurRad="50760" dist="37674" dir="2700000" algn="tl" rotWithShape="0">
+              <a:srgbClr val="000000">
+                <a:alpha val="40000"/>
+              </a:srgbClr>
+            </a:outerShdw>
+          </a:effectLst>
+        </p:spPr>
+        <p:style>
+          <a:lnRef idx="2">
+            <a:schemeClr val="accent1">
+              <a:shade val="50000"/>
+            </a:schemeClr>
+          </a:lnRef>
+          <a:fillRef idx="1">
+            <a:schemeClr val="accent1"/>
+          </a:fillRef>
+          <a:effectRef idx="0">
+            <a:schemeClr val="accent1"/>
+          </a:effectRef>
+          <a:fontRef idx="minor"/>
+        </p:style>
+        <p:txBody>
+          <a:bodyPr lIns="90000" tIns="45000" rIns="90000" bIns="45000" anchor="ctr">
+            <a:noAutofit/>
+          </a:bodyPr>
+          <a:lstStyle/>
+          <a:p>
+            <a:pPr algn="ctr"/>
+            <a:r>
+              <a:rPr lang="en-US" sz="1280" spc="-2" dirty="0">
+                <a:solidFill>
+                  <a:srgbClr val="FFFFFF"/>
+                </a:solidFill>
+                <a:latin typeface="Arial"/>
+              </a:rPr>
+              <a:t>SOC Peripheral</a:t>
+            </a:r>
+            <a:endParaRPr lang="en-IN" sz="1280" spc="-2" dirty="0">
+              <a:solidFill>
+                <a:srgbClr val="FFFFFF"/>
+              </a:solidFill>
+              <a:latin typeface="Arial"/>
+            </a:endParaRPr>
+          </a:p>
+        </p:txBody>
+      </p:sp>
+      <p:sp>
+        <p:nvSpPr>
+          <p:cNvPr id="78" name="CustomShape 8">
+            <a:extLst>
+              <a:ext uri="{FF2B5EF4-FFF2-40B4-BE49-F238E27FC236}">
+                <a16:creationId xmlns:a16="http://schemas.microsoft.com/office/drawing/2014/main" id="{490D27A3-6945-406A-BAF2-EFE79C38162A}"/>
+              </a:ext>
+            </a:extLst>
+          </p:cNvPr>
+          <p:cNvSpPr/>
+          <p:nvPr/>
+        </p:nvSpPr>
+        <p:spPr>
+          <a:xfrm>
+            <a:off x="6435589" y="3644037"/>
+            <a:ext cx="1093502" cy="508005"/>
+          </a:xfrm>
+          <a:prstGeom prst="rect">
+            <a:avLst/>
+          </a:prstGeom>
+          <a:solidFill>
+            <a:srgbClr val="00B0F0"/>
+          </a:solidFill>
+          <a:ln>
+            <a:noFill/>
+          </a:ln>
+          <a:effectLst>
+            <a:outerShdw blurRad="50760" dist="37674" dir="2700000" algn="tl" rotWithShape="0">
+              <a:srgbClr val="000000">
+                <a:alpha val="40000"/>
+              </a:srgbClr>
+            </a:outerShdw>
+          </a:effectLst>
+        </p:spPr>
+        <p:style>
+          <a:lnRef idx="2">
+            <a:schemeClr val="accent1">
+              <a:shade val="50000"/>
+            </a:schemeClr>
+          </a:lnRef>
+          <a:fillRef idx="1">
+            <a:schemeClr val="accent1"/>
+          </a:fillRef>
+          <a:effectRef idx="0">
+            <a:schemeClr val="accent1"/>
+          </a:effectRef>
+          <a:fontRef idx="minor"/>
+        </p:style>
+        <p:txBody>
+          <a:bodyPr lIns="90000" tIns="45000" rIns="90000" bIns="45000" anchor="ctr">
+            <a:noAutofit/>
+          </a:bodyPr>
+          <a:lstStyle/>
+          <a:p>
+            <a:pPr algn="ctr"/>
+            <a:r>
+              <a:rPr lang="en-IN" sz="1280" spc="-2" dirty="0">
+                <a:solidFill>
+                  <a:srgbClr val="000000"/>
+                </a:solidFill>
+                <a:latin typeface="Arial"/>
+              </a:rPr>
+              <a:t>Tamagawa</a:t>
+            </a:r>
+          </a:p>
+        </p:txBody>
+      </p:sp>
+      <p:sp>
+        <p:nvSpPr>
+          <p:cNvPr id="86" name="CustomShape 15">
+            <a:extLst>
+              <a:ext uri="{FF2B5EF4-FFF2-40B4-BE49-F238E27FC236}">
+                <a16:creationId xmlns:a16="http://schemas.microsoft.com/office/drawing/2014/main" id="{3A564F5B-DC40-45FF-8B10-DCCC5DE7D8E3}"/>
+              </a:ext>
+            </a:extLst>
+          </p:cNvPr>
+          <p:cNvSpPr/>
+          <p:nvPr/>
+        </p:nvSpPr>
+        <p:spPr>
+          <a:xfrm>
+            <a:off x="3815786" y="3662725"/>
+            <a:ext cx="1030713" cy="449641"/>
+          </a:xfrm>
+          <a:prstGeom prst="rect">
+            <a:avLst/>
+          </a:prstGeom>
+          <a:solidFill>
+            <a:schemeClr val="bg2"/>
+          </a:solidFill>
+          <a:ln>
+            <a:noFill/>
+          </a:ln>
+          <a:effectLst>
+            <a:outerShdw blurRad="50760" dist="37674" dir="2700000" algn="tl" rotWithShape="0">
+              <a:srgbClr val="000000">
+                <a:alpha val="40000"/>
+              </a:srgbClr>
+            </a:outerShdw>
+          </a:effectLst>
+        </p:spPr>
+        <p:style>
+          <a:lnRef idx="2">
+            <a:schemeClr val="accent1">
+              <a:shade val="50000"/>
+            </a:schemeClr>
+          </a:lnRef>
+          <a:fillRef idx="1">
+            <a:schemeClr val="accent1"/>
+          </a:fillRef>
+          <a:effectRef idx="0">
+            <a:schemeClr val="accent1"/>
+          </a:effectRef>
+          <a:fontRef idx="minor"/>
+        </p:style>
+        <p:txBody>
+          <a:bodyPr lIns="90000" tIns="45000" rIns="90000" bIns="45000" anchor="ctr">
+            <a:noAutofit/>
+          </a:bodyPr>
+          <a:lstStyle/>
+          <a:p>
+            <a:pPr algn="ctr"/>
+            <a:r>
+              <a:rPr lang="en-US" sz="1280" spc="-2" dirty="0">
+                <a:solidFill>
+                  <a:srgbClr val="FFFFFF"/>
+                </a:solidFill>
+                <a:latin typeface="Arial"/>
+              </a:rPr>
+              <a:t>Board Peripheral</a:t>
+            </a:r>
+            <a:endParaRPr lang="en-IN" sz="1280" spc="-2" dirty="0">
+              <a:solidFill>
+                <a:srgbClr val="FFFFFF"/>
+              </a:solidFill>
+              <a:latin typeface="Arial"/>
+            </a:endParaRPr>
+          </a:p>
+        </p:txBody>
+      </p:sp>
+      <p:sp>
+        <p:nvSpPr>
+          <p:cNvPr id="90" name="CustomShape 8">
+            <a:extLst>
+              <a:ext uri="{FF2B5EF4-FFF2-40B4-BE49-F238E27FC236}">
+                <a16:creationId xmlns:a16="http://schemas.microsoft.com/office/drawing/2014/main" id="{51B6AC0E-4960-4B0D-A32D-2DE55843B9E2}"/>
+              </a:ext>
+            </a:extLst>
+          </p:cNvPr>
+          <p:cNvSpPr/>
+          <p:nvPr/>
+        </p:nvSpPr>
+        <p:spPr>
+          <a:xfrm>
+            <a:off x="5131149" y="3640214"/>
+            <a:ext cx="1093502" cy="507271"/>
+          </a:xfrm>
+          <a:prstGeom prst="rect">
+            <a:avLst/>
+          </a:prstGeom>
+          <a:solidFill>
+            <a:srgbClr val="92D050"/>
+          </a:solidFill>
+          <a:ln>
+            <a:noFill/>
+          </a:ln>
+          <a:effectLst>
+            <a:outerShdw blurRad="50760" dist="37674" dir="2700000" algn="tl" rotWithShape="0">
+              <a:srgbClr val="000000">
+                <a:alpha val="40000"/>
+              </a:srgbClr>
+            </a:outerShdw>
+          </a:effectLst>
+        </p:spPr>
+        <p:style>
+          <a:lnRef idx="2">
+            <a:schemeClr val="accent1">
+              <a:shade val="50000"/>
+            </a:schemeClr>
+          </a:lnRef>
+          <a:fillRef idx="1">
+            <a:schemeClr val="accent1"/>
+          </a:fillRef>
+          <a:effectRef idx="0">
+            <a:schemeClr val="accent1"/>
+          </a:effectRef>
+          <a:fontRef idx="minor"/>
+        </p:style>
+        <p:txBody>
+          <a:bodyPr lIns="90000" tIns="45000" rIns="90000" bIns="45000" anchor="ctr">
+            <a:noAutofit/>
+          </a:bodyPr>
+          <a:lstStyle/>
+          <a:p>
+            <a:pPr algn="ctr"/>
+            <a:r>
+              <a:rPr lang="en-IN" sz="1280" spc="-2" dirty="0">
+                <a:solidFill>
+                  <a:srgbClr val="000000"/>
+                </a:solidFill>
+                <a:latin typeface="Arial"/>
+              </a:rPr>
+              <a:t>EtherCAT FW HAL</a:t>
+            </a:r>
+          </a:p>
+        </p:txBody>
+      </p:sp>
+      <p:sp>
+        <p:nvSpPr>
+          <p:cNvPr id="91" name="CustomShape 8">
+            <a:extLst>
+              <a:ext uri="{FF2B5EF4-FFF2-40B4-BE49-F238E27FC236}">
+                <a16:creationId xmlns:a16="http://schemas.microsoft.com/office/drawing/2014/main" id="{14161222-74A9-4F70-807B-78DD69EEE3D1}"/>
+              </a:ext>
+            </a:extLst>
+          </p:cNvPr>
+          <p:cNvSpPr/>
+          <p:nvPr/>
+        </p:nvSpPr>
+        <p:spPr>
+          <a:xfrm>
+            <a:off x="5129692" y="4291693"/>
+            <a:ext cx="1094959" cy="463845"/>
+          </a:xfrm>
+          <a:prstGeom prst="rect">
+            <a:avLst/>
+          </a:prstGeom>
+          <a:solidFill>
+            <a:srgbClr val="92D050"/>
+          </a:solidFill>
+          <a:ln>
+            <a:noFill/>
+          </a:ln>
+          <a:effectLst>
+            <a:outerShdw blurRad="50760" dist="37674" dir="2700000" algn="tl" rotWithShape="0">
+              <a:srgbClr val="000000">
+                <a:alpha val="40000"/>
+              </a:srgbClr>
+            </a:outerShdw>
+          </a:effectLst>
+        </p:spPr>
+        <p:style>
+          <a:lnRef idx="2">
+            <a:schemeClr val="accent1">
+              <a:shade val="50000"/>
+            </a:schemeClr>
+          </a:lnRef>
+          <a:fillRef idx="1">
+            <a:schemeClr val="accent1"/>
+          </a:fillRef>
+          <a:effectRef idx="0">
+            <a:schemeClr val="accent1"/>
+          </a:effectRef>
+          <a:fontRef idx="minor"/>
+        </p:style>
+        <p:txBody>
+          <a:bodyPr lIns="90000" tIns="45000" rIns="90000" bIns="45000" anchor="ctr">
+            <a:noAutofit/>
+          </a:bodyPr>
+          <a:lstStyle/>
+          <a:p>
+            <a:pPr algn="ctr"/>
+            <a:r>
+              <a:rPr lang="en-IN" sz="1280" spc="-2" dirty="0">
+                <a:solidFill>
+                  <a:srgbClr val="000000"/>
+                </a:solidFill>
+                <a:latin typeface="Arial"/>
+              </a:rPr>
+              <a:t>ICSS EMAC</a:t>
+            </a:r>
+          </a:p>
+        </p:txBody>
+      </p:sp>
+      <p:sp>
+        <p:nvSpPr>
+          <p:cNvPr id="92" name="CustomShape 14">
+            <a:extLst>
+              <a:ext uri="{FF2B5EF4-FFF2-40B4-BE49-F238E27FC236}">
+                <a16:creationId xmlns:a16="http://schemas.microsoft.com/office/drawing/2014/main" id="{E1B86C6F-42EE-44F6-AFD0-BB06C39225F2}"/>
+              </a:ext>
+            </a:extLst>
+          </p:cNvPr>
+          <p:cNvSpPr/>
+          <p:nvPr/>
+        </p:nvSpPr>
+        <p:spPr>
+          <a:xfrm>
+            <a:off x="1984105" y="2446421"/>
+            <a:ext cx="5738720" cy="858028"/>
+          </a:xfrm>
+          <a:prstGeom prst="rect">
+            <a:avLst/>
+          </a:prstGeom>
+          <a:noFill/>
+          <a:ln>
+            <a:solidFill>
+              <a:srgbClr val="000000"/>
+            </a:solidFill>
+            <a:round/>
+          </a:ln>
+        </p:spPr>
+        <p:style>
+          <a:lnRef idx="2">
+            <a:schemeClr val="accent1">
+              <a:shade val="50000"/>
+            </a:schemeClr>
+          </a:lnRef>
+          <a:fillRef idx="1">
+            <a:schemeClr val="accent1"/>
+          </a:fillRef>
+          <a:effectRef idx="0">
+            <a:schemeClr val="accent1"/>
+          </a:effectRef>
+          <a:fontRef idx="minor"/>
+        </p:style>
+        <p:txBody>
+          <a:bodyPr lIns="90000" tIns="45000" rIns="90000" bIns="45000" anchor="ctr">
+            <a:noAutofit/>
+          </a:bodyPr>
+          <a:lstStyle/>
+          <a:p>
+            <a:pPr>
+              <a:lnSpc>
+                <a:spcPct val="100000"/>
+              </a:lnSpc>
+              <a:buNone/>
+            </a:pPr>
+            <a:r>
+              <a:rPr lang="en-US" spc="-2" dirty="0">
+                <a:solidFill>
+                  <a:srgbClr val="000000"/>
+                </a:solidFill>
+                <a:latin typeface="Arial"/>
+              </a:rPr>
+              <a:t>Protocol Stacks </a:t>
+            </a:r>
+          </a:p>
+          <a:p>
+            <a:pPr>
+              <a:lnSpc>
+                <a:spcPct val="100000"/>
+              </a:lnSpc>
+              <a:buNone/>
+            </a:pPr>
+            <a:r>
+              <a:rPr lang="en-US" spc="-2" dirty="0">
+                <a:solidFill>
+                  <a:srgbClr val="000000"/>
+                </a:solidFill>
+                <a:latin typeface="Arial"/>
+              </a:rPr>
+              <a:t>and Middleware</a:t>
+            </a:r>
+            <a:endParaRPr lang="en-IN" spc="-2" dirty="0">
+              <a:latin typeface="Arial"/>
+            </a:endParaRPr>
+          </a:p>
+        </p:txBody>
+      </p:sp>
+      <p:sp>
+        <p:nvSpPr>
+          <p:cNvPr id="118" name="CustomShape 15">
+            <a:extLst>
+              <a:ext uri="{FF2B5EF4-FFF2-40B4-BE49-F238E27FC236}">
+                <a16:creationId xmlns:a16="http://schemas.microsoft.com/office/drawing/2014/main" id="{780414EF-B491-44AD-A87E-D8A46FD90D82}"/>
+              </a:ext>
+            </a:extLst>
+          </p:cNvPr>
+          <p:cNvSpPr/>
+          <p:nvPr/>
+        </p:nvSpPr>
+        <p:spPr>
+          <a:xfrm>
+            <a:off x="4385871" y="2678161"/>
+            <a:ext cx="1033751" cy="449641"/>
+          </a:xfrm>
+          <a:prstGeom prst="rect">
+            <a:avLst/>
+          </a:prstGeom>
+          <a:solidFill>
+            <a:schemeClr val="bg2"/>
+          </a:solidFill>
+          <a:ln>
+            <a:noFill/>
+          </a:ln>
+          <a:effectLst>
+            <a:outerShdw blurRad="50760" dist="37674" dir="2700000" algn="tl" rotWithShape="0">
+              <a:srgbClr val="000000">
+                <a:alpha val="40000"/>
+              </a:srgbClr>
+            </a:outerShdw>
+          </a:effectLst>
+        </p:spPr>
+        <p:style>
+          <a:lnRef idx="2">
+            <a:schemeClr val="accent1">
+              <a:shade val="50000"/>
+            </a:schemeClr>
+          </a:lnRef>
+          <a:fillRef idx="1">
+            <a:schemeClr val="accent1"/>
+          </a:fillRef>
+          <a:effectRef idx="0">
+            <a:schemeClr val="accent1"/>
+          </a:effectRef>
+          <a:fontRef idx="minor"/>
+        </p:style>
+        <p:txBody>
+          <a:bodyPr lIns="90000" tIns="45000" rIns="90000" bIns="45000" anchor="ctr">
+            <a:noAutofit/>
+          </a:bodyPr>
+          <a:lstStyle/>
+          <a:p>
+            <a:pPr algn="ctr"/>
+            <a:r>
+              <a:rPr lang="en-US" sz="1280" spc="-2" dirty="0">
+                <a:solidFill>
+                  <a:srgbClr val="FFFFFF"/>
+                </a:solidFill>
+                <a:latin typeface="Arial"/>
+              </a:rPr>
+              <a:t>LwIP</a:t>
+            </a:r>
+          </a:p>
+          <a:p>
+            <a:pPr algn="ctr"/>
+            <a:r>
+              <a:rPr lang="en-US" sz="1280" spc="-2" dirty="0">
+                <a:solidFill>
+                  <a:srgbClr val="FFFFFF"/>
+                </a:solidFill>
+                <a:latin typeface="Arial"/>
+              </a:rPr>
+              <a:t>(TCP/UDP)</a:t>
+            </a:r>
+            <a:endParaRPr lang="en-IN" sz="1280" spc="-2" dirty="0">
+              <a:solidFill>
+                <a:srgbClr val="FFFFFF"/>
+              </a:solidFill>
+              <a:latin typeface="Arial"/>
+            </a:endParaRPr>
+          </a:p>
+        </p:txBody>
+      </p:sp>
+      <p:sp>
+        <p:nvSpPr>
+          <p:cNvPr id="123" name="CustomShape 8">
+            <a:extLst>
+              <a:ext uri="{FF2B5EF4-FFF2-40B4-BE49-F238E27FC236}">
+                <a16:creationId xmlns:a16="http://schemas.microsoft.com/office/drawing/2014/main" id="{56CD9380-8E19-4FB9-90FF-E3C8CEFE4F07}"/>
+              </a:ext>
+            </a:extLst>
+          </p:cNvPr>
+          <p:cNvSpPr/>
+          <p:nvPr/>
+        </p:nvSpPr>
+        <p:spPr>
+          <a:xfrm>
+            <a:off x="5909216" y="2678161"/>
+            <a:ext cx="1052746" cy="449640"/>
+          </a:xfrm>
+          <a:prstGeom prst="rect">
+            <a:avLst/>
+          </a:prstGeom>
+          <a:solidFill>
+            <a:srgbClr val="92D050"/>
+          </a:solidFill>
+          <a:ln>
+            <a:noFill/>
+          </a:ln>
+          <a:effectLst>
+            <a:outerShdw blurRad="50760" dist="37674" dir="2700000" algn="tl" rotWithShape="0">
+              <a:srgbClr val="000000">
+                <a:alpha val="40000"/>
+              </a:srgbClr>
+            </a:outerShdw>
+          </a:effectLst>
+        </p:spPr>
+        <p:style>
+          <a:lnRef idx="2">
+            <a:schemeClr val="accent1">
+              <a:shade val="50000"/>
+            </a:schemeClr>
+          </a:lnRef>
+          <a:fillRef idx="1">
+            <a:schemeClr val="accent1"/>
+          </a:fillRef>
+          <a:effectRef idx="0">
+            <a:schemeClr val="accent1"/>
+          </a:effectRef>
+          <a:fontRef idx="minor"/>
+        </p:style>
+        <p:txBody>
+          <a:bodyPr lIns="90000" tIns="45000" rIns="90000" bIns="45000" anchor="ctr">
+            <a:noAutofit/>
+          </a:bodyPr>
+          <a:lstStyle/>
+          <a:p>
+            <a:pPr algn="ctr"/>
+            <a:r>
+              <a:rPr lang="en-IN" sz="1280" spc="-2" dirty="0">
+                <a:solidFill>
+                  <a:srgbClr val="000000"/>
+                </a:solidFill>
+                <a:latin typeface="Arial"/>
+              </a:rPr>
+              <a:t>EtherCAT</a:t>
+            </a:r>
+          </a:p>
+        </p:txBody>
+      </p:sp>
+      <p:sp>
+        <p:nvSpPr>
+          <p:cNvPr id="142" name="CustomShape 8">
+            <a:extLst>
+              <a:ext uri="{FF2B5EF4-FFF2-40B4-BE49-F238E27FC236}">
+                <a16:creationId xmlns:a16="http://schemas.microsoft.com/office/drawing/2014/main" id="{84F12E88-D8B0-41DD-AAA0-7C765BE9231D}"/>
+              </a:ext>
+            </a:extLst>
+          </p:cNvPr>
+          <p:cNvSpPr/>
+          <p:nvPr/>
+        </p:nvSpPr>
+        <p:spPr>
+          <a:xfrm>
+            <a:off x="5025670" y="999061"/>
+            <a:ext cx="1185077" cy="455099"/>
+          </a:xfrm>
+          <a:prstGeom prst="rect">
+            <a:avLst/>
+          </a:prstGeom>
+          <a:solidFill>
+            <a:srgbClr val="92D050"/>
+          </a:solidFill>
+          <a:ln>
+            <a:noFill/>
+          </a:ln>
+          <a:effectLst>
+            <a:outerShdw blurRad="50760" dist="37674" dir="2700000" algn="tl" rotWithShape="0">
+              <a:srgbClr val="000000">
+                <a:alpha val="40000"/>
+              </a:srgbClr>
+            </a:outerShdw>
+          </a:effectLst>
+        </p:spPr>
+        <p:style>
+          <a:lnRef idx="2">
+            <a:schemeClr val="accent1">
+              <a:shade val="50000"/>
+            </a:schemeClr>
+          </a:lnRef>
+          <a:fillRef idx="1">
+            <a:schemeClr val="accent1"/>
+          </a:fillRef>
+          <a:effectRef idx="0">
+            <a:schemeClr val="accent1"/>
+          </a:effectRef>
+          <a:fontRef idx="minor"/>
+        </p:style>
+        <p:txBody>
+          <a:bodyPr lIns="90000" tIns="45000" rIns="90000" bIns="45000" anchor="ctr">
+            <a:noAutofit/>
+          </a:bodyPr>
+          <a:lstStyle/>
+          <a:p>
+            <a:pPr algn="ctr"/>
+            <a:r>
+              <a:rPr lang="en-IN" sz="1280" spc="-2" dirty="0">
+                <a:solidFill>
+                  <a:srgbClr val="000000"/>
+                </a:solidFill>
+                <a:latin typeface="Arial"/>
+              </a:rPr>
+              <a:t>EtherCAT</a:t>
+            </a:r>
+          </a:p>
+        </p:txBody>
+      </p:sp>
+      <p:sp>
+        <p:nvSpPr>
+          <p:cNvPr id="69" name="CustomShape 15">
+            <a:extLst>
+              <a:ext uri="{FF2B5EF4-FFF2-40B4-BE49-F238E27FC236}">
+                <a16:creationId xmlns:a16="http://schemas.microsoft.com/office/drawing/2014/main" id="{94A9817F-8321-4B48-A6E6-43178676CCF7}"/>
+              </a:ext>
+            </a:extLst>
+          </p:cNvPr>
+          <p:cNvSpPr/>
+          <p:nvPr/>
+        </p:nvSpPr>
+        <p:spPr>
+          <a:xfrm>
+            <a:off x="6415211" y="1588356"/>
+            <a:ext cx="1094959" cy="501106"/>
+          </a:xfrm>
+          <a:prstGeom prst="rect">
+            <a:avLst/>
+          </a:prstGeom>
+          <a:solidFill>
+            <a:srgbClr val="00B0F0"/>
+          </a:solidFill>
+          <a:ln>
+            <a:noFill/>
+          </a:ln>
+          <a:effectLst>
+            <a:outerShdw blurRad="50760" dist="37674" dir="2700000" algn="tl" rotWithShape="0">
+              <a:srgbClr val="000000">
+                <a:alpha val="40000"/>
+              </a:srgbClr>
+            </a:outerShdw>
+          </a:effectLst>
+        </p:spPr>
+        <p:style>
+          <a:lnRef idx="2">
+            <a:schemeClr val="accent1">
+              <a:shade val="50000"/>
+            </a:schemeClr>
+          </a:lnRef>
+          <a:fillRef idx="1">
+            <a:schemeClr val="accent1"/>
+          </a:fillRef>
+          <a:effectRef idx="0">
+            <a:schemeClr val="accent1"/>
+          </a:effectRef>
+          <a:fontRef idx="minor"/>
+        </p:style>
+        <p:txBody>
+          <a:bodyPr lIns="90000" tIns="45000" rIns="90000" bIns="45000" anchor="ctr">
+            <a:noAutofit/>
+          </a:bodyPr>
+          <a:lstStyle/>
+          <a:p>
+            <a:pPr algn="ctr"/>
+            <a:r>
+              <a:rPr lang="en-US" sz="1280" spc="-2" dirty="0">
+                <a:solidFill>
+                  <a:srgbClr val="000000"/>
+                </a:solidFill>
+              </a:rPr>
+              <a:t>RTLibs</a:t>
+            </a:r>
+            <a:endParaRPr lang="en-IN" sz="1280" spc="-2" dirty="0">
+              <a:solidFill>
+                <a:srgbClr val="000000"/>
+              </a:solidFill>
+              <a:latin typeface="Arial"/>
+            </a:endParaRPr>
+          </a:p>
+        </p:txBody>
+      </p:sp>
+      <p:sp>
+        <p:nvSpPr>
+          <p:cNvPr id="70" name="CustomShape 8">
+            <a:extLst>
+              <a:ext uri="{FF2B5EF4-FFF2-40B4-BE49-F238E27FC236}">
+                <a16:creationId xmlns:a16="http://schemas.microsoft.com/office/drawing/2014/main" id="{ACF071DC-726D-42F2-B042-ED4EC811037C}"/>
+              </a:ext>
+            </a:extLst>
+          </p:cNvPr>
+          <p:cNvSpPr/>
+          <p:nvPr/>
+        </p:nvSpPr>
+        <p:spPr>
+          <a:xfrm>
+            <a:off x="6415211" y="999062"/>
+            <a:ext cx="1093502" cy="449642"/>
+          </a:xfrm>
+          <a:prstGeom prst="rect">
+            <a:avLst/>
+          </a:prstGeom>
+          <a:solidFill>
+            <a:srgbClr val="00B0F0"/>
+          </a:solidFill>
+          <a:ln>
+            <a:noFill/>
+          </a:ln>
+          <a:effectLst>
+            <a:outerShdw blurRad="50760" dist="37674" dir="2700000" algn="tl" rotWithShape="0">
+              <a:srgbClr val="000000">
+                <a:alpha val="40000"/>
+              </a:srgbClr>
+            </a:outerShdw>
+          </a:effectLst>
+        </p:spPr>
+        <p:style>
+          <a:lnRef idx="2">
+            <a:schemeClr val="accent1">
+              <a:shade val="50000"/>
+            </a:schemeClr>
+          </a:lnRef>
+          <a:fillRef idx="1">
+            <a:schemeClr val="accent1"/>
+          </a:fillRef>
+          <a:effectRef idx="0">
+            <a:schemeClr val="accent1"/>
+          </a:effectRef>
+          <a:fontRef idx="minor"/>
+        </p:style>
+        <p:txBody>
+          <a:bodyPr lIns="90000" tIns="45000" rIns="90000" bIns="45000" anchor="ctr">
+            <a:noAutofit/>
+          </a:bodyPr>
+          <a:lstStyle/>
+          <a:p>
+            <a:pPr algn="ctr"/>
+            <a:r>
+              <a:rPr lang="en-IN" sz="1280" spc="-2" dirty="0">
+                <a:solidFill>
+                  <a:srgbClr val="000000"/>
+                </a:solidFill>
+                <a:latin typeface="Arial"/>
+              </a:rPr>
+              <a:t>Tamagawa</a:t>
+            </a:r>
+          </a:p>
+        </p:txBody>
+      </p:sp>
+      <p:sp>
+        <p:nvSpPr>
+          <p:cNvPr id="38" name="CustomShape 8">
+            <a:extLst>
+              <a:ext uri="{FF2B5EF4-FFF2-40B4-BE49-F238E27FC236}">
+                <a16:creationId xmlns:a16="http://schemas.microsoft.com/office/drawing/2014/main" id="{5211EEA9-63DF-4DAF-B441-2B51CD21E224}"/>
+              </a:ext>
+            </a:extLst>
+          </p:cNvPr>
+          <p:cNvSpPr/>
+          <p:nvPr/>
+        </p:nvSpPr>
+        <p:spPr>
+          <a:xfrm>
+            <a:off x="5025671" y="1598368"/>
+            <a:ext cx="1186534" cy="491094"/>
+          </a:xfrm>
+          <a:prstGeom prst="rect">
+            <a:avLst/>
+          </a:prstGeom>
+          <a:solidFill>
+            <a:srgbClr val="00B0F0"/>
+          </a:solidFill>
+          <a:ln>
+            <a:noFill/>
+          </a:ln>
+          <a:effectLst>
+            <a:outerShdw blurRad="50760" dist="37674" dir="2700000" algn="tl" rotWithShape="0">
+              <a:srgbClr val="000000">
+                <a:alpha val="40000"/>
+              </a:srgbClr>
+            </a:outerShdw>
+          </a:effectLst>
+        </p:spPr>
+        <p:style>
+          <a:lnRef idx="2">
+            <a:schemeClr val="accent1">
+              <a:shade val="50000"/>
+            </a:schemeClr>
+          </a:lnRef>
+          <a:fillRef idx="1">
+            <a:schemeClr val="accent1"/>
+          </a:fillRef>
+          <a:effectRef idx="0">
+            <a:schemeClr val="accent1"/>
+          </a:effectRef>
+          <a:fontRef idx="minor"/>
+        </p:style>
+        <p:txBody>
+          <a:bodyPr wrap="none" lIns="90000" tIns="45000" rIns="90000" bIns="45000" anchor="ctr">
+            <a:noAutofit/>
+          </a:bodyPr>
+          <a:lstStyle/>
+          <a:p>
+            <a:pPr algn="ctr"/>
+            <a:r>
+              <a:rPr lang="en-US" sz="1100" dirty="0">
+                <a:latin typeface="Calibri" panose="020F0502020204030204" pitchFamily="34" charset="0"/>
+                <a:cs typeface="Calibri" panose="020F0502020204030204" pitchFamily="34" charset="0"/>
+              </a:rPr>
+              <a:t>Universal Motor </a:t>
+            </a:r>
+          </a:p>
+          <a:p>
+            <a:pPr algn="ctr"/>
+            <a:r>
+              <a:rPr lang="en-US" sz="1100" dirty="0">
+                <a:latin typeface="Calibri" panose="020F0502020204030204" pitchFamily="34" charset="0"/>
+                <a:cs typeface="Calibri" panose="020F0502020204030204" pitchFamily="34" charset="0"/>
+              </a:rPr>
+              <a:t>Control</a:t>
+            </a:r>
+          </a:p>
+          <a:p>
+            <a:pPr algn="ctr"/>
+            <a:r>
+              <a:rPr lang="en-US" sz="1100" dirty="0">
+                <a:latin typeface="Calibri" panose="020F0502020204030204" pitchFamily="34" charset="0"/>
+                <a:cs typeface="Calibri" panose="020F0502020204030204" pitchFamily="34" charset="0"/>
+              </a:rPr>
+              <a:t>Reference Design</a:t>
+            </a:r>
+          </a:p>
+        </p:txBody>
+      </p:sp>
+      <p:sp>
+        <p:nvSpPr>
+          <p:cNvPr id="43" name="CustomShape 8">
+            <a:extLst>
+              <a:ext uri="{FF2B5EF4-FFF2-40B4-BE49-F238E27FC236}">
+                <a16:creationId xmlns:a16="http://schemas.microsoft.com/office/drawing/2014/main" id="{F79820AA-3E72-410A-9A25-5E06BE8DF841}"/>
               </a:ext>
             </a:extLst>
           </p:cNvPr>
@@ -9753,6 +10630,1772 @@
               </a:solidFill>
               <a:latin typeface="Arial"/>
             </a:endParaRPr>
+          </a:p>
+        </p:txBody>
+      </p:sp>
+    </p:spTree>
+    <p:extLst>
+      <p:ext uri="{BB962C8B-B14F-4D97-AF65-F5344CB8AC3E}">
+        <p14:creationId xmlns:p14="http://schemas.microsoft.com/office/powerpoint/2010/main" val="3200722840"/>
+      </p:ext>
+    </p:extLst>
+  </p:cSld>
+  <p:clrMapOvr>
+    <a:masterClrMapping/>
+  </p:clrMapOvr>
+</p:sld>
+</file>
+
+<file path=ppt/slides/slide3.xml><?xml version="1.0" encoding="utf-8"?>
+<p:sld xmlns:a="http://schemas.openxmlformats.org/drawingml/2006/main" xmlns:r="http://schemas.openxmlformats.org/officeDocument/2006/relationships" xmlns:p="http://schemas.openxmlformats.org/presentationml/2006/main">
+  <p:cSld>
+    <p:spTree>
+      <p:nvGrpSpPr>
+        <p:cNvPr id="1" name=""/>
+        <p:cNvGrpSpPr/>
+        <p:nvPr/>
+      </p:nvGrpSpPr>
+      <p:grpSpPr>
+        <a:xfrm>
+          <a:off x="0" y="0"/>
+          <a:ext cx="0" cy="0"/>
+          <a:chOff x="0" y="0"/>
+          <a:chExt cx="0" cy="0"/>
+        </a:xfrm>
+      </p:grpSpPr>
+      <p:sp>
+        <p:nvSpPr>
+          <p:cNvPr id="2" name="Title 1">
+            <a:extLst>
+              <a:ext uri="{FF2B5EF4-FFF2-40B4-BE49-F238E27FC236}">
+                <a16:creationId xmlns:a16="http://schemas.microsoft.com/office/drawing/2014/main" id="{2725729B-986F-4361-8441-2202045AB807}"/>
+              </a:ext>
+            </a:extLst>
+          </p:cNvPr>
+          <p:cNvSpPr>
+            <a:spLocks noGrp="1"/>
+          </p:cNvSpPr>
+          <p:nvPr>
+            <p:ph type="title"/>
+          </p:nvPr>
+        </p:nvSpPr>
+        <p:spPr>
+          <a:xfrm>
+            <a:off x="370840" y="171461"/>
+            <a:ext cx="13533120" cy="448308"/>
+          </a:xfrm>
+        </p:spPr>
+        <p:txBody>
+          <a:bodyPr/>
+          <a:lstStyle/>
+          <a:p>
+            <a:r>
+              <a:rPr lang="en-US" sz="2800" dirty="0"/>
+              <a:t>Motor Control SDK </a:t>
+            </a:r>
+            <a:r>
+              <a:rPr lang="en-US" sz="2800" dirty="0">
+                <a:solidFill>
+                  <a:schemeClr val="tx1"/>
+                </a:solidFill>
+              </a:rPr>
+              <a:t>| Component Mapping for AM261x</a:t>
+            </a:r>
+          </a:p>
+        </p:txBody>
+      </p:sp>
+      <p:sp>
+        <p:nvSpPr>
+          <p:cNvPr id="93" name="CustomShape 1">
+            <a:extLst>
+              <a:ext uri="{FF2B5EF4-FFF2-40B4-BE49-F238E27FC236}">
+                <a16:creationId xmlns:a16="http://schemas.microsoft.com/office/drawing/2014/main" id="{F2BD7EF1-9939-4343-B882-9BB7D2B6DE8E}"/>
+              </a:ext>
+            </a:extLst>
+          </p:cNvPr>
+          <p:cNvSpPr/>
+          <p:nvPr/>
+        </p:nvSpPr>
+        <p:spPr>
+          <a:xfrm>
+            <a:off x="1984105" y="5123174"/>
+            <a:ext cx="5749210" cy="1005164"/>
+          </a:xfrm>
+          <a:prstGeom prst="rect">
+            <a:avLst/>
+          </a:prstGeom>
+          <a:noFill/>
+          <a:ln>
+            <a:solidFill>
+              <a:srgbClr val="000000"/>
+            </a:solidFill>
+            <a:round/>
+          </a:ln>
+        </p:spPr>
+        <p:style>
+          <a:lnRef idx="2">
+            <a:schemeClr val="accent1">
+              <a:shade val="50000"/>
+            </a:schemeClr>
+          </a:lnRef>
+          <a:fillRef idx="1">
+            <a:schemeClr val="accent1"/>
+          </a:fillRef>
+          <a:effectRef idx="0">
+            <a:schemeClr val="accent1"/>
+          </a:effectRef>
+          <a:fontRef idx="minor"/>
+        </p:style>
+        <p:txBody>
+          <a:bodyPr lIns="90000" tIns="45000" rIns="90000" bIns="45000" anchor="ctr">
+            <a:noAutofit/>
+          </a:bodyPr>
+          <a:lstStyle/>
+          <a:p>
+            <a:pPr>
+              <a:lnSpc>
+                <a:spcPct val="100000"/>
+              </a:lnSpc>
+              <a:buNone/>
+            </a:pPr>
+            <a:r>
+              <a:rPr lang="en-US" spc="-2" dirty="0">
+                <a:solidFill>
+                  <a:srgbClr val="000000"/>
+                </a:solidFill>
+                <a:latin typeface="Arial"/>
+                <a:ea typeface="DejaVu Sans"/>
+              </a:rPr>
+              <a:t>OS Kernel</a:t>
+            </a:r>
+            <a:endParaRPr lang="en-IN" spc="-2" dirty="0">
+              <a:latin typeface="Arial"/>
+            </a:endParaRPr>
+          </a:p>
+        </p:txBody>
+      </p:sp>
+      <p:sp>
+        <p:nvSpPr>
+          <p:cNvPr id="94" name="CustomShape 3">
+            <a:extLst>
+              <a:ext uri="{FF2B5EF4-FFF2-40B4-BE49-F238E27FC236}">
+                <a16:creationId xmlns:a16="http://schemas.microsoft.com/office/drawing/2014/main" id="{F396EB7B-63A1-4BA5-B2F2-757577BDD2A9}"/>
+              </a:ext>
+            </a:extLst>
+          </p:cNvPr>
+          <p:cNvSpPr/>
+          <p:nvPr/>
+        </p:nvSpPr>
+        <p:spPr>
+          <a:xfrm>
+            <a:off x="5129692" y="5199495"/>
+            <a:ext cx="2399399" cy="379800"/>
+          </a:xfrm>
+          <a:prstGeom prst="rect">
+            <a:avLst/>
+          </a:prstGeom>
+          <a:solidFill>
+            <a:schemeClr val="bg2"/>
+          </a:solidFill>
+          <a:ln>
+            <a:noFill/>
+          </a:ln>
+          <a:effectLst>
+            <a:outerShdw blurRad="50760" dist="37674" dir="2700000" algn="tl" rotWithShape="0">
+              <a:srgbClr val="000000">
+                <a:alpha val="40000"/>
+              </a:srgbClr>
+            </a:outerShdw>
+          </a:effectLst>
+        </p:spPr>
+        <p:style>
+          <a:lnRef idx="2">
+            <a:schemeClr val="accent1">
+              <a:shade val="50000"/>
+            </a:schemeClr>
+          </a:lnRef>
+          <a:fillRef idx="1">
+            <a:schemeClr val="accent1"/>
+          </a:fillRef>
+          <a:effectRef idx="0">
+            <a:schemeClr val="accent1"/>
+          </a:effectRef>
+          <a:fontRef idx="minor"/>
+        </p:style>
+        <p:txBody>
+          <a:bodyPr lIns="90000" tIns="45000" rIns="90000" bIns="45000" anchor="ctr">
+            <a:noAutofit/>
+          </a:bodyPr>
+          <a:lstStyle/>
+          <a:p>
+            <a:pPr algn="ctr">
+              <a:lnSpc>
+                <a:spcPct val="100000"/>
+              </a:lnSpc>
+              <a:buNone/>
+            </a:pPr>
+            <a:r>
+              <a:rPr lang="en-US" sz="1200" spc="-2" dirty="0">
+                <a:solidFill>
+                  <a:srgbClr val="FFFFFF"/>
+                </a:solidFill>
+                <a:latin typeface="Arial"/>
+                <a:ea typeface="DejaVu Sans"/>
+              </a:rPr>
+              <a:t>Driver Porting Layer (DPL)</a:t>
+            </a:r>
+            <a:endParaRPr lang="en-IN" sz="1200" spc="-2" dirty="0">
+              <a:latin typeface="Arial"/>
+            </a:endParaRPr>
+          </a:p>
+        </p:txBody>
+      </p:sp>
+      <p:sp>
+        <p:nvSpPr>
+          <p:cNvPr id="96" name="CustomShape 5">
+            <a:extLst>
+              <a:ext uri="{FF2B5EF4-FFF2-40B4-BE49-F238E27FC236}">
+                <a16:creationId xmlns:a16="http://schemas.microsoft.com/office/drawing/2014/main" id="{59C50511-9CD0-4024-89B9-50BB30830633}"/>
+              </a:ext>
+            </a:extLst>
+          </p:cNvPr>
+          <p:cNvSpPr/>
+          <p:nvPr/>
+        </p:nvSpPr>
+        <p:spPr>
+          <a:xfrm>
+            <a:off x="6506435" y="5655616"/>
+            <a:ext cx="1002278" cy="379800"/>
+          </a:xfrm>
+          <a:prstGeom prst="rect">
+            <a:avLst/>
+          </a:prstGeom>
+          <a:solidFill>
+            <a:schemeClr val="bg2"/>
+          </a:solidFill>
+          <a:ln>
+            <a:noFill/>
+          </a:ln>
+          <a:effectLst>
+            <a:outerShdw blurRad="50760" dist="37674" dir="2700000" algn="tl" rotWithShape="0">
+              <a:srgbClr val="000000">
+                <a:alpha val="40000"/>
+              </a:srgbClr>
+            </a:outerShdw>
+          </a:effectLst>
+        </p:spPr>
+        <p:style>
+          <a:lnRef idx="2">
+            <a:schemeClr val="accent1">
+              <a:shade val="50000"/>
+            </a:schemeClr>
+          </a:lnRef>
+          <a:fillRef idx="1">
+            <a:schemeClr val="accent1"/>
+          </a:fillRef>
+          <a:effectRef idx="0">
+            <a:schemeClr val="accent1"/>
+          </a:effectRef>
+          <a:fontRef idx="minor"/>
+        </p:style>
+        <p:txBody>
+          <a:bodyPr lIns="90000" tIns="45000" rIns="90000" bIns="45000" anchor="ctr">
+            <a:noAutofit/>
+          </a:bodyPr>
+          <a:lstStyle/>
+          <a:p>
+            <a:pPr algn="ctr">
+              <a:lnSpc>
+                <a:spcPct val="100000"/>
+              </a:lnSpc>
+              <a:buNone/>
+            </a:pPr>
+            <a:r>
+              <a:rPr lang="en-US" sz="1200" spc="-2" dirty="0">
+                <a:solidFill>
+                  <a:srgbClr val="FFFFFF"/>
+                </a:solidFill>
+                <a:latin typeface="Arial"/>
+                <a:ea typeface="DejaVu Sans"/>
+              </a:rPr>
+              <a:t>No RTOS</a:t>
+            </a:r>
+            <a:endParaRPr lang="en-IN" sz="1200" spc="-2" dirty="0">
+              <a:latin typeface="Arial"/>
+            </a:endParaRPr>
+          </a:p>
+        </p:txBody>
+      </p:sp>
+      <p:sp>
+        <p:nvSpPr>
+          <p:cNvPr id="97" name="CustomShape 6">
+            <a:extLst>
+              <a:ext uri="{FF2B5EF4-FFF2-40B4-BE49-F238E27FC236}">
+                <a16:creationId xmlns:a16="http://schemas.microsoft.com/office/drawing/2014/main" id="{4EC958E8-FC03-4C5C-9647-29B758349B13}"/>
+              </a:ext>
+            </a:extLst>
+          </p:cNvPr>
+          <p:cNvSpPr/>
+          <p:nvPr/>
+        </p:nvSpPr>
+        <p:spPr>
+          <a:xfrm>
+            <a:off x="5129692" y="5665489"/>
+            <a:ext cx="1266164" cy="379800"/>
+          </a:xfrm>
+          <a:prstGeom prst="rect">
+            <a:avLst/>
+          </a:prstGeom>
+          <a:solidFill>
+            <a:schemeClr val="bg2"/>
+          </a:solidFill>
+          <a:ln>
+            <a:noFill/>
+          </a:ln>
+          <a:effectLst>
+            <a:outerShdw blurRad="50760" dist="37674" dir="2700000" algn="tl" rotWithShape="0">
+              <a:srgbClr val="000000">
+                <a:alpha val="40000"/>
+              </a:srgbClr>
+            </a:outerShdw>
+          </a:effectLst>
+        </p:spPr>
+        <p:style>
+          <a:lnRef idx="2">
+            <a:schemeClr val="accent1">
+              <a:shade val="50000"/>
+            </a:schemeClr>
+          </a:lnRef>
+          <a:fillRef idx="1">
+            <a:schemeClr val="accent1"/>
+          </a:fillRef>
+          <a:effectRef idx="0">
+            <a:schemeClr val="accent1"/>
+          </a:effectRef>
+          <a:fontRef idx="minor"/>
+        </p:style>
+        <p:txBody>
+          <a:bodyPr lIns="90000" tIns="45000" rIns="90000" bIns="45000" anchor="ctr">
+            <a:noAutofit/>
+          </a:bodyPr>
+          <a:lstStyle/>
+          <a:p>
+            <a:pPr algn="ctr">
+              <a:lnSpc>
+                <a:spcPct val="100000"/>
+              </a:lnSpc>
+              <a:buNone/>
+            </a:pPr>
+            <a:r>
+              <a:rPr lang="en-US" sz="1200" spc="-2" dirty="0">
+                <a:solidFill>
+                  <a:srgbClr val="FFFFFF"/>
+                </a:solidFill>
+                <a:latin typeface="Arial"/>
+                <a:ea typeface="DejaVu Sans"/>
+              </a:rPr>
+              <a:t>FreeRTOS Kernel</a:t>
+            </a:r>
+            <a:endParaRPr lang="en-IN" sz="1200" spc="-2" dirty="0">
+              <a:latin typeface="Arial"/>
+            </a:endParaRPr>
+          </a:p>
+        </p:txBody>
+      </p:sp>
+      <p:sp>
+        <p:nvSpPr>
+          <p:cNvPr id="98" name="CustomShape 7">
+            <a:extLst>
+              <a:ext uri="{FF2B5EF4-FFF2-40B4-BE49-F238E27FC236}">
+                <a16:creationId xmlns:a16="http://schemas.microsoft.com/office/drawing/2014/main" id="{BBDFF6FF-96DF-415E-B361-BF5DECAA8CF2}"/>
+              </a:ext>
+            </a:extLst>
+          </p:cNvPr>
+          <p:cNvSpPr/>
+          <p:nvPr/>
+        </p:nvSpPr>
+        <p:spPr>
+          <a:xfrm>
+            <a:off x="3841538" y="5208289"/>
+            <a:ext cx="1002278" cy="837000"/>
+          </a:xfrm>
+          <a:prstGeom prst="rect">
+            <a:avLst/>
+          </a:prstGeom>
+          <a:solidFill>
+            <a:schemeClr val="bg2"/>
+          </a:solidFill>
+          <a:ln>
+            <a:noFill/>
+          </a:ln>
+          <a:effectLst>
+            <a:outerShdw blurRad="50760" dist="37674" dir="2700000" algn="tl" rotWithShape="0">
+              <a:srgbClr val="000000">
+                <a:alpha val="40000"/>
+              </a:srgbClr>
+            </a:outerShdw>
+          </a:effectLst>
+        </p:spPr>
+        <p:style>
+          <a:lnRef idx="2">
+            <a:schemeClr val="accent1">
+              <a:shade val="50000"/>
+            </a:schemeClr>
+          </a:lnRef>
+          <a:fillRef idx="1">
+            <a:schemeClr val="accent1"/>
+          </a:fillRef>
+          <a:effectRef idx="0">
+            <a:schemeClr val="accent1"/>
+          </a:effectRef>
+          <a:fontRef idx="minor"/>
+        </p:style>
+        <p:txBody>
+          <a:bodyPr lIns="90000" tIns="45000" rIns="90000" bIns="45000" anchor="ctr">
+            <a:noAutofit/>
+          </a:bodyPr>
+          <a:lstStyle/>
+          <a:p>
+            <a:pPr algn="ctr">
+              <a:lnSpc>
+                <a:spcPct val="100000"/>
+              </a:lnSpc>
+              <a:buNone/>
+            </a:pPr>
+            <a:r>
+              <a:rPr lang="en-US" sz="1200" spc="-2" dirty="0">
+                <a:solidFill>
+                  <a:srgbClr val="FFFFFF"/>
+                </a:solidFill>
+                <a:latin typeface="Arial"/>
+                <a:ea typeface="DejaVu Sans"/>
+              </a:rPr>
+              <a:t>FreeRTOS POSIX </a:t>
+            </a:r>
+            <a:endParaRPr lang="en-IN" sz="1200" spc="-2" dirty="0">
+              <a:latin typeface="Arial"/>
+            </a:endParaRPr>
+          </a:p>
+        </p:txBody>
+      </p:sp>
+      <p:sp>
+        <p:nvSpPr>
+          <p:cNvPr id="99" name="CustomShape 8">
+            <a:extLst>
+              <a:ext uri="{FF2B5EF4-FFF2-40B4-BE49-F238E27FC236}">
+                <a16:creationId xmlns:a16="http://schemas.microsoft.com/office/drawing/2014/main" id="{300ACF90-638E-45E4-AA50-B7E85398CF97}"/>
+              </a:ext>
+            </a:extLst>
+          </p:cNvPr>
+          <p:cNvSpPr/>
+          <p:nvPr/>
+        </p:nvSpPr>
+        <p:spPr>
+          <a:xfrm>
+            <a:off x="3814741" y="999062"/>
+            <a:ext cx="1031758" cy="449641"/>
+          </a:xfrm>
+          <a:prstGeom prst="rect">
+            <a:avLst/>
+          </a:prstGeom>
+          <a:solidFill>
+            <a:schemeClr val="bg2"/>
+          </a:solidFill>
+          <a:ln>
+            <a:noFill/>
+          </a:ln>
+          <a:effectLst>
+            <a:outerShdw blurRad="50760" dist="37674" dir="2700000" algn="tl" rotWithShape="0">
+              <a:srgbClr val="000000">
+                <a:alpha val="40000"/>
+              </a:srgbClr>
+            </a:outerShdw>
+          </a:effectLst>
+        </p:spPr>
+        <p:style>
+          <a:lnRef idx="2">
+            <a:schemeClr val="accent1">
+              <a:shade val="50000"/>
+            </a:schemeClr>
+          </a:lnRef>
+          <a:fillRef idx="1">
+            <a:schemeClr val="accent1"/>
+          </a:fillRef>
+          <a:effectRef idx="0">
+            <a:schemeClr val="accent1"/>
+          </a:effectRef>
+          <a:fontRef idx="minor"/>
+        </p:style>
+        <p:txBody>
+          <a:bodyPr lIns="90000" tIns="45000" rIns="90000" bIns="45000" anchor="ctr">
+            <a:noAutofit/>
+          </a:bodyPr>
+          <a:lstStyle/>
+          <a:p>
+            <a:pPr algn="ctr"/>
+            <a:r>
+              <a:rPr lang="en-US" sz="1280" spc="-2" dirty="0">
+                <a:solidFill>
+                  <a:srgbClr val="FFFFFF"/>
+                </a:solidFill>
+                <a:latin typeface="Arial"/>
+              </a:rPr>
+              <a:t>Examples</a:t>
+            </a:r>
+            <a:endParaRPr lang="en-IN" sz="1280" spc="-2" dirty="0">
+              <a:solidFill>
+                <a:srgbClr val="FFFFFF"/>
+              </a:solidFill>
+              <a:latin typeface="Arial"/>
+            </a:endParaRPr>
+          </a:p>
+        </p:txBody>
+      </p:sp>
+      <p:sp>
+        <p:nvSpPr>
+          <p:cNvPr id="105" name="CustomShape 16">
+            <a:extLst>
+              <a:ext uri="{FF2B5EF4-FFF2-40B4-BE49-F238E27FC236}">
+                <a16:creationId xmlns:a16="http://schemas.microsoft.com/office/drawing/2014/main" id="{4F3D06DA-9050-4F82-9322-CFBBA934B192}"/>
+              </a:ext>
+            </a:extLst>
+          </p:cNvPr>
+          <p:cNvSpPr/>
+          <p:nvPr/>
+        </p:nvSpPr>
+        <p:spPr>
+          <a:xfrm>
+            <a:off x="1974457" y="795733"/>
+            <a:ext cx="5738719" cy="1425754"/>
+          </a:xfrm>
+          <a:prstGeom prst="rect">
+            <a:avLst/>
+          </a:prstGeom>
+          <a:noFill/>
+          <a:ln>
+            <a:solidFill>
+              <a:srgbClr val="000000"/>
+            </a:solidFill>
+            <a:round/>
+          </a:ln>
+        </p:spPr>
+        <p:style>
+          <a:lnRef idx="2">
+            <a:schemeClr val="accent1">
+              <a:shade val="50000"/>
+            </a:schemeClr>
+          </a:lnRef>
+          <a:fillRef idx="1">
+            <a:schemeClr val="accent1"/>
+          </a:fillRef>
+          <a:effectRef idx="0">
+            <a:schemeClr val="accent1"/>
+          </a:effectRef>
+          <a:fontRef idx="minor"/>
+        </p:style>
+        <p:txBody>
+          <a:bodyPr lIns="90000" tIns="45000" rIns="90000" bIns="45000" anchor="ctr">
+            <a:noAutofit/>
+          </a:bodyPr>
+          <a:lstStyle/>
+          <a:p>
+            <a:pPr>
+              <a:lnSpc>
+                <a:spcPct val="100000"/>
+              </a:lnSpc>
+              <a:buNone/>
+            </a:pPr>
+            <a:r>
+              <a:rPr lang="en-US" spc="-2" dirty="0">
+                <a:solidFill>
+                  <a:srgbClr val="000000"/>
+                </a:solidFill>
+                <a:latin typeface="Arial"/>
+                <a:ea typeface="DejaVu Sans"/>
+              </a:rPr>
+              <a:t>Examples</a:t>
+            </a:r>
+            <a:endParaRPr lang="en-IN" spc="-2" dirty="0">
+              <a:latin typeface="Arial"/>
+            </a:endParaRPr>
+          </a:p>
+          <a:p>
+            <a:pPr>
+              <a:lnSpc>
+                <a:spcPct val="100000"/>
+              </a:lnSpc>
+              <a:buNone/>
+            </a:pPr>
+            <a:r>
+              <a:rPr lang="en-US" spc="-2" dirty="0">
+                <a:solidFill>
+                  <a:srgbClr val="000000"/>
+                </a:solidFill>
+                <a:latin typeface="Arial"/>
+                <a:ea typeface="DejaVu Sans"/>
+              </a:rPr>
+              <a:t>And Demos</a:t>
+            </a:r>
+            <a:endParaRPr lang="en-IN" spc="-2" dirty="0">
+              <a:latin typeface="Arial"/>
+            </a:endParaRPr>
+          </a:p>
+        </p:txBody>
+      </p:sp>
+      <p:sp>
+        <p:nvSpPr>
+          <p:cNvPr id="106" name="CustomShape 17">
+            <a:extLst>
+              <a:ext uri="{FF2B5EF4-FFF2-40B4-BE49-F238E27FC236}">
+                <a16:creationId xmlns:a16="http://schemas.microsoft.com/office/drawing/2014/main" id="{A732682E-0FAC-4756-92C6-C873E4A1FBF8}"/>
+              </a:ext>
+            </a:extLst>
+          </p:cNvPr>
+          <p:cNvSpPr/>
+          <p:nvPr/>
+        </p:nvSpPr>
+        <p:spPr>
+          <a:xfrm>
+            <a:off x="9383564" y="793214"/>
+            <a:ext cx="1916640" cy="5420132"/>
+          </a:xfrm>
+          <a:prstGeom prst="rect">
+            <a:avLst/>
+          </a:prstGeom>
+          <a:noFill/>
+          <a:ln>
+            <a:solidFill>
+              <a:srgbClr val="000000"/>
+            </a:solidFill>
+            <a:round/>
+          </a:ln>
+        </p:spPr>
+        <p:style>
+          <a:lnRef idx="2">
+            <a:schemeClr val="accent1">
+              <a:shade val="50000"/>
+            </a:schemeClr>
+          </a:lnRef>
+          <a:fillRef idx="1">
+            <a:schemeClr val="accent1"/>
+          </a:fillRef>
+          <a:effectRef idx="0">
+            <a:schemeClr val="accent1"/>
+          </a:effectRef>
+          <a:fontRef idx="minor"/>
+        </p:style>
+        <p:txBody>
+          <a:bodyPr lIns="90000" tIns="45000" rIns="90000" bIns="45000" anchor="t">
+            <a:noAutofit/>
+          </a:bodyPr>
+          <a:lstStyle/>
+          <a:p>
+            <a:pPr algn="ctr">
+              <a:lnSpc>
+                <a:spcPct val="100000"/>
+              </a:lnSpc>
+              <a:buNone/>
+            </a:pPr>
+            <a:r>
+              <a:rPr lang="en-US" spc="-2" dirty="0">
+                <a:solidFill>
+                  <a:srgbClr val="000000"/>
+                </a:solidFill>
+                <a:latin typeface="Arial"/>
+                <a:ea typeface="DejaVu Sans"/>
+              </a:rPr>
+              <a:t>Tools</a:t>
+            </a:r>
+            <a:endParaRPr lang="en-IN" spc="-2" dirty="0">
+              <a:latin typeface="Arial"/>
+            </a:endParaRPr>
+          </a:p>
+        </p:txBody>
+      </p:sp>
+      <p:sp>
+        <p:nvSpPr>
+          <p:cNvPr id="107" name="CustomShape 18">
+            <a:extLst>
+              <a:ext uri="{FF2B5EF4-FFF2-40B4-BE49-F238E27FC236}">
+                <a16:creationId xmlns:a16="http://schemas.microsoft.com/office/drawing/2014/main" id="{18303473-FA0C-4E6A-A716-8B344B585B1F}"/>
+              </a:ext>
+            </a:extLst>
+          </p:cNvPr>
+          <p:cNvSpPr/>
+          <p:nvPr/>
+        </p:nvSpPr>
+        <p:spPr>
+          <a:xfrm>
+            <a:off x="9540704" y="3707834"/>
+            <a:ext cx="1602360" cy="462600"/>
+          </a:xfrm>
+          <a:prstGeom prst="rect">
+            <a:avLst/>
+          </a:prstGeom>
+          <a:solidFill>
+            <a:schemeClr val="bg2"/>
+          </a:solidFill>
+          <a:ln>
+            <a:noFill/>
+          </a:ln>
+          <a:effectLst>
+            <a:outerShdw blurRad="50760" dist="37674" dir="2700000" algn="tl" rotWithShape="0">
+              <a:srgbClr val="000000">
+                <a:alpha val="40000"/>
+              </a:srgbClr>
+            </a:outerShdw>
+          </a:effectLst>
+        </p:spPr>
+        <p:style>
+          <a:lnRef idx="2">
+            <a:schemeClr val="accent1">
+              <a:shade val="50000"/>
+            </a:schemeClr>
+          </a:lnRef>
+          <a:fillRef idx="1">
+            <a:schemeClr val="accent1"/>
+          </a:fillRef>
+          <a:effectRef idx="0">
+            <a:schemeClr val="accent1"/>
+          </a:effectRef>
+          <a:fontRef idx="minor"/>
+        </p:style>
+        <p:txBody>
+          <a:bodyPr lIns="90000" tIns="45000" rIns="90000" bIns="45000" anchor="ctr">
+            <a:noAutofit/>
+          </a:bodyPr>
+          <a:lstStyle/>
+          <a:p>
+            <a:pPr algn="ctr"/>
+            <a:r>
+              <a:rPr lang="en-US" sz="1600" spc="-2" dirty="0">
+                <a:solidFill>
+                  <a:srgbClr val="FFFFFF"/>
+                </a:solidFill>
+                <a:latin typeface="Arial"/>
+              </a:rPr>
+              <a:t>SysConfig</a:t>
+            </a:r>
+            <a:endParaRPr lang="en-IN" sz="1600" spc="-2" dirty="0">
+              <a:solidFill>
+                <a:srgbClr val="FFFFFF"/>
+              </a:solidFill>
+              <a:latin typeface="Arial"/>
+            </a:endParaRPr>
+          </a:p>
+        </p:txBody>
+      </p:sp>
+      <p:sp>
+        <p:nvSpPr>
+          <p:cNvPr id="108" name="CustomShape 19">
+            <a:extLst>
+              <a:ext uri="{FF2B5EF4-FFF2-40B4-BE49-F238E27FC236}">
+                <a16:creationId xmlns:a16="http://schemas.microsoft.com/office/drawing/2014/main" id="{8EDCC865-568A-435E-BF7C-851D917BF793}"/>
+              </a:ext>
+            </a:extLst>
+          </p:cNvPr>
+          <p:cNvSpPr/>
+          <p:nvPr/>
+        </p:nvSpPr>
+        <p:spPr>
+          <a:xfrm>
+            <a:off x="9530264" y="5396411"/>
+            <a:ext cx="1602360" cy="725093"/>
+          </a:xfrm>
+          <a:prstGeom prst="rect">
+            <a:avLst/>
+          </a:prstGeom>
+          <a:solidFill>
+            <a:schemeClr val="bg2"/>
+          </a:solidFill>
+          <a:ln>
+            <a:noFill/>
+          </a:ln>
+          <a:effectLst>
+            <a:outerShdw blurRad="50760" dist="37674" dir="2700000" algn="tl" rotWithShape="0">
+              <a:srgbClr val="000000">
+                <a:alpha val="40000"/>
+              </a:srgbClr>
+            </a:outerShdw>
+          </a:effectLst>
+        </p:spPr>
+        <p:style>
+          <a:lnRef idx="2">
+            <a:schemeClr val="accent1">
+              <a:shade val="50000"/>
+            </a:schemeClr>
+          </a:lnRef>
+          <a:fillRef idx="1">
+            <a:schemeClr val="accent1"/>
+          </a:fillRef>
+          <a:effectRef idx="0">
+            <a:schemeClr val="accent1"/>
+          </a:effectRef>
+          <a:fontRef idx="minor"/>
+        </p:style>
+        <p:txBody>
+          <a:bodyPr lIns="90000" tIns="45000" rIns="90000" bIns="45000" anchor="ctr">
+            <a:noAutofit/>
+          </a:bodyPr>
+          <a:lstStyle/>
+          <a:p>
+            <a:pPr algn="ctr"/>
+            <a:r>
+              <a:rPr lang="en-US" sz="1600" spc="-2" dirty="0">
+                <a:solidFill>
+                  <a:srgbClr val="FFFFFF"/>
+                </a:solidFill>
+                <a:latin typeface="Arial"/>
+              </a:rPr>
+              <a:t>Code Composer Studio (CCS)</a:t>
+            </a:r>
+            <a:endParaRPr lang="en-IN" sz="1600" spc="-2" dirty="0">
+              <a:solidFill>
+                <a:srgbClr val="FFFFFF"/>
+              </a:solidFill>
+              <a:latin typeface="Arial"/>
+            </a:endParaRPr>
+          </a:p>
+        </p:txBody>
+      </p:sp>
+      <p:sp>
+        <p:nvSpPr>
+          <p:cNvPr id="109" name="CustomShape 20">
+            <a:extLst>
+              <a:ext uri="{FF2B5EF4-FFF2-40B4-BE49-F238E27FC236}">
+                <a16:creationId xmlns:a16="http://schemas.microsoft.com/office/drawing/2014/main" id="{A0D9FC60-4F5B-4105-8563-5EFE48BD0569}"/>
+              </a:ext>
+            </a:extLst>
+          </p:cNvPr>
+          <p:cNvSpPr/>
+          <p:nvPr/>
+        </p:nvSpPr>
+        <p:spPr>
+          <a:xfrm>
+            <a:off x="9530264" y="4513854"/>
+            <a:ext cx="1602360" cy="621360"/>
+          </a:xfrm>
+          <a:prstGeom prst="rect">
+            <a:avLst/>
+          </a:prstGeom>
+          <a:solidFill>
+            <a:schemeClr val="bg2"/>
+          </a:solidFill>
+          <a:ln>
+            <a:noFill/>
+          </a:ln>
+          <a:effectLst>
+            <a:outerShdw blurRad="50760" dist="37674" dir="2700000" algn="tl" rotWithShape="0">
+              <a:srgbClr val="000000">
+                <a:alpha val="40000"/>
+              </a:srgbClr>
+            </a:outerShdw>
+          </a:effectLst>
+        </p:spPr>
+        <p:style>
+          <a:lnRef idx="2">
+            <a:schemeClr val="accent1">
+              <a:shade val="50000"/>
+            </a:schemeClr>
+          </a:lnRef>
+          <a:fillRef idx="1">
+            <a:schemeClr val="accent1"/>
+          </a:fillRef>
+          <a:effectRef idx="0">
+            <a:schemeClr val="accent1"/>
+          </a:effectRef>
+          <a:fontRef idx="minor"/>
+        </p:style>
+        <p:txBody>
+          <a:bodyPr lIns="90000" tIns="45000" rIns="90000" bIns="45000" anchor="ctr">
+            <a:noAutofit/>
+          </a:bodyPr>
+          <a:lstStyle/>
+          <a:p>
+            <a:pPr algn="ctr"/>
+            <a:r>
+              <a:rPr lang="en-US" sz="1600" spc="-2" dirty="0">
+                <a:solidFill>
+                  <a:srgbClr val="FFFFFF"/>
+                </a:solidFill>
+                <a:latin typeface="Arial"/>
+              </a:rPr>
+              <a:t>TI CLANG Compiler</a:t>
+            </a:r>
+            <a:endParaRPr lang="en-IN" sz="1600" spc="-2" dirty="0">
+              <a:solidFill>
+                <a:srgbClr val="FFFFFF"/>
+              </a:solidFill>
+              <a:latin typeface="Arial"/>
+            </a:endParaRPr>
+          </a:p>
+        </p:txBody>
+      </p:sp>
+      <p:sp>
+        <p:nvSpPr>
+          <p:cNvPr id="110" name="CustomShape 21">
+            <a:extLst>
+              <a:ext uri="{FF2B5EF4-FFF2-40B4-BE49-F238E27FC236}">
+                <a16:creationId xmlns:a16="http://schemas.microsoft.com/office/drawing/2014/main" id="{09D8FDC2-2E2B-4C96-9E1C-41CEC48BD62A}"/>
+              </a:ext>
+            </a:extLst>
+          </p:cNvPr>
+          <p:cNvSpPr/>
+          <p:nvPr/>
+        </p:nvSpPr>
+        <p:spPr>
+          <a:xfrm>
+            <a:off x="9519497" y="2471818"/>
+            <a:ext cx="1602360" cy="862560"/>
+          </a:xfrm>
+          <a:prstGeom prst="rect">
+            <a:avLst/>
+          </a:prstGeom>
+          <a:solidFill>
+            <a:schemeClr val="bg2"/>
+          </a:solidFill>
+          <a:ln>
+            <a:noFill/>
+          </a:ln>
+          <a:effectLst>
+            <a:outerShdw blurRad="50760" dist="37674" dir="2700000" algn="tl" rotWithShape="0">
+              <a:srgbClr val="000000">
+                <a:alpha val="40000"/>
+              </a:srgbClr>
+            </a:outerShdw>
+          </a:effectLst>
+        </p:spPr>
+        <p:style>
+          <a:lnRef idx="2">
+            <a:schemeClr val="accent1">
+              <a:shade val="50000"/>
+            </a:schemeClr>
+          </a:lnRef>
+          <a:fillRef idx="1">
+            <a:schemeClr val="accent1"/>
+          </a:fillRef>
+          <a:effectRef idx="0">
+            <a:schemeClr val="accent1"/>
+          </a:effectRef>
+          <a:fontRef idx="minor"/>
+        </p:style>
+        <p:txBody>
+          <a:bodyPr lIns="90000" tIns="45000" rIns="90000" bIns="45000" anchor="ctr">
+            <a:noAutofit/>
+          </a:bodyPr>
+          <a:lstStyle/>
+          <a:p>
+            <a:pPr algn="ctr"/>
+            <a:r>
+              <a:rPr lang="en-US" sz="1600" spc="-2" dirty="0">
+                <a:solidFill>
+                  <a:srgbClr val="FFFFFF"/>
+                </a:solidFill>
+                <a:latin typeface="Arial"/>
+              </a:rPr>
+              <a:t>TI Resource Explorer (TIREX)</a:t>
+            </a:r>
+            <a:endParaRPr lang="en-IN" sz="1600" spc="-2" dirty="0">
+              <a:solidFill>
+                <a:srgbClr val="FFFFFF"/>
+              </a:solidFill>
+              <a:latin typeface="Arial"/>
+            </a:endParaRPr>
+          </a:p>
+        </p:txBody>
+      </p:sp>
+      <p:sp>
+        <p:nvSpPr>
+          <p:cNvPr id="111" name="CustomShape 22">
+            <a:extLst>
+              <a:ext uri="{FF2B5EF4-FFF2-40B4-BE49-F238E27FC236}">
+                <a16:creationId xmlns:a16="http://schemas.microsoft.com/office/drawing/2014/main" id="{EB428E7A-3FA5-49EF-BD88-DE4809590EBB}"/>
+              </a:ext>
+            </a:extLst>
+          </p:cNvPr>
+          <p:cNvSpPr/>
+          <p:nvPr/>
+        </p:nvSpPr>
+        <p:spPr>
+          <a:xfrm>
+            <a:off x="1974455" y="6294032"/>
+            <a:ext cx="5758860" cy="536947"/>
+          </a:xfrm>
+          <a:prstGeom prst="rect">
+            <a:avLst/>
+          </a:prstGeom>
+          <a:solidFill>
+            <a:schemeClr val="tx1"/>
+          </a:solidFill>
+          <a:ln>
+            <a:noFill/>
+          </a:ln>
+        </p:spPr>
+        <p:style>
+          <a:lnRef idx="2">
+            <a:schemeClr val="accent1">
+              <a:shade val="50000"/>
+            </a:schemeClr>
+          </a:lnRef>
+          <a:fillRef idx="1">
+            <a:schemeClr val="accent1"/>
+          </a:fillRef>
+          <a:effectRef idx="0">
+            <a:schemeClr val="accent1"/>
+          </a:effectRef>
+          <a:fontRef idx="minor"/>
+        </p:style>
+        <p:txBody>
+          <a:bodyPr lIns="90000" tIns="45000" rIns="90000" bIns="45000" anchor="ctr">
+            <a:noAutofit/>
+          </a:bodyPr>
+          <a:lstStyle/>
+          <a:p>
+            <a:pPr algn="ctr">
+              <a:lnSpc>
+                <a:spcPct val="100000"/>
+              </a:lnSpc>
+              <a:buNone/>
+            </a:pPr>
+            <a:r>
+              <a:rPr lang="en-US" sz="1600" spc="-2" dirty="0">
+                <a:solidFill>
+                  <a:srgbClr val="FFFFFF"/>
+                </a:solidFill>
+                <a:latin typeface="Arial"/>
+                <a:ea typeface="DejaVu Sans"/>
+              </a:rPr>
+              <a:t>ARM R5F, ARM M4F + SOC peripherals + EVM peripherals</a:t>
+            </a:r>
+            <a:endParaRPr lang="en-IN" sz="1600" spc="-2" dirty="0">
+              <a:latin typeface="Arial"/>
+            </a:endParaRPr>
+          </a:p>
+        </p:txBody>
+      </p:sp>
+      <p:sp>
+        <p:nvSpPr>
+          <p:cNvPr id="112" name="CustomShape 23">
+            <a:extLst>
+              <a:ext uri="{FF2B5EF4-FFF2-40B4-BE49-F238E27FC236}">
+                <a16:creationId xmlns:a16="http://schemas.microsoft.com/office/drawing/2014/main" id="{03A1A3BF-D144-4FDC-942A-8AA5E0B37952}"/>
+              </a:ext>
+            </a:extLst>
+          </p:cNvPr>
+          <p:cNvSpPr/>
+          <p:nvPr/>
+        </p:nvSpPr>
+        <p:spPr>
+          <a:xfrm>
+            <a:off x="9383564" y="6306633"/>
+            <a:ext cx="1916640" cy="524347"/>
+          </a:xfrm>
+          <a:prstGeom prst="rect">
+            <a:avLst/>
+          </a:prstGeom>
+          <a:solidFill>
+            <a:schemeClr val="tx1"/>
+          </a:solidFill>
+          <a:ln>
+            <a:noFill/>
+          </a:ln>
+        </p:spPr>
+        <p:style>
+          <a:lnRef idx="2">
+            <a:schemeClr val="accent1">
+              <a:shade val="50000"/>
+            </a:schemeClr>
+          </a:lnRef>
+          <a:fillRef idx="1">
+            <a:schemeClr val="accent1"/>
+          </a:fillRef>
+          <a:effectRef idx="0">
+            <a:schemeClr val="accent1"/>
+          </a:effectRef>
+          <a:fontRef idx="minor"/>
+        </p:style>
+        <p:txBody>
+          <a:bodyPr lIns="90000" tIns="45000" rIns="90000" bIns="45000" anchor="ctr">
+            <a:noAutofit/>
+          </a:bodyPr>
+          <a:lstStyle/>
+          <a:p>
+            <a:pPr algn="ctr">
+              <a:lnSpc>
+                <a:spcPct val="100000"/>
+              </a:lnSpc>
+              <a:buNone/>
+            </a:pPr>
+            <a:r>
+              <a:rPr lang="en-US" sz="1600" spc="-2" dirty="0">
+                <a:solidFill>
+                  <a:srgbClr val="FFFFFF"/>
+                </a:solidFill>
+                <a:latin typeface="Arial"/>
+                <a:ea typeface="DejaVu Sans"/>
+              </a:rPr>
+              <a:t>X86 Host (Windows / Linux)</a:t>
+            </a:r>
+            <a:endParaRPr lang="en-IN" sz="1600" spc="-2" dirty="0">
+              <a:latin typeface="Arial"/>
+            </a:endParaRPr>
+          </a:p>
+        </p:txBody>
+      </p:sp>
+      <p:sp>
+        <p:nvSpPr>
+          <p:cNvPr id="113" name="CustomShape 24">
+            <a:extLst>
+              <a:ext uri="{FF2B5EF4-FFF2-40B4-BE49-F238E27FC236}">
+                <a16:creationId xmlns:a16="http://schemas.microsoft.com/office/drawing/2014/main" id="{F7FC4F91-0E6E-4B6E-BF07-BC51B5C929A5}"/>
+              </a:ext>
+            </a:extLst>
+          </p:cNvPr>
+          <p:cNvSpPr/>
+          <p:nvPr/>
+        </p:nvSpPr>
+        <p:spPr>
+          <a:xfrm>
+            <a:off x="3816124" y="1604082"/>
+            <a:ext cx="1031760" cy="491094"/>
+          </a:xfrm>
+          <a:prstGeom prst="rect">
+            <a:avLst/>
+          </a:prstGeom>
+          <a:solidFill>
+            <a:schemeClr val="bg2"/>
+          </a:solidFill>
+          <a:ln>
+            <a:noFill/>
+          </a:ln>
+          <a:effectLst>
+            <a:outerShdw blurRad="50760" dist="37674" dir="2700000" algn="tl" rotWithShape="0">
+              <a:srgbClr val="000000">
+                <a:alpha val="40000"/>
+              </a:srgbClr>
+            </a:outerShdw>
+          </a:effectLst>
+        </p:spPr>
+        <p:style>
+          <a:lnRef idx="2">
+            <a:schemeClr val="accent1">
+              <a:shade val="50000"/>
+            </a:schemeClr>
+          </a:lnRef>
+          <a:fillRef idx="1">
+            <a:schemeClr val="accent1"/>
+          </a:fillRef>
+          <a:effectRef idx="0">
+            <a:schemeClr val="accent1"/>
+          </a:effectRef>
+          <a:fontRef idx="minor"/>
+        </p:style>
+        <p:txBody>
+          <a:bodyPr lIns="90000" tIns="45000" rIns="90000" bIns="45000" anchor="ctr">
+            <a:noAutofit/>
+          </a:bodyPr>
+          <a:lstStyle/>
+          <a:p>
+            <a:pPr algn="ctr"/>
+            <a:r>
+              <a:rPr lang="en-US" sz="1280" spc="-2" dirty="0">
+                <a:solidFill>
+                  <a:srgbClr val="FFFFFF"/>
+                </a:solidFill>
+                <a:latin typeface="Arial"/>
+              </a:rPr>
+              <a:t>Demos</a:t>
+            </a:r>
+            <a:endParaRPr lang="en-IN" sz="1280" spc="-2" dirty="0">
+              <a:solidFill>
+                <a:srgbClr val="FFFFFF"/>
+              </a:solidFill>
+              <a:latin typeface="Arial"/>
+            </a:endParaRPr>
+          </a:p>
+        </p:txBody>
+      </p:sp>
+      <p:sp>
+        <p:nvSpPr>
+          <p:cNvPr id="114" name="CustomShape 25">
+            <a:extLst>
+              <a:ext uri="{FF2B5EF4-FFF2-40B4-BE49-F238E27FC236}">
+                <a16:creationId xmlns:a16="http://schemas.microsoft.com/office/drawing/2014/main" id="{DCFBB7F5-443D-4495-A25F-BDA3B199691F}"/>
+              </a:ext>
+            </a:extLst>
+          </p:cNvPr>
+          <p:cNvSpPr/>
+          <p:nvPr/>
+        </p:nvSpPr>
+        <p:spPr>
+          <a:xfrm>
+            <a:off x="9519497" y="1226902"/>
+            <a:ext cx="1602360" cy="862560"/>
+          </a:xfrm>
+          <a:prstGeom prst="rect">
+            <a:avLst/>
+          </a:prstGeom>
+          <a:solidFill>
+            <a:schemeClr val="bg2"/>
+          </a:solidFill>
+          <a:ln>
+            <a:noFill/>
+          </a:ln>
+          <a:effectLst>
+            <a:outerShdw blurRad="50760" dist="37674" dir="2700000" algn="tl" rotWithShape="0">
+              <a:srgbClr val="000000">
+                <a:alpha val="40000"/>
+              </a:srgbClr>
+            </a:outerShdw>
+          </a:effectLst>
+        </p:spPr>
+        <p:style>
+          <a:lnRef idx="2">
+            <a:schemeClr val="accent1">
+              <a:shade val="50000"/>
+            </a:schemeClr>
+          </a:lnRef>
+          <a:fillRef idx="1">
+            <a:schemeClr val="accent1"/>
+          </a:fillRef>
+          <a:effectRef idx="0">
+            <a:schemeClr val="accent1"/>
+          </a:effectRef>
+          <a:fontRef idx="minor"/>
+        </p:style>
+        <p:txBody>
+          <a:bodyPr lIns="90000" tIns="45000" rIns="90000" bIns="45000" anchor="ctr">
+            <a:noAutofit/>
+          </a:bodyPr>
+          <a:lstStyle/>
+          <a:p>
+            <a:pPr algn="ctr"/>
+            <a:r>
+              <a:rPr lang="en-US" sz="1600" spc="-2" dirty="0">
+                <a:solidFill>
+                  <a:srgbClr val="FFFFFF"/>
+                </a:solidFill>
+                <a:latin typeface="Arial"/>
+              </a:rPr>
+              <a:t>SDK Tools (Flashing, Boot, …)</a:t>
+            </a:r>
+            <a:endParaRPr lang="en-IN" sz="1600" spc="-2" dirty="0">
+              <a:solidFill>
+                <a:srgbClr val="FFFFFF"/>
+              </a:solidFill>
+              <a:latin typeface="Arial"/>
+            </a:endParaRPr>
+          </a:p>
+        </p:txBody>
+      </p:sp>
+      <p:sp>
+        <p:nvSpPr>
+          <p:cNvPr id="137" name="CustomShape 7">
+            <a:extLst>
+              <a:ext uri="{FF2B5EF4-FFF2-40B4-BE49-F238E27FC236}">
+                <a16:creationId xmlns:a16="http://schemas.microsoft.com/office/drawing/2014/main" id="{63348C38-19BF-49D5-8C54-18BEAF892E69}"/>
+              </a:ext>
+            </a:extLst>
+          </p:cNvPr>
+          <p:cNvSpPr/>
+          <p:nvPr/>
+        </p:nvSpPr>
+        <p:spPr>
+          <a:xfrm>
+            <a:off x="3739478" y="6920016"/>
+            <a:ext cx="1660156" cy="514877"/>
+          </a:xfrm>
+          <a:prstGeom prst="rect">
+            <a:avLst/>
+          </a:prstGeom>
+          <a:solidFill>
+            <a:schemeClr val="bg2"/>
+          </a:solidFill>
+          <a:ln>
+            <a:noFill/>
+          </a:ln>
+          <a:effectLst>
+            <a:outerShdw blurRad="50760" dist="37674" dir="2700000" algn="tl" rotWithShape="0">
+              <a:srgbClr val="000000">
+                <a:alpha val="40000"/>
+              </a:srgbClr>
+            </a:outerShdw>
+          </a:effectLst>
+        </p:spPr>
+        <p:style>
+          <a:lnRef idx="2">
+            <a:schemeClr val="accent1">
+              <a:shade val="50000"/>
+            </a:schemeClr>
+          </a:lnRef>
+          <a:fillRef idx="1">
+            <a:schemeClr val="accent1"/>
+          </a:fillRef>
+          <a:effectRef idx="0">
+            <a:schemeClr val="accent1"/>
+          </a:effectRef>
+          <a:fontRef idx="minor"/>
+        </p:style>
+        <p:txBody>
+          <a:bodyPr lIns="90000" tIns="45000" rIns="90000" bIns="45000" anchor="ctr">
+            <a:noAutofit/>
+          </a:bodyPr>
+          <a:lstStyle/>
+          <a:p>
+            <a:pPr algn="ctr">
+              <a:lnSpc>
+                <a:spcPct val="100000"/>
+              </a:lnSpc>
+              <a:buNone/>
+            </a:pPr>
+            <a:r>
+              <a:rPr lang="en-US" sz="1600" spc="-2" dirty="0">
+                <a:solidFill>
+                  <a:srgbClr val="FFFFFF"/>
+                </a:solidFill>
+                <a:latin typeface="Arial"/>
+                <a:ea typeface="DejaVu Sans"/>
+              </a:rPr>
+              <a:t>MCU+ SDK </a:t>
+            </a:r>
+            <a:endParaRPr lang="en-IN" sz="1600" spc="-2" dirty="0">
+              <a:latin typeface="Arial"/>
+            </a:endParaRPr>
+          </a:p>
+        </p:txBody>
+      </p:sp>
+      <p:sp>
+        <p:nvSpPr>
+          <p:cNvPr id="47" name="CustomShape 17">
+            <a:extLst>
+              <a:ext uri="{FF2B5EF4-FFF2-40B4-BE49-F238E27FC236}">
+                <a16:creationId xmlns:a16="http://schemas.microsoft.com/office/drawing/2014/main" id="{4291FF05-F6CE-4A38-84EE-58927DBC4826}"/>
+              </a:ext>
+            </a:extLst>
+          </p:cNvPr>
+          <p:cNvSpPr/>
+          <p:nvPr/>
+        </p:nvSpPr>
+        <p:spPr>
+          <a:xfrm>
+            <a:off x="7833404" y="793214"/>
+            <a:ext cx="1404368" cy="5420131"/>
+          </a:xfrm>
+          <a:prstGeom prst="rect">
+            <a:avLst/>
+          </a:prstGeom>
+          <a:noFill/>
+          <a:ln>
+            <a:solidFill>
+              <a:srgbClr val="000000"/>
+            </a:solidFill>
+            <a:round/>
+          </a:ln>
+        </p:spPr>
+        <p:style>
+          <a:lnRef idx="2">
+            <a:schemeClr val="accent1">
+              <a:shade val="50000"/>
+            </a:schemeClr>
+          </a:lnRef>
+          <a:fillRef idx="1">
+            <a:schemeClr val="accent1"/>
+          </a:fillRef>
+          <a:effectRef idx="0">
+            <a:schemeClr val="accent1"/>
+          </a:effectRef>
+          <a:fontRef idx="minor"/>
+        </p:style>
+        <p:txBody>
+          <a:bodyPr lIns="90000" tIns="45000" rIns="90000" bIns="45000" anchor="t">
+            <a:noAutofit/>
+          </a:bodyPr>
+          <a:lstStyle/>
+          <a:p>
+            <a:pPr algn="ctr">
+              <a:lnSpc>
+                <a:spcPct val="100000"/>
+              </a:lnSpc>
+              <a:buNone/>
+            </a:pPr>
+            <a:r>
+              <a:rPr lang="en-US" spc="-2" dirty="0">
+                <a:solidFill>
+                  <a:srgbClr val="000000"/>
+                </a:solidFill>
+                <a:latin typeface="Arial"/>
+              </a:rPr>
+              <a:t>Firmware</a:t>
+            </a:r>
+            <a:endParaRPr lang="en-IN" spc="-2" dirty="0">
+              <a:latin typeface="Arial"/>
+            </a:endParaRPr>
+          </a:p>
+        </p:txBody>
+      </p:sp>
+      <p:sp>
+        <p:nvSpPr>
+          <p:cNvPr id="52" name="CustomShape 23">
+            <a:extLst>
+              <a:ext uri="{FF2B5EF4-FFF2-40B4-BE49-F238E27FC236}">
+                <a16:creationId xmlns:a16="http://schemas.microsoft.com/office/drawing/2014/main" id="{7BCD0863-F6ED-4DC4-983E-37943352EE5E}"/>
+              </a:ext>
+            </a:extLst>
+          </p:cNvPr>
+          <p:cNvSpPr/>
+          <p:nvPr/>
+        </p:nvSpPr>
+        <p:spPr>
+          <a:xfrm>
+            <a:off x="7833404" y="6306633"/>
+            <a:ext cx="1404368" cy="524347"/>
+          </a:xfrm>
+          <a:prstGeom prst="rect">
+            <a:avLst/>
+          </a:prstGeom>
+          <a:solidFill>
+            <a:schemeClr val="tx1"/>
+          </a:solidFill>
+          <a:ln>
+            <a:noFill/>
+          </a:ln>
+        </p:spPr>
+        <p:style>
+          <a:lnRef idx="2">
+            <a:schemeClr val="accent1">
+              <a:shade val="50000"/>
+            </a:schemeClr>
+          </a:lnRef>
+          <a:fillRef idx="1">
+            <a:schemeClr val="accent1"/>
+          </a:fillRef>
+          <a:effectRef idx="0">
+            <a:schemeClr val="accent1"/>
+          </a:effectRef>
+          <a:fontRef idx="minor"/>
+        </p:style>
+        <p:txBody>
+          <a:bodyPr lIns="90000" tIns="45000" rIns="90000" bIns="45000" anchor="ctr">
+            <a:noAutofit/>
+          </a:bodyPr>
+          <a:lstStyle/>
+          <a:p>
+            <a:pPr algn="ctr">
+              <a:lnSpc>
+                <a:spcPct val="100000"/>
+              </a:lnSpc>
+              <a:buNone/>
+            </a:pPr>
+            <a:r>
+              <a:rPr lang="en-US" sz="1600" spc="-2" dirty="0">
+                <a:solidFill>
+                  <a:srgbClr val="FFFFFF"/>
+                </a:solidFill>
+                <a:latin typeface="Arial"/>
+                <a:ea typeface="DejaVu Sans"/>
+              </a:rPr>
+              <a:t>ICSS</a:t>
+            </a:r>
+            <a:endParaRPr lang="en-IN" sz="1600" spc="-2" dirty="0">
+              <a:latin typeface="Arial"/>
+            </a:endParaRPr>
+          </a:p>
+        </p:txBody>
+      </p:sp>
+      <p:sp>
+        <p:nvSpPr>
+          <p:cNvPr id="53" name="CustomShape 15">
+            <a:extLst>
+              <a:ext uri="{FF2B5EF4-FFF2-40B4-BE49-F238E27FC236}">
+                <a16:creationId xmlns:a16="http://schemas.microsoft.com/office/drawing/2014/main" id="{34B5E01D-4EAE-45C9-B426-238451E602E8}"/>
+              </a:ext>
+            </a:extLst>
+          </p:cNvPr>
+          <p:cNvSpPr/>
+          <p:nvPr/>
+        </p:nvSpPr>
+        <p:spPr>
+          <a:xfrm>
+            <a:off x="7527797" y="6920016"/>
+            <a:ext cx="1782416" cy="509528"/>
+          </a:xfrm>
+          <a:prstGeom prst="rect">
+            <a:avLst/>
+          </a:prstGeom>
+          <a:solidFill>
+            <a:srgbClr val="00B0F0"/>
+          </a:solidFill>
+          <a:ln>
+            <a:noFill/>
+          </a:ln>
+          <a:effectLst>
+            <a:outerShdw blurRad="50760" dist="37674" dir="2700000" algn="tl" rotWithShape="0">
+              <a:srgbClr val="000000">
+                <a:alpha val="40000"/>
+              </a:srgbClr>
+            </a:outerShdw>
+          </a:effectLst>
+        </p:spPr>
+        <p:style>
+          <a:lnRef idx="2">
+            <a:schemeClr val="accent1">
+              <a:shade val="50000"/>
+            </a:schemeClr>
+          </a:lnRef>
+          <a:fillRef idx="1">
+            <a:schemeClr val="accent1"/>
+          </a:fillRef>
+          <a:effectRef idx="0">
+            <a:schemeClr val="accent1"/>
+          </a:effectRef>
+          <a:fontRef idx="minor"/>
+        </p:style>
+        <p:txBody>
+          <a:bodyPr lIns="90000" tIns="45000" rIns="90000" bIns="45000" anchor="ctr">
+            <a:noAutofit/>
+          </a:bodyPr>
+          <a:lstStyle/>
+          <a:p>
+            <a:pPr algn="ctr"/>
+            <a:r>
+              <a:rPr lang="en-IN" sz="1280" spc="-2" dirty="0">
+                <a:solidFill>
+                  <a:srgbClr val="000000"/>
+                </a:solidFill>
+                <a:latin typeface="Arial"/>
+              </a:rPr>
+              <a:t>Motor Control SDK</a:t>
+            </a:r>
+          </a:p>
+        </p:txBody>
+      </p:sp>
+      <p:sp>
+        <p:nvSpPr>
+          <p:cNvPr id="71" name="CustomShape 14">
+            <a:extLst>
+              <a:ext uri="{FF2B5EF4-FFF2-40B4-BE49-F238E27FC236}">
+                <a16:creationId xmlns:a16="http://schemas.microsoft.com/office/drawing/2014/main" id="{EBA946F5-D295-4F2E-8D3D-32CB272F98DA}"/>
+              </a:ext>
+            </a:extLst>
+          </p:cNvPr>
+          <p:cNvSpPr/>
+          <p:nvPr/>
+        </p:nvSpPr>
+        <p:spPr>
+          <a:xfrm>
+            <a:off x="1974457" y="3529383"/>
+            <a:ext cx="5758860" cy="1377720"/>
+          </a:xfrm>
+          <a:prstGeom prst="rect">
+            <a:avLst/>
+          </a:prstGeom>
+          <a:noFill/>
+          <a:ln>
+            <a:solidFill>
+              <a:srgbClr val="000000"/>
+            </a:solidFill>
+            <a:round/>
+          </a:ln>
+        </p:spPr>
+        <p:style>
+          <a:lnRef idx="2">
+            <a:schemeClr val="accent1">
+              <a:shade val="50000"/>
+            </a:schemeClr>
+          </a:lnRef>
+          <a:fillRef idx="1">
+            <a:schemeClr val="accent1"/>
+          </a:fillRef>
+          <a:effectRef idx="0">
+            <a:schemeClr val="accent1"/>
+          </a:effectRef>
+          <a:fontRef idx="minor"/>
+        </p:style>
+        <p:txBody>
+          <a:bodyPr lIns="90000" tIns="45000" rIns="90000" bIns="45000" anchor="ctr">
+            <a:noAutofit/>
+          </a:bodyPr>
+          <a:lstStyle/>
+          <a:p>
+            <a:pPr>
+              <a:lnSpc>
+                <a:spcPct val="100000"/>
+              </a:lnSpc>
+              <a:buNone/>
+            </a:pPr>
+            <a:r>
+              <a:rPr lang="en-US" spc="-2" dirty="0">
+                <a:solidFill>
+                  <a:srgbClr val="000000"/>
+                </a:solidFill>
+                <a:latin typeface="Arial"/>
+                <a:ea typeface="DejaVu Sans"/>
+              </a:rPr>
+              <a:t>Drivers and</a:t>
+            </a:r>
+            <a:endParaRPr lang="en-IN" spc="-2" dirty="0">
+              <a:latin typeface="Arial"/>
+            </a:endParaRPr>
+          </a:p>
+          <a:p>
+            <a:pPr>
+              <a:lnSpc>
+                <a:spcPct val="100000"/>
+              </a:lnSpc>
+              <a:buNone/>
+            </a:pPr>
+            <a:r>
+              <a:rPr lang="en-US" spc="-2" dirty="0">
+                <a:solidFill>
+                  <a:srgbClr val="000000"/>
+                </a:solidFill>
+                <a:latin typeface="Arial"/>
+                <a:ea typeface="DejaVu Sans"/>
+              </a:rPr>
+              <a:t>HAL</a:t>
+            </a:r>
+            <a:endParaRPr lang="en-IN" spc="-2" dirty="0">
+              <a:latin typeface="Arial"/>
+            </a:endParaRPr>
+          </a:p>
+        </p:txBody>
+      </p:sp>
+      <p:sp>
+        <p:nvSpPr>
+          <p:cNvPr id="83" name="CustomShape 15">
+            <a:extLst>
+              <a:ext uri="{FF2B5EF4-FFF2-40B4-BE49-F238E27FC236}">
+                <a16:creationId xmlns:a16="http://schemas.microsoft.com/office/drawing/2014/main" id="{2B3E019C-8EF4-444D-8BD9-35787B4CE89D}"/>
+              </a:ext>
+            </a:extLst>
+          </p:cNvPr>
+          <p:cNvSpPr/>
+          <p:nvPr/>
+        </p:nvSpPr>
+        <p:spPr>
+          <a:xfrm>
+            <a:off x="6435589" y="4291694"/>
+            <a:ext cx="1094959" cy="497782"/>
+          </a:xfrm>
+          <a:prstGeom prst="rect">
+            <a:avLst/>
+          </a:prstGeom>
+          <a:solidFill>
+            <a:srgbClr val="00B0F0"/>
+          </a:solidFill>
+          <a:ln>
+            <a:noFill/>
+          </a:ln>
+          <a:effectLst>
+            <a:outerShdw blurRad="50760" dist="37674" dir="2700000" algn="tl" rotWithShape="0">
+              <a:srgbClr val="000000">
+                <a:alpha val="40000"/>
+              </a:srgbClr>
+            </a:outerShdw>
+          </a:effectLst>
+        </p:spPr>
+        <p:style>
+          <a:lnRef idx="2">
+            <a:schemeClr val="accent1">
+              <a:shade val="50000"/>
+            </a:schemeClr>
+          </a:lnRef>
+          <a:fillRef idx="1">
+            <a:schemeClr val="accent1"/>
+          </a:fillRef>
+          <a:effectRef idx="0">
+            <a:schemeClr val="accent1"/>
+          </a:effectRef>
+          <a:fontRef idx="minor"/>
+        </p:style>
+        <p:txBody>
+          <a:bodyPr lIns="90000" tIns="45000" rIns="90000" bIns="45000" anchor="ctr">
+            <a:noAutofit/>
+          </a:bodyPr>
+          <a:lstStyle/>
+          <a:p>
+            <a:pPr algn="ctr"/>
+            <a:r>
+              <a:rPr lang="en-US" sz="1280" spc="-2" dirty="0">
+                <a:solidFill>
+                  <a:srgbClr val="000000"/>
+                </a:solidFill>
+              </a:rPr>
+              <a:t>Tamagawa</a:t>
+            </a:r>
+            <a:endParaRPr lang="en-IN" sz="1280" spc="-2" dirty="0">
+              <a:solidFill>
+                <a:srgbClr val="000000"/>
+              </a:solidFill>
+              <a:latin typeface="Arial"/>
+            </a:endParaRPr>
+          </a:p>
+        </p:txBody>
+      </p:sp>
+      <p:sp>
+        <p:nvSpPr>
+          <p:cNvPr id="42" name="CustomShape 15">
+            <a:extLst>
+              <a:ext uri="{FF2B5EF4-FFF2-40B4-BE49-F238E27FC236}">
+                <a16:creationId xmlns:a16="http://schemas.microsoft.com/office/drawing/2014/main" id="{301D606C-56BB-4F04-94B2-6CA392EC85A4}"/>
+              </a:ext>
+            </a:extLst>
+          </p:cNvPr>
+          <p:cNvSpPr/>
+          <p:nvPr/>
+        </p:nvSpPr>
+        <p:spPr>
+          <a:xfrm>
+            <a:off x="5524003" y="6922690"/>
+            <a:ext cx="1782415" cy="509528"/>
+          </a:xfrm>
+          <a:prstGeom prst="rect">
+            <a:avLst/>
+          </a:prstGeom>
+          <a:solidFill>
+            <a:srgbClr val="92D050"/>
+          </a:solidFill>
+          <a:ln>
+            <a:noFill/>
+          </a:ln>
+          <a:effectLst>
+            <a:outerShdw blurRad="50760" dist="37674" dir="2700000" algn="tl" rotWithShape="0">
+              <a:srgbClr val="000000">
+                <a:alpha val="40000"/>
+              </a:srgbClr>
+            </a:outerShdw>
+          </a:effectLst>
+        </p:spPr>
+        <p:style>
+          <a:lnRef idx="2">
+            <a:schemeClr val="accent1">
+              <a:shade val="50000"/>
+            </a:schemeClr>
+          </a:lnRef>
+          <a:fillRef idx="1">
+            <a:schemeClr val="accent1"/>
+          </a:fillRef>
+          <a:effectRef idx="0">
+            <a:schemeClr val="accent1"/>
+          </a:effectRef>
+          <a:fontRef idx="minor"/>
+        </p:style>
+        <p:txBody>
+          <a:bodyPr lIns="56250" tIns="28125" rIns="56250" bIns="28125" anchor="ctr">
+            <a:noAutofit/>
+          </a:bodyPr>
+          <a:lstStyle/>
+          <a:p>
+            <a:pPr algn="ctr"/>
+            <a:r>
+              <a:rPr lang="en-IN" sz="1100" spc="-1" dirty="0">
+                <a:solidFill>
+                  <a:srgbClr val="000000"/>
+                </a:solidFill>
+                <a:latin typeface="Arial"/>
+              </a:rPr>
+              <a:t>Industrial Communications SDK</a:t>
+            </a:r>
           </a:p>
         </p:txBody>
       </p:sp>
@@ -9891,7 +12534,7 @@
                 </a:solidFill>
                 <a:latin typeface="Arial"/>
               </a:rPr>
-              <a:t>Tamagawa</a:t>
+              <a:t>EnDat</a:t>
             </a:r>
           </a:p>
         </p:txBody>
@@ -10469,7 +13112,7 @@
                   <a:srgbClr val="000000"/>
                 </a:solidFill>
               </a:rPr>
-              <a:t>RTLibs</a:t>
+              <a:t>Tamagawa</a:t>
             </a:r>
             <a:endParaRPr lang="en-IN" sz="1280" spc="-2" dirty="0">
               <a:solidFill>
@@ -10542,100 +13185,249 @@
                 </a:solidFill>
                 <a:latin typeface="Arial"/>
               </a:rPr>
-              <a:t>Tamagawa</a:t>
+              <a:t>EnDat</a:t>
             </a:r>
           </a:p>
         </p:txBody>
       </p:sp>
-      <p:sp>
-        <p:nvSpPr>
-          <p:cNvPr id="38" name="CustomShape 8">
+      <p:grpSp>
+        <p:nvGrpSpPr>
+          <p:cNvPr id="39" name="Group 38">
             <a:extLst>
               <a:ext uri="{FF2B5EF4-FFF2-40B4-BE49-F238E27FC236}">
-                <a16:creationId xmlns:a16="http://schemas.microsoft.com/office/drawing/2014/main" id="{5211EEA9-63DF-4DAF-B441-2B51CD21E224}"/>
+                <a16:creationId xmlns:a16="http://schemas.microsoft.com/office/drawing/2014/main" id="{6BD1015E-3835-446B-B2DC-ED9330F617FB}"/>
               </a:ext>
             </a:extLst>
           </p:cNvPr>
-          <p:cNvSpPr/>
+          <p:cNvGrpSpPr/>
           <p:nvPr/>
-        </p:nvSpPr>
-        <p:spPr>
+        </p:nvGrpSpPr>
+        <p:grpSpPr>
           <a:xfrm>
-            <a:off x="5025671" y="1598368"/>
-            <a:ext cx="1186534" cy="491094"/>
+            <a:off x="7976203" y="2756717"/>
+            <a:ext cx="1118769" cy="1812015"/>
+            <a:chOff x="7974028" y="1413194"/>
+            <a:chExt cx="1118769" cy="1812015"/>
           </a:xfrm>
-          <a:prstGeom prst="rect">
-            <a:avLst/>
-          </a:prstGeom>
-          <a:solidFill>
-            <a:srgbClr val="00B0F0"/>
-          </a:solidFill>
-          <a:ln>
-            <a:noFill/>
-          </a:ln>
-          <a:effectLst>
-            <a:outerShdw blurRad="50760" dist="37674" dir="2700000" algn="tl" rotWithShape="0">
-              <a:srgbClr val="000000">
-                <a:alpha val="40000"/>
-              </a:srgbClr>
-            </a:outerShdw>
-          </a:effectLst>
-        </p:spPr>
-        <p:style>
-          <a:lnRef idx="2">
-            <a:schemeClr val="accent1">
-              <a:shade val="50000"/>
-            </a:schemeClr>
-          </a:lnRef>
-          <a:fillRef idx="1">
-            <a:schemeClr val="accent1"/>
-          </a:fillRef>
-          <a:effectRef idx="0">
-            <a:schemeClr val="accent1"/>
-          </a:effectRef>
-          <a:fontRef idx="minor"/>
-        </p:style>
-        <p:txBody>
-          <a:bodyPr wrap="none" lIns="90000" tIns="45000" rIns="90000" bIns="45000" anchor="ctr">
-            <a:noAutofit/>
-          </a:bodyPr>
-          <a:lstStyle/>
-          <a:p>
-            <a:pPr algn="ctr"/>
-            <a:r>
-              <a:rPr lang="en-US" sz="1100" dirty="0">
-                <a:latin typeface="Calibri" panose="020F0502020204030204" pitchFamily="34" charset="0"/>
-                <a:cs typeface="Calibri" panose="020F0502020204030204" pitchFamily="34" charset="0"/>
-              </a:rPr>
-              <a:t>Universal Motor </a:t>
-            </a:r>
-          </a:p>
-          <a:p>
-            <a:pPr algn="ctr"/>
-            <a:r>
-              <a:rPr lang="en-US" sz="1100" dirty="0">
-                <a:latin typeface="Calibri" panose="020F0502020204030204" pitchFamily="34" charset="0"/>
-                <a:cs typeface="Calibri" panose="020F0502020204030204" pitchFamily="34" charset="0"/>
-              </a:rPr>
-              <a:t>Control</a:t>
-            </a:r>
-          </a:p>
-          <a:p>
-            <a:pPr algn="ctr"/>
-            <a:r>
-              <a:rPr lang="en-US" sz="1100" dirty="0">
-                <a:latin typeface="Calibri" panose="020F0502020204030204" pitchFamily="34" charset="0"/>
-                <a:cs typeface="Calibri" panose="020F0502020204030204" pitchFamily="34" charset="0"/>
-              </a:rPr>
-              <a:t>Reference Design</a:t>
-            </a:r>
-          </a:p>
-        </p:txBody>
-      </p:sp>
+        </p:grpSpPr>
+        <p:sp>
+          <p:nvSpPr>
+            <p:cNvPr id="40" name="CustomShape 8">
+              <a:extLst>
+                <a:ext uri="{FF2B5EF4-FFF2-40B4-BE49-F238E27FC236}">
+                  <a16:creationId xmlns:a16="http://schemas.microsoft.com/office/drawing/2014/main" id="{01121847-31DF-46AA-B838-EAFA788320FD}"/>
+                </a:ext>
+              </a:extLst>
+            </p:cNvPr>
+            <p:cNvSpPr/>
+            <p:nvPr/>
+          </p:nvSpPr>
+          <p:spPr>
+            <a:xfrm>
+              <a:off x="7974028" y="2854862"/>
+              <a:ext cx="1114418" cy="370347"/>
+            </a:xfrm>
+            <a:prstGeom prst="rect">
+              <a:avLst/>
+            </a:prstGeom>
+            <a:solidFill>
+              <a:srgbClr val="92D050"/>
+            </a:solidFill>
+            <a:ln>
+              <a:noFill/>
+            </a:ln>
+            <a:effectLst>
+              <a:outerShdw blurRad="50760" dist="37674" dir="2700000" algn="tl" rotWithShape="0">
+                <a:srgbClr val="000000">
+                  <a:alpha val="40000"/>
+                </a:srgbClr>
+              </a:outerShdw>
+            </a:effectLst>
+          </p:spPr>
+          <p:style>
+            <a:lnRef idx="2">
+              <a:schemeClr val="accent1">
+                <a:shade val="50000"/>
+              </a:schemeClr>
+            </a:lnRef>
+            <a:fillRef idx="1">
+              <a:schemeClr val="accent1"/>
+            </a:fillRef>
+            <a:effectRef idx="0">
+              <a:schemeClr val="accent1"/>
+            </a:effectRef>
+            <a:fontRef idx="minor"/>
+          </p:style>
+          <p:txBody>
+            <a:bodyPr lIns="56250" tIns="28125" rIns="56250" bIns="28125" anchor="ctr">
+              <a:noAutofit/>
+            </a:bodyPr>
+            <a:lstStyle/>
+            <a:p>
+              <a:pPr algn="ctr"/>
+              <a:r>
+                <a:rPr lang="en-US" sz="1280" spc="-1" dirty="0">
+                  <a:solidFill>
+                    <a:srgbClr val="000000"/>
+                  </a:solidFill>
+                  <a:latin typeface="Arial"/>
+                </a:rPr>
+                <a:t>EtherCAT</a:t>
+              </a:r>
+              <a:endParaRPr lang="en-IN" sz="1280" spc="-1" dirty="0">
+                <a:solidFill>
+                  <a:srgbClr val="000000"/>
+                </a:solidFill>
+                <a:latin typeface="Arial"/>
+              </a:endParaRPr>
+            </a:p>
+          </p:txBody>
+        </p:sp>
+        <p:sp>
+          <p:nvSpPr>
+            <p:cNvPr id="41" name="CustomShape 8">
+              <a:extLst>
+                <a:ext uri="{FF2B5EF4-FFF2-40B4-BE49-F238E27FC236}">
+                  <a16:creationId xmlns:a16="http://schemas.microsoft.com/office/drawing/2014/main" id="{B2E5371C-069D-4B40-AC59-96EF0DAFDAC4}"/>
+                </a:ext>
+              </a:extLst>
+            </p:cNvPr>
+            <p:cNvSpPr/>
+            <p:nvPr/>
+          </p:nvSpPr>
+          <p:spPr>
+            <a:xfrm>
+              <a:off x="7978379" y="1413194"/>
+              <a:ext cx="1114418" cy="370347"/>
+            </a:xfrm>
+            <a:prstGeom prst="rect">
+              <a:avLst/>
+            </a:prstGeom>
+            <a:solidFill>
+              <a:srgbClr val="00B0F0"/>
+            </a:solidFill>
+            <a:ln>
+              <a:noFill/>
+            </a:ln>
+            <a:effectLst>
+              <a:outerShdw blurRad="50760" dist="37674" dir="2700000" algn="tl" rotWithShape="0">
+                <a:srgbClr val="000000">
+                  <a:alpha val="40000"/>
+                </a:srgbClr>
+              </a:outerShdw>
+            </a:effectLst>
+          </p:spPr>
+          <p:style>
+            <a:lnRef idx="2">
+              <a:schemeClr val="accent1">
+                <a:shade val="50000"/>
+              </a:schemeClr>
+            </a:lnRef>
+            <a:fillRef idx="1">
+              <a:schemeClr val="accent1"/>
+            </a:fillRef>
+            <a:effectRef idx="0">
+              <a:schemeClr val="accent1"/>
+            </a:effectRef>
+            <a:fontRef idx="minor"/>
+          </p:style>
+          <p:txBody>
+            <a:bodyPr lIns="90000" tIns="45000" rIns="90000" bIns="45000" anchor="ctr">
+              <a:noAutofit/>
+            </a:bodyPr>
+            <a:lstStyle/>
+            <a:p>
+              <a:pPr algn="ctr"/>
+              <a:r>
+                <a:rPr lang="en-IN" sz="1280" spc="-2" dirty="0">
+                  <a:solidFill>
+                    <a:srgbClr val="000000"/>
+                  </a:solidFill>
+                  <a:latin typeface="Arial"/>
+                </a:rPr>
+                <a:t>EnDat</a:t>
+              </a:r>
+            </a:p>
+          </p:txBody>
+        </p:sp>
+        <p:sp>
+          <p:nvSpPr>
+            <p:cNvPr id="43" name="CustomShape 8">
+              <a:extLst>
+                <a:ext uri="{FF2B5EF4-FFF2-40B4-BE49-F238E27FC236}">
+                  <a16:creationId xmlns:a16="http://schemas.microsoft.com/office/drawing/2014/main" id="{21E969EE-BA3E-4C5C-9730-05841FA4B7E2}"/>
+                </a:ext>
+              </a:extLst>
+            </p:cNvPr>
+            <p:cNvSpPr/>
+            <p:nvPr/>
+          </p:nvSpPr>
+          <p:spPr>
+            <a:xfrm>
+              <a:off x="7974028" y="2148191"/>
+              <a:ext cx="1114418" cy="370347"/>
+            </a:xfrm>
+            <a:prstGeom prst="rect">
+              <a:avLst/>
+            </a:prstGeom>
+            <a:solidFill>
+              <a:srgbClr val="00B0F0"/>
+            </a:solidFill>
+            <a:ln>
+              <a:noFill/>
+            </a:ln>
+            <a:effectLst>
+              <a:outerShdw blurRad="50760" dist="37674" dir="2700000" algn="tl" rotWithShape="0">
+                <a:srgbClr val="000000">
+                  <a:alpha val="40000"/>
+                </a:srgbClr>
+              </a:outerShdw>
+            </a:effectLst>
+          </p:spPr>
+          <p:style>
+            <a:lnRef idx="2">
+              <a:schemeClr val="accent1">
+                <a:shade val="50000"/>
+              </a:schemeClr>
+            </a:lnRef>
+            <a:fillRef idx="1">
+              <a:schemeClr val="accent1"/>
+            </a:fillRef>
+            <a:effectRef idx="0">
+              <a:schemeClr val="accent1"/>
+            </a:effectRef>
+            <a:fontRef idx="minor"/>
+          </p:style>
+          <p:txBody>
+            <a:bodyPr lIns="90000" tIns="45000" rIns="90000" bIns="45000" anchor="ctr">
+              <a:noAutofit/>
+            </a:bodyPr>
+            <a:lstStyle/>
+            <a:p>
+              <a:pPr algn="ctr"/>
+              <a:r>
+                <a:rPr lang="en-US" sz="1280" spc="-2" dirty="0">
+                  <a:solidFill>
+                    <a:srgbClr val="000000"/>
+                  </a:solidFill>
+                  <a:latin typeface="Arial"/>
+                </a:rPr>
+                <a:t>Tamagawa</a:t>
+              </a:r>
+              <a:endParaRPr lang="en-IN" sz="1280" spc="-2" dirty="0">
+                <a:solidFill>
+                  <a:srgbClr val="000000"/>
+                </a:solidFill>
+                <a:latin typeface="Arial"/>
+              </a:endParaRPr>
+            </a:p>
+          </p:txBody>
+        </p:sp>
+      </p:grpSp>
     </p:spTree>
     <p:extLst>
       <p:ext uri="{BB962C8B-B14F-4D97-AF65-F5344CB8AC3E}">
-        <p14:creationId xmlns:p14="http://schemas.microsoft.com/office/powerpoint/2010/main" val="3200722840"/>
+        <p14:creationId xmlns:p14="http://schemas.microsoft.com/office/powerpoint/2010/main" val="337316527"/>
       </p:ext>
     </p:extLst>
   </p:cSld>
@@ -10645,7 +13437,7 @@
 </p:sld>
 </file>
 
-<file path=ppt/slides/slide3.xml><?xml version="1.0" encoding="utf-8"?>
+<file path=ppt/slides/slide4.xml><?xml version="1.0" encoding="utf-8"?>
 <p:sld xmlns:a="http://schemas.openxmlformats.org/drawingml/2006/main" xmlns:r="http://schemas.openxmlformats.org/officeDocument/2006/relationships" xmlns:p="http://schemas.openxmlformats.org/presentationml/2006/main">
   <p:cSld>
     <p:spTree>
@@ -15204,7 +17996,7 @@
 </p:sld>
 </file>
 
-<file path=ppt/slides/slide4.xml><?xml version="1.0" encoding="utf-8"?>
+<file path=ppt/slides/slide5.xml><?xml version="1.0" encoding="utf-8"?>
 <p:sld xmlns:a="http://schemas.openxmlformats.org/drawingml/2006/main" xmlns:r="http://schemas.openxmlformats.org/officeDocument/2006/relationships" xmlns:p="http://schemas.openxmlformats.org/presentationml/2006/main">
   <p:cSld>
     <p:spTree>

</xml_diff>

<commit_message>
am261x: docs: Update release notes, main page, license and manifest
- Update the name of launchpad and evm boards for all pages

Fixes: PINDSW-8355

Signed-off-by: Dhaval Khandla <dhavaljk@ti.com>
</commit_message>
<xml_diff>
--- a/docs_src/docs/api_guide/images/images.pptx
+++ b/docs_src/docs/api_guide/images/images.pptx
@@ -10718,8 +10718,8 @@
         </p:nvSpPr>
         <p:spPr>
           <a:xfrm>
-            <a:off x="1984105" y="5123174"/>
-            <a:ext cx="5749210" cy="1005164"/>
+            <a:off x="524105" y="5123173"/>
+            <a:ext cx="7209210" cy="1090171"/>
           </a:xfrm>
           <a:prstGeom prst="rect">
             <a:avLst/>
@@ -10788,8 +10788,8 @@
         </p:nvSpPr>
         <p:spPr>
           <a:xfrm>
-            <a:off x="5129692" y="5199495"/>
-            <a:ext cx="2399399" cy="379800"/>
+            <a:off x="4191764" y="5241908"/>
+            <a:ext cx="3354663" cy="379800"/>
           </a:xfrm>
           <a:prstGeom prst="rect">
             <a:avLst/>
@@ -10864,8 +10864,8 @@
         </p:nvSpPr>
         <p:spPr>
           <a:xfrm>
-            <a:off x="6506435" y="5655616"/>
-            <a:ext cx="1002278" cy="379800"/>
+            <a:off x="5956637" y="5724763"/>
+            <a:ext cx="1589790" cy="379800"/>
           </a:xfrm>
           <a:prstGeom prst="rect">
             <a:avLst/>
@@ -10940,8 +10940,8 @@
         </p:nvSpPr>
         <p:spPr>
           <a:xfrm>
-            <a:off x="5129692" y="5665489"/>
-            <a:ext cx="1266164" cy="379800"/>
+            <a:off x="4197595" y="5729238"/>
+            <a:ext cx="1560810" cy="379800"/>
           </a:xfrm>
           <a:prstGeom prst="rect">
             <a:avLst/>
@@ -11016,8 +11016,8 @@
         </p:nvSpPr>
         <p:spPr>
           <a:xfrm>
-            <a:off x="3841538" y="5208289"/>
-            <a:ext cx="1002278" cy="837000"/>
+            <a:off x="1824621" y="5246989"/>
+            <a:ext cx="2018174" cy="837000"/>
           </a:xfrm>
           <a:prstGeom prst="rect">
             <a:avLst/>
@@ -11080,79 +11080,6 @@
       </p:sp>
       <p:sp>
         <p:nvSpPr>
-          <p:cNvPr id="99" name="CustomShape 8">
-            <a:extLst>
-              <a:ext uri="{FF2B5EF4-FFF2-40B4-BE49-F238E27FC236}">
-                <a16:creationId xmlns:a16="http://schemas.microsoft.com/office/drawing/2014/main" id="{300ACF90-638E-45E4-AA50-B7E85398CF97}"/>
-              </a:ext>
-            </a:extLst>
-          </p:cNvPr>
-          <p:cNvSpPr/>
-          <p:nvPr/>
-        </p:nvSpPr>
-        <p:spPr>
-          <a:xfrm>
-            <a:off x="3814741" y="999062"/>
-            <a:ext cx="1031758" cy="449641"/>
-          </a:xfrm>
-          <a:prstGeom prst="rect">
-            <a:avLst/>
-          </a:prstGeom>
-          <a:solidFill>
-            <a:schemeClr val="bg2"/>
-          </a:solidFill>
-          <a:ln>
-            <a:noFill/>
-          </a:ln>
-          <a:effectLst>
-            <a:outerShdw blurRad="50760" dist="37674" dir="2700000" algn="tl" rotWithShape="0">
-              <a:srgbClr val="000000">
-                <a:alpha val="40000"/>
-              </a:srgbClr>
-            </a:outerShdw>
-          </a:effectLst>
-        </p:spPr>
-        <p:style>
-          <a:lnRef idx="2">
-            <a:schemeClr val="accent1">
-              <a:shade val="50000"/>
-            </a:schemeClr>
-          </a:lnRef>
-          <a:fillRef idx="1">
-            <a:schemeClr val="accent1"/>
-          </a:fillRef>
-          <a:effectRef idx="0">
-            <a:schemeClr val="accent1"/>
-          </a:effectRef>
-          <a:fontRef idx="minor"/>
-        </p:style>
-        <p:txBody>
-          <a:bodyPr lIns="90000" tIns="45000" rIns="90000" bIns="45000" anchor="ctr">
-            <a:noAutofit/>
-          </a:bodyPr>
-          <a:lstStyle/>
-          <a:p>
-            <a:pPr algn="ctr"/>
-            <a:r>
-              <a:rPr lang="en-US" sz="1280" spc="-2" dirty="0">
-                <a:solidFill>
-                  <a:srgbClr val="FFFFFF"/>
-                </a:solidFill>
-                <a:latin typeface="Arial"/>
-              </a:rPr>
-              <a:t>Examples</a:t>
-            </a:r>
-            <a:endParaRPr lang="en-IN" sz="1280" spc="-2" dirty="0">
-              <a:solidFill>
-                <a:srgbClr val="FFFFFF"/>
-              </a:solidFill>
-              <a:latin typeface="Arial"/>
-            </a:endParaRPr>
-          </a:p>
-        </p:txBody>
-      </p:sp>
-      <p:sp>
-        <p:nvSpPr>
           <p:cNvPr id="105" name="CustomShape 16">
             <a:extLst>
               <a:ext uri="{FF2B5EF4-FFF2-40B4-BE49-F238E27FC236}">
@@ -11165,8 +11092,8 @@
         </p:nvSpPr>
         <p:spPr>
           <a:xfrm>
-            <a:off x="1974457" y="795733"/>
-            <a:ext cx="5738719" cy="1425754"/>
+            <a:off x="524107" y="795733"/>
+            <a:ext cx="7189070" cy="1425754"/>
           </a:xfrm>
           <a:prstGeom prst="rect">
             <a:avLst/>
@@ -11618,8 +11545,8 @@
         </p:nvSpPr>
         <p:spPr>
           <a:xfrm>
-            <a:off x="1974455" y="6294032"/>
-            <a:ext cx="5758860" cy="536947"/>
+            <a:off x="524105" y="6294032"/>
+            <a:ext cx="7209210" cy="536947"/>
           </a:xfrm>
           <a:prstGeom prst="rect">
             <a:avLst/>
@@ -11737,79 +11664,6 @@
               <a:t>X86 Host (Windows / Linux)</a:t>
             </a:r>
             <a:endParaRPr lang="en-IN" sz="1600" spc="-2" dirty="0">
-              <a:latin typeface="Arial"/>
-            </a:endParaRPr>
-          </a:p>
-        </p:txBody>
-      </p:sp>
-      <p:sp>
-        <p:nvSpPr>
-          <p:cNvPr id="113" name="CustomShape 24">
-            <a:extLst>
-              <a:ext uri="{FF2B5EF4-FFF2-40B4-BE49-F238E27FC236}">
-                <a16:creationId xmlns:a16="http://schemas.microsoft.com/office/drawing/2014/main" id="{F7FC4F91-0E6E-4B6E-BF07-BC51B5C929A5}"/>
-              </a:ext>
-            </a:extLst>
-          </p:cNvPr>
-          <p:cNvSpPr/>
-          <p:nvPr/>
-        </p:nvSpPr>
-        <p:spPr>
-          <a:xfrm>
-            <a:off x="3816124" y="1604082"/>
-            <a:ext cx="1031760" cy="491094"/>
-          </a:xfrm>
-          <a:prstGeom prst="rect">
-            <a:avLst/>
-          </a:prstGeom>
-          <a:solidFill>
-            <a:schemeClr val="bg2"/>
-          </a:solidFill>
-          <a:ln>
-            <a:noFill/>
-          </a:ln>
-          <a:effectLst>
-            <a:outerShdw blurRad="50760" dist="37674" dir="2700000" algn="tl" rotWithShape="0">
-              <a:srgbClr val="000000">
-                <a:alpha val="40000"/>
-              </a:srgbClr>
-            </a:outerShdw>
-          </a:effectLst>
-        </p:spPr>
-        <p:style>
-          <a:lnRef idx="2">
-            <a:schemeClr val="accent1">
-              <a:shade val="50000"/>
-            </a:schemeClr>
-          </a:lnRef>
-          <a:fillRef idx="1">
-            <a:schemeClr val="accent1"/>
-          </a:fillRef>
-          <a:effectRef idx="0">
-            <a:schemeClr val="accent1"/>
-          </a:effectRef>
-          <a:fontRef idx="minor"/>
-        </p:style>
-        <p:txBody>
-          <a:bodyPr lIns="90000" tIns="45000" rIns="90000" bIns="45000" anchor="ctr">
-            <a:noAutofit/>
-          </a:bodyPr>
-          <a:lstStyle/>
-          <a:p>
-            <a:pPr algn="ctr"/>
-            <a:r>
-              <a:rPr lang="en-US" sz="1280" spc="-2" dirty="0">
-                <a:solidFill>
-                  <a:srgbClr val="FFFFFF"/>
-                </a:solidFill>
-                <a:latin typeface="Arial"/>
-              </a:rPr>
-              <a:t>Demos</a:t>
-            </a:r>
-            <a:endParaRPr lang="en-IN" sz="1280" spc="-2" dirty="0">
-              <a:solidFill>
-                <a:srgbClr val="FFFFFF"/>
-              </a:solidFill>
               <a:latin typeface="Arial"/>
             </a:endParaRPr>
           </a:p>
@@ -12183,8 +12037,8 @@
         </p:nvSpPr>
         <p:spPr>
           <a:xfrm>
-            <a:off x="1974457" y="3529383"/>
-            <a:ext cx="5758860" cy="1377720"/>
+            <a:off x="524107" y="3529383"/>
+            <a:ext cx="7209210" cy="1377720"/>
           </a:xfrm>
           <a:prstGeom prst="rect">
             <a:avLst/>
@@ -12262,78 +12116,6 @@
       </p:sp>
       <p:sp>
         <p:nvSpPr>
-          <p:cNvPr id="83" name="CustomShape 15">
-            <a:extLst>
-              <a:ext uri="{FF2B5EF4-FFF2-40B4-BE49-F238E27FC236}">
-                <a16:creationId xmlns:a16="http://schemas.microsoft.com/office/drawing/2014/main" id="{2B3E019C-8EF4-444D-8BD9-35787B4CE89D}"/>
-              </a:ext>
-            </a:extLst>
-          </p:cNvPr>
-          <p:cNvSpPr/>
-          <p:nvPr/>
-        </p:nvSpPr>
-        <p:spPr>
-          <a:xfrm>
-            <a:off x="6435589" y="4291694"/>
-            <a:ext cx="1094959" cy="497782"/>
-          </a:xfrm>
-          <a:prstGeom prst="rect">
-            <a:avLst/>
-          </a:prstGeom>
-          <a:solidFill>
-            <a:srgbClr val="00B0F0"/>
-          </a:solidFill>
-          <a:ln>
-            <a:noFill/>
-          </a:ln>
-          <a:effectLst>
-            <a:outerShdw blurRad="50760" dist="37674" dir="2700000" algn="tl" rotWithShape="0">
-              <a:srgbClr val="000000">
-                <a:alpha val="40000"/>
-              </a:srgbClr>
-            </a:outerShdw>
-          </a:effectLst>
-        </p:spPr>
-        <p:style>
-          <a:lnRef idx="2">
-            <a:schemeClr val="accent1">
-              <a:shade val="50000"/>
-            </a:schemeClr>
-          </a:lnRef>
-          <a:fillRef idx="1">
-            <a:schemeClr val="accent1"/>
-          </a:fillRef>
-          <a:effectRef idx="0">
-            <a:schemeClr val="accent1"/>
-          </a:effectRef>
-          <a:fontRef idx="minor"/>
-        </p:style>
-        <p:txBody>
-          <a:bodyPr lIns="90000" tIns="45000" rIns="90000" bIns="45000" anchor="ctr">
-            <a:noAutofit/>
-          </a:bodyPr>
-          <a:lstStyle/>
-          <a:p>
-            <a:pPr algn="ctr"/>
-            <a:r>
-              <a:rPr lang="en-US" sz="1280" spc="-2" dirty="0">
-                <a:solidFill>
-                  <a:srgbClr val="000000"/>
-                </a:solidFill>
-              </a:rPr>
-              <a:t>Tamagawa</a:t>
-            </a:r>
-            <a:endParaRPr lang="en-IN" sz="1280" spc="-2" dirty="0">
-              <a:solidFill>
-                <a:srgbClr val="000000"/>
-              </a:solidFill>
-              <a:latin typeface="Arial"/>
-            </a:endParaRPr>
-          </a:p>
-        </p:txBody>
-      </p:sp>
-      <p:sp>
-        <p:nvSpPr>
           <p:cNvPr id="42" name="CustomShape 15">
             <a:extLst>
               <a:ext uri="{FF2B5EF4-FFF2-40B4-BE49-F238E27FC236}">
@@ -12401,353 +12183,6 @@
       </p:sp>
       <p:sp>
         <p:nvSpPr>
-          <p:cNvPr id="76" name="CustomShape 4">
-            <a:extLst>
-              <a:ext uri="{FF2B5EF4-FFF2-40B4-BE49-F238E27FC236}">
-                <a16:creationId xmlns:a16="http://schemas.microsoft.com/office/drawing/2014/main" id="{1B024EA3-0E43-445D-BF88-EC0D5B5DFFBA}"/>
-              </a:ext>
-            </a:extLst>
-          </p:cNvPr>
-          <p:cNvSpPr/>
-          <p:nvPr/>
-        </p:nvSpPr>
-        <p:spPr>
-          <a:xfrm>
-            <a:off x="3815786" y="4256573"/>
-            <a:ext cx="1030713" cy="497783"/>
-          </a:xfrm>
-          <a:prstGeom prst="rect">
-            <a:avLst/>
-          </a:prstGeom>
-          <a:solidFill>
-            <a:schemeClr val="bg2"/>
-          </a:solidFill>
-          <a:ln>
-            <a:noFill/>
-          </a:ln>
-          <a:effectLst>
-            <a:outerShdw blurRad="50760" dist="37674" dir="2700000" algn="tl" rotWithShape="0">
-              <a:srgbClr val="000000">
-                <a:alpha val="40000"/>
-              </a:srgbClr>
-            </a:outerShdw>
-          </a:effectLst>
-        </p:spPr>
-        <p:style>
-          <a:lnRef idx="2">
-            <a:schemeClr val="accent1">
-              <a:shade val="50000"/>
-            </a:schemeClr>
-          </a:lnRef>
-          <a:fillRef idx="1">
-            <a:schemeClr val="accent1"/>
-          </a:fillRef>
-          <a:effectRef idx="0">
-            <a:schemeClr val="accent1"/>
-          </a:effectRef>
-          <a:fontRef idx="minor"/>
-        </p:style>
-        <p:txBody>
-          <a:bodyPr lIns="90000" tIns="45000" rIns="90000" bIns="45000" anchor="ctr">
-            <a:noAutofit/>
-          </a:bodyPr>
-          <a:lstStyle/>
-          <a:p>
-            <a:pPr algn="ctr"/>
-            <a:r>
-              <a:rPr lang="en-US" sz="1280" spc="-2" dirty="0">
-                <a:solidFill>
-                  <a:srgbClr val="FFFFFF"/>
-                </a:solidFill>
-                <a:latin typeface="Arial"/>
-              </a:rPr>
-              <a:t>SOC Peripheral</a:t>
-            </a:r>
-            <a:endParaRPr lang="en-IN" sz="1280" spc="-2" dirty="0">
-              <a:solidFill>
-                <a:srgbClr val="FFFFFF"/>
-              </a:solidFill>
-              <a:latin typeface="Arial"/>
-            </a:endParaRPr>
-          </a:p>
-        </p:txBody>
-      </p:sp>
-      <p:sp>
-        <p:nvSpPr>
-          <p:cNvPr id="78" name="CustomShape 8">
-            <a:extLst>
-              <a:ext uri="{FF2B5EF4-FFF2-40B4-BE49-F238E27FC236}">
-                <a16:creationId xmlns:a16="http://schemas.microsoft.com/office/drawing/2014/main" id="{490D27A3-6945-406A-BAF2-EFE79C38162A}"/>
-              </a:ext>
-            </a:extLst>
-          </p:cNvPr>
-          <p:cNvSpPr/>
-          <p:nvPr/>
-        </p:nvSpPr>
-        <p:spPr>
-          <a:xfrm>
-            <a:off x="6435589" y="3644037"/>
-            <a:ext cx="1093502" cy="508005"/>
-          </a:xfrm>
-          <a:prstGeom prst="rect">
-            <a:avLst/>
-          </a:prstGeom>
-          <a:solidFill>
-            <a:srgbClr val="00B0F0"/>
-          </a:solidFill>
-          <a:ln>
-            <a:noFill/>
-          </a:ln>
-          <a:effectLst>
-            <a:outerShdw blurRad="50760" dist="37674" dir="2700000" algn="tl" rotWithShape="0">
-              <a:srgbClr val="000000">
-                <a:alpha val="40000"/>
-              </a:srgbClr>
-            </a:outerShdw>
-          </a:effectLst>
-        </p:spPr>
-        <p:style>
-          <a:lnRef idx="2">
-            <a:schemeClr val="accent1">
-              <a:shade val="50000"/>
-            </a:schemeClr>
-          </a:lnRef>
-          <a:fillRef idx="1">
-            <a:schemeClr val="accent1"/>
-          </a:fillRef>
-          <a:effectRef idx="0">
-            <a:schemeClr val="accent1"/>
-          </a:effectRef>
-          <a:fontRef idx="minor"/>
-        </p:style>
-        <p:txBody>
-          <a:bodyPr lIns="90000" tIns="45000" rIns="90000" bIns="45000" anchor="ctr">
-            <a:noAutofit/>
-          </a:bodyPr>
-          <a:lstStyle/>
-          <a:p>
-            <a:pPr algn="ctr"/>
-            <a:r>
-              <a:rPr lang="en-IN" sz="1280" spc="-2" dirty="0">
-                <a:solidFill>
-                  <a:srgbClr val="000000"/>
-                </a:solidFill>
-                <a:latin typeface="Arial"/>
-              </a:rPr>
-              <a:t>EnDat</a:t>
-            </a:r>
-          </a:p>
-        </p:txBody>
-      </p:sp>
-      <p:sp>
-        <p:nvSpPr>
-          <p:cNvPr id="86" name="CustomShape 15">
-            <a:extLst>
-              <a:ext uri="{FF2B5EF4-FFF2-40B4-BE49-F238E27FC236}">
-                <a16:creationId xmlns:a16="http://schemas.microsoft.com/office/drawing/2014/main" id="{3A564F5B-DC40-45FF-8B10-DCCC5DE7D8E3}"/>
-              </a:ext>
-            </a:extLst>
-          </p:cNvPr>
-          <p:cNvSpPr/>
-          <p:nvPr/>
-        </p:nvSpPr>
-        <p:spPr>
-          <a:xfrm>
-            <a:off x="3815786" y="3662725"/>
-            <a:ext cx="1030713" cy="449641"/>
-          </a:xfrm>
-          <a:prstGeom prst="rect">
-            <a:avLst/>
-          </a:prstGeom>
-          <a:solidFill>
-            <a:schemeClr val="bg2"/>
-          </a:solidFill>
-          <a:ln>
-            <a:noFill/>
-          </a:ln>
-          <a:effectLst>
-            <a:outerShdw blurRad="50760" dist="37674" dir="2700000" algn="tl" rotWithShape="0">
-              <a:srgbClr val="000000">
-                <a:alpha val="40000"/>
-              </a:srgbClr>
-            </a:outerShdw>
-          </a:effectLst>
-        </p:spPr>
-        <p:style>
-          <a:lnRef idx="2">
-            <a:schemeClr val="accent1">
-              <a:shade val="50000"/>
-            </a:schemeClr>
-          </a:lnRef>
-          <a:fillRef idx="1">
-            <a:schemeClr val="accent1"/>
-          </a:fillRef>
-          <a:effectRef idx="0">
-            <a:schemeClr val="accent1"/>
-          </a:effectRef>
-          <a:fontRef idx="minor"/>
-        </p:style>
-        <p:txBody>
-          <a:bodyPr lIns="90000" tIns="45000" rIns="90000" bIns="45000" anchor="ctr">
-            <a:noAutofit/>
-          </a:bodyPr>
-          <a:lstStyle/>
-          <a:p>
-            <a:pPr algn="ctr"/>
-            <a:r>
-              <a:rPr lang="en-US" sz="1280" spc="-2" dirty="0">
-                <a:solidFill>
-                  <a:srgbClr val="FFFFFF"/>
-                </a:solidFill>
-                <a:latin typeface="Arial"/>
-              </a:rPr>
-              <a:t>Board Peripheral</a:t>
-            </a:r>
-            <a:endParaRPr lang="en-IN" sz="1280" spc="-2" dirty="0">
-              <a:solidFill>
-                <a:srgbClr val="FFFFFF"/>
-              </a:solidFill>
-              <a:latin typeface="Arial"/>
-            </a:endParaRPr>
-          </a:p>
-        </p:txBody>
-      </p:sp>
-      <p:sp>
-        <p:nvSpPr>
-          <p:cNvPr id="90" name="CustomShape 8">
-            <a:extLst>
-              <a:ext uri="{FF2B5EF4-FFF2-40B4-BE49-F238E27FC236}">
-                <a16:creationId xmlns:a16="http://schemas.microsoft.com/office/drawing/2014/main" id="{51B6AC0E-4960-4B0D-A32D-2DE55843B9E2}"/>
-              </a:ext>
-            </a:extLst>
-          </p:cNvPr>
-          <p:cNvSpPr/>
-          <p:nvPr/>
-        </p:nvSpPr>
-        <p:spPr>
-          <a:xfrm>
-            <a:off x="5131149" y="3640214"/>
-            <a:ext cx="1093502" cy="507271"/>
-          </a:xfrm>
-          <a:prstGeom prst="rect">
-            <a:avLst/>
-          </a:prstGeom>
-          <a:solidFill>
-            <a:srgbClr val="92D050"/>
-          </a:solidFill>
-          <a:ln>
-            <a:noFill/>
-          </a:ln>
-          <a:effectLst>
-            <a:outerShdw blurRad="50760" dist="37674" dir="2700000" algn="tl" rotWithShape="0">
-              <a:srgbClr val="000000">
-                <a:alpha val="40000"/>
-              </a:srgbClr>
-            </a:outerShdw>
-          </a:effectLst>
-        </p:spPr>
-        <p:style>
-          <a:lnRef idx="2">
-            <a:schemeClr val="accent1">
-              <a:shade val="50000"/>
-            </a:schemeClr>
-          </a:lnRef>
-          <a:fillRef idx="1">
-            <a:schemeClr val="accent1"/>
-          </a:fillRef>
-          <a:effectRef idx="0">
-            <a:schemeClr val="accent1"/>
-          </a:effectRef>
-          <a:fontRef idx="minor"/>
-        </p:style>
-        <p:txBody>
-          <a:bodyPr lIns="90000" tIns="45000" rIns="90000" bIns="45000" anchor="ctr">
-            <a:noAutofit/>
-          </a:bodyPr>
-          <a:lstStyle/>
-          <a:p>
-            <a:pPr algn="ctr"/>
-            <a:r>
-              <a:rPr lang="en-IN" sz="1280" spc="-2" dirty="0">
-                <a:solidFill>
-                  <a:srgbClr val="000000"/>
-                </a:solidFill>
-                <a:latin typeface="Arial"/>
-              </a:rPr>
-              <a:t>EtherCAT FW HAL</a:t>
-            </a:r>
-          </a:p>
-        </p:txBody>
-      </p:sp>
-      <p:sp>
-        <p:nvSpPr>
-          <p:cNvPr id="91" name="CustomShape 8">
-            <a:extLst>
-              <a:ext uri="{FF2B5EF4-FFF2-40B4-BE49-F238E27FC236}">
-                <a16:creationId xmlns:a16="http://schemas.microsoft.com/office/drawing/2014/main" id="{14161222-74A9-4F70-807B-78DD69EEE3D1}"/>
-              </a:ext>
-            </a:extLst>
-          </p:cNvPr>
-          <p:cNvSpPr/>
-          <p:nvPr/>
-        </p:nvSpPr>
-        <p:spPr>
-          <a:xfrm>
-            <a:off x="5129692" y="4291693"/>
-            <a:ext cx="1094959" cy="463845"/>
-          </a:xfrm>
-          <a:prstGeom prst="rect">
-            <a:avLst/>
-          </a:prstGeom>
-          <a:solidFill>
-            <a:srgbClr val="92D050"/>
-          </a:solidFill>
-          <a:ln>
-            <a:noFill/>
-          </a:ln>
-          <a:effectLst>
-            <a:outerShdw blurRad="50760" dist="37674" dir="2700000" algn="tl" rotWithShape="0">
-              <a:srgbClr val="000000">
-                <a:alpha val="40000"/>
-              </a:srgbClr>
-            </a:outerShdw>
-          </a:effectLst>
-        </p:spPr>
-        <p:style>
-          <a:lnRef idx="2">
-            <a:schemeClr val="accent1">
-              <a:shade val="50000"/>
-            </a:schemeClr>
-          </a:lnRef>
-          <a:fillRef idx="1">
-            <a:schemeClr val="accent1"/>
-          </a:fillRef>
-          <a:effectRef idx="0">
-            <a:schemeClr val="accent1"/>
-          </a:effectRef>
-          <a:fontRef idx="minor"/>
-        </p:style>
-        <p:txBody>
-          <a:bodyPr lIns="90000" tIns="45000" rIns="90000" bIns="45000" anchor="ctr">
-            <a:noAutofit/>
-          </a:bodyPr>
-          <a:lstStyle/>
-          <a:p>
-            <a:pPr algn="ctr"/>
-            <a:r>
-              <a:rPr lang="en-IN" sz="1280" spc="-2" dirty="0">
-                <a:solidFill>
-                  <a:srgbClr val="000000"/>
-                </a:solidFill>
-                <a:latin typeface="Arial"/>
-              </a:rPr>
-              <a:t>ICSS EMAC</a:t>
-            </a:r>
-          </a:p>
-        </p:txBody>
-      </p:sp>
-      <p:sp>
-        <p:nvSpPr>
           <p:cNvPr id="92" name="CustomShape 14">
             <a:extLst>
               <a:ext uri="{FF2B5EF4-FFF2-40B4-BE49-F238E27FC236}">
@@ -12760,8 +12195,8 @@
         </p:nvSpPr>
         <p:spPr>
           <a:xfrm>
-            <a:off x="1984105" y="2446421"/>
-            <a:ext cx="5738720" cy="858028"/>
+            <a:off x="524107" y="2446421"/>
+            <a:ext cx="7198718" cy="858028"/>
           </a:xfrm>
           <a:prstGeom prst="rect">
             <a:avLst/>
@@ -12846,7 +12281,7 @@
         </p:nvSpPr>
         <p:spPr>
           <a:xfrm>
-            <a:off x="4385871" y="2678161"/>
+            <a:off x="2331827" y="2646651"/>
             <a:ext cx="1033751" cy="449641"/>
           </a:xfrm>
           <a:prstGeom prst="rect">
@@ -12931,7 +12366,7 @@
         </p:nvSpPr>
         <p:spPr>
           <a:xfrm>
-            <a:off x="5909216" y="2678161"/>
+            <a:off x="3631602" y="2650615"/>
             <a:ext cx="1052746" cy="449640"/>
           </a:xfrm>
           <a:prstGeom prst="rect">
@@ -12984,218 +12419,12 @@
           </a:p>
         </p:txBody>
       </p:sp>
-      <p:sp>
-        <p:nvSpPr>
-          <p:cNvPr id="142" name="CustomShape 8">
+      <p:grpSp>
+        <p:nvGrpSpPr>
+          <p:cNvPr id="5" name="Group 4">
             <a:extLst>
               <a:ext uri="{FF2B5EF4-FFF2-40B4-BE49-F238E27FC236}">
-                <a16:creationId xmlns:a16="http://schemas.microsoft.com/office/drawing/2014/main" id="{84F12E88-D8B0-41DD-AAA0-7C765BE9231D}"/>
-              </a:ext>
-            </a:extLst>
-          </p:cNvPr>
-          <p:cNvSpPr/>
-          <p:nvPr/>
-        </p:nvSpPr>
-        <p:spPr>
-          <a:xfrm>
-            <a:off x="5025670" y="999061"/>
-            <a:ext cx="1185077" cy="455099"/>
-          </a:xfrm>
-          <a:prstGeom prst="rect">
-            <a:avLst/>
-          </a:prstGeom>
-          <a:solidFill>
-            <a:srgbClr val="92D050"/>
-          </a:solidFill>
-          <a:ln>
-            <a:noFill/>
-          </a:ln>
-          <a:effectLst>
-            <a:outerShdw blurRad="50760" dist="37674" dir="2700000" algn="tl" rotWithShape="0">
-              <a:srgbClr val="000000">
-                <a:alpha val="40000"/>
-              </a:srgbClr>
-            </a:outerShdw>
-          </a:effectLst>
-        </p:spPr>
-        <p:style>
-          <a:lnRef idx="2">
-            <a:schemeClr val="accent1">
-              <a:shade val="50000"/>
-            </a:schemeClr>
-          </a:lnRef>
-          <a:fillRef idx="1">
-            <a:schemeClr val="accent1"/>
-          </a:fillRef>
-          <a:effectRef idx="0">
-            <a:schemeClr val="accent1"/>
-          </a:effectRef>
-          <a:fontRef idx="minor"/>
-        </p:style>
-        <p:txBody>
-          <a:bodyPr lIns="90000" tIns="45000" rIns="90000" bIns="45000" anchor="ctr">
-            <a:noAutofit/>
-          </a:bodyPr>
-          <a:lstStyle/>
-          <a:p>
-            <a:pPr algn="ctr"/>
-            <a:r>
-              <a:rPr lang="en-IN" sz="1280" spc="-2" dirty="0">
-                <a:solidFill>
-                  <a:srgbClr val="000000"/>
-                </a:solidFill>
-                <a:latin typeface="Arial"/>
-              </a:rPr>
-              <a:t>EtherCAT</a:t>
-            </a:r>
-          </a:p>
-        </p:txBody>
-      </p:sp>
-      <p:sp>
-        <p:nvSpPr>
-          <p:cNvPr id="69" name="CustomShape 15">
-            <a:extLst>
-              <a:ext uri="{FF2B5EF4-FFF2-40B4-BE49-F238E27FC236}">
-                <a16:creationId xmlns:a16="http://schemas.microsoft.com/office/drawing/2014/main" id="{94A9817F-8321-4B48-A6E6-43178676CCF7}"/>
-              </a:ext>
-            </a:extLst>
-          </p:cNvPr>
-          <p:cNvSpPr/>
-          <p:nvPr/>
-        </p:nvSpPr>
-        <p:spPr>
-          <a:xfrm>
-            <a:off x="6415211" y="1588356"/>
-            <a:ext cx="1094959" cy="501106"/>
-          </a:xfrm>
-          <a:prstGeom prst="rect">
-            <a:avLst/>
-          </a:prstGeom>
-          <a:solidFill>
-            <a:srgbClr val="00B0F0"/>
-          </a:solidFill>
-          <a:ln>
-            <a:noFill/>
-          </a:ln>
-          <a:effectLst>
-            <a:outerShdw blurRad="50760" dist="37674" dir="2700000" algn="tl" rotWithShape="0">
-              <a:srgbClr val="000000">
-                <a:alpha val="40000"/>
-              </a:srgbClr>
-            </a:outerShdw>
-          </a:effectLst>
-        </p:spPr>
-        <p:style>
-          <a:lnRef idx="2">
-            <a:schemeClr val="accent1">
-              <a:shade val="50000"/>
-            </a:schemeClr>
-          </a:lnRef>
-          <a:fillRef idx="1">
-            <a:schemeClr val="accent1"/>
-          </a:fillRef>
-          <a:effectRef idx="0">
-            <a:schemeClr val="accent1"/>
-          </a:effectRef>
-          <a:fontRef idx="minor"/>
-        </p:style>
-        <p:txBody>
-          <a:bodyPr lIns="90000" tIns="45000" rIns="90000" bIns="45000" anchor="ctr">
-            <a:noAutofit/>
-          </a:bodyPr>
-          <a:lstStyle/>
-          <a:p>
-            <a:pPr algn="ctr"/>
-            <a:r>
-              <a:rPr lang="en-US" sz="1280" spc="-2" dirty="0">
-                <a:solidFill>
-                  <a:srgbClr val="000000"/>
-                </a:solidFill>
-              </a:rPr>
-              <a:t>Tamagawa</a:t>
-            </a:r>
-            <a:endParaRPr lang="en-IN" sz="1280" spc="-2" dirty="0">
-              <a:solidFill>
-                <a:srgbClr val="000000"/>
-              </a:solidFill>
-              <a:latin typeface="Arial"/>
-            </a:endParaRPr>
-          </a:p>
-        </p:txBody>
-      </p:sp>
-      <p:sp>
-        <p:nvSpPr>
-          <p:cNvPr id="70" name="CustomShape 8">
-            <a:extLst>
-              <a:ext uri="{FF2B5EF4-FFF2-40B4-BE49-F238E27FC236}">
-                <a16:creationId xmlns:a16="http://schemas.microsoft.com/office/drawing/2014/main" id="{ACF071DC-726D-42F2-B042-ED4EC811037C}"/>
-              </a:ext>
-            </a:extLst>
-          </p:cNvPr>
-          <p:cNvSpPr/>
-          <p:nvPr/>
-        </p:nvSpPr>
-        <p:spPr>
-          <a:xfrm>
-            <a:off x="6415211" y="999062"/>
-            <a:ext cx="1093502" cy="449642"/>
-          </a:xfrm>
-          <a:prstGeom prst="rect">
-            <a:avLst/>
-          </a:prstGeom>
-          <a:solidFill>
-            <a:srgbClr val="00B0F0"/>
-          </a:solidFill>
-          <a:ln>
-            <a:noFill/>
-          </a:ln>
-          <a:effectLst>
-            <a:outerShdw blurRad="50760" dist="37674" dir="2700000" algn="tl" rotWithShape="0">
-              <a:srgbClr val="000000">
-                <a:alpha val="40000"/>
-              </a:srgbClr>
-            </a:outerShdw>
-          </a:effectLst>
-        </p:spPr>
-        <p:style>
-          <a:lnRef idx="2">
-            <a:schemeClr val="accent1">
-              <a:shade val="50000"/>
-            </a:schemeClr>
-          </a:lnRef>
-          <a:fillRef idx="1">
-            <a:schemeClr val="accent1"/>
-          </a:fillRef>
-          <a:effectRef idx="0">
-            <a:schemeClr val="accent1"/>
-          </a:effectRef>
-          <a:fontRef idx="minor"/>
-        </p:style>
-        <p:txBody>
-          <a:bodyPr lIns="90000" tIns="45000" rIns="90000" bIns="45000" anchor="ctr">
-            <a:noAutofit/>
-          </a:bodyPr>
-          <a:lstStyle/>
-          <a:p>
-            <a:pPr algn="ctr"/>
-            <a:r>
-              <a:rPr lang="en-IN" sz="1280" spc="-2" dirty="0">
-                <a:solidFill>
-                  <a:srgbClr val="000000"/>
-                </a:solidFill>
-                <a:latin typeface="Arial"/>
-              </a:rPr>
-              <a:t>EnDat</a:t>
-            </a:r>
-          </a:p>
-        </p:txBody>
-      </p:sp>
-      <p:grpSp>
-        <p:nvGrpSpPr>
-          <p:cNvPr id="39" name="Group 38">
-            <a:extLst>
-              <a:ext uri="{FF2B5EF4-FFF2-40B4-BE49-F238E27FC236}">
-                <a16:creationId xmlns:a16="http://schemas.microsoft.com/office/drawing/2014/main" id="{6BD1015E-3835-446B-B2DC-ED9330F617FB}"/>
+                <a16:creationId xmlns:a16="http://schemas.microsoft.com/office/drawing/2014/main" id="{AEA93676-F8AC-4475-A4C3-E7488D990B68}"/>
               </a:ext>
             </a:extLst>
           </p:cNvPr>
@@ -13204,10 +12433,776 @@
         </p:nvGrpSpPr>
         <p:grpSpPr>
           <a:xfrm>
-            <a:off x="7976203" y="2756717"/>
-            <a:ext cx="1118769" cy="1812015"/>
-            <a:chOff x="7974028" y="1413194"/>
-            <a:chExt cx="1118769" cy="1812015"/>
+            <a:off x="1852003" y="1599526"/>
+            <a:ext cx="5750763" cy="489936"/>
+            <a:chOff x="1963773" y="1577028"/>
+            <a:chExt cx="5750763" cy="489936"/>
+          </a:xfrm>
+        </p:grpSpPr>
+        <p:sp>
+          <p:nvSpPr>
+            <p:cNvPr id="113" name="CustomShape 24">
+              <a:extLst>
+                <a:ext uri="{FF2B5EF4-FFF2-40B4-BE49-F238E27FC236}">
+                  <a16:creationId xmlns:a16="http://schemas.microsoft.com/office/drawing/2014/main" id="{F7FC4F91-0E6E-4B6E-BF07-BC51B5C929A5}"/>
+                </a:ext>
+              </a:extLst>
+            </p:cNvPr>
+            <p:cNvSpPr/>
+            <p:nvPr/>
+          </p:nvSpPr>
+          <p:spPr>
+            <a:xfrm>
+              <a:off x="1963773" y="1594157"/>
+              <a:ext cx="1031760" cy="448541"/>
+            </a:xfrm>
+            <a:prstGeom prst="rect">
+              <a:avLst/>
+            </a:prstGeom>
+            <a:solidFill>
+              <a:schemeClr val="bg2"/>
+            </a:solidFill>
+            <a:ln>
+              <a:noFill/>
+            </a:ln>
+            <a:effectLst>
+              <a:outerShdw blurRad="50760" dist="37674" dir="2700000" algn="tl" rotWithShape="0">
+                <a:srgbClr val="000000">
+                  <a:alpha val="40000"/>
+                </a:srgbClr>
+              </a:outerShdw>
+            </a:effectLst>
+          </p:spPr>
+          <p:style>
+            <a:lnRef idx="2">
+              <a:schemeClr val="accent1">
+                <a:shade val="50000"/>
+              </a:schemeClr>
+            </a:lnRef>
+            <a:fillRef idx="1">
+              <a:schemeClr val="accent1"/>
+            </a:fillRef>
+            <a:effectRef idx="0">
+              <a:schemeClr val="accent1"/>
+            </a:effectRef>
+            <a:fontRef idx="minor"/>
+          </p:style>
+          <p:txBody>
+            <a:bodyPr lIns="90000" tIns="45000" rIns="90000" bIns="45000" anchor="ctr">
+              <a:noAutofit/>
+            </a:bodyPr>
+            <a:lstStyle/>
+            <a:p>
+              <a:pPr algn="ctr"/>
+              <a:r>
+                <a:rPr lang="en-US" sz="1280" spc="-2" dirty="0">
+                  <a:solidFill>
+                    <a:srgbClr val="FFFFFF"/>
+                  </a:solidFill>
+                  <a:latin typeface="Arial"/>
+                </a:rPr>
+                <a:t>Demos</a:t>
+              </a:r>
+              <a:endParaRPr lang="en-IN" sz="1280" spc="-2" dirty="0">
+                <a:solidFill>
+                  <a:srgbClr val="FFFFFF"/>
+                </a:solidFill>
+                <a:latin typeface="Arial"/>
+              </a:endParaRPr>
+            </a:p>
+          </p:txBody>
+        </p:sp>
+        <p:grpSp>
+          <p:nvGrpSpPr>
+            <p:cNvPr id="4" name="Group 3">
+              <a:extLst>
+                <a:ext uri="{FF2B5EF4-FFF2-40B4-BE49-F238E27FC236}">
+                  <a16:creationId xmlns:a16="http://schemas.microsoft.com/office/drawing/2014/main" id="{BA3E4047-8A5B-4D11-89AE-7E8A12E72099}"/>
+                </a:ext>
+              </a:extLst>
+            </p:cNvPr>
+            <p:cNvGrpSpPr/>
+            <p:nvPr/>
+          </p:nvGrpSpPr>
+          <p:grpSpPr>
+            <a:xfrm>
+              <a:off x="3141326" y="1577028"/>
+              <a:ext cx="4573210" cy="489936"/>
+              <a:chOff x="3141326" y="1577028"/>
+              <a:chExt cx="4573210" cy="489936"/>
+            </a:xfrm>
+          </p:grpSpPr>
+          <p:sp>
+            <p:nvSpPr>
+              <p:cNvPr id="69" name="CustomShape 15">
+                <a:extLst>
+                  <a:ext uri="{FF2B5EF4-FFF2-40B4-BE49-F238E27FC236}">
+                    <a16:creationId xmlns:a16="http://schemas.microsoft.com/office/drawing/2014/main" id="{94A9817F-8321-4B48-A6E6-43178676CCF7}"/>
+                  </a:ext>
+                </a:extLst>
+              </p:cNvPr>
+              <p:cNvSpPr/>
+              <p:nvPr/>
+            </p:nvSpPr>
+            <p:spPr>
+              <a:xfrm>
+                <a:off x="5454077" y="1577836"/>
+                <a:ext cx="1031759" cy="489128"/>
+              </a:xfrm>
+              <a:prstGeom prst="rect">
+                <a:avLst/>
+              </a:prstGeom>
+              <a:solidFill>
+                <a:srgbClr val="00B0F0"/>
+              </a:solidFill>
+              <a:ln>
+                <a:noFill/>
+              </a:ln>
+              <a:effectLst>
+                <a:outerShdw blurRad="50760" dist="37674" dir="2700000" algn="tl" rotWithShape="0">
+                  <a:srgbClr val="000000">
+                    <a:alpha val="40000"/>
+                  </a:srgbClr>
+                </a:outerShdw>
+              </a:effectLst>
+            </p:spPr>
+            <p:style>
+              <a:lnRef idx="2">
+                <a:schemeClr val="accent1">
+                  <a:shade val="50000"/>
+                </a:schemeClr>
+              </a:lnRef>
+              <a:fillRef idx="1">
+                <a:schemeClr val="accent1"/>
+              </a:fillRef>
+              <a:effectRef idx="0">
+                <a:schemeClr val="accent1"/>
+              </a:effectRef>
+              <a:fontRef idx="minor"/>
+            </p:style>
+            <p:txBody>
+              <a:bodyPr lIns="90000" tIns="45000" rIns="90000" bIns="45000" anchor="ctr">
+                <a:noAutofit/>
+              </a:bodyPr>
+              <a:lstStyle/>
+              <a:p>
+                <a:pPr algn="ctr"/>
+                <a:r>
+                  <a:rPr lang="en-US" sz="1280" spc="-2" dirty="0">
+                    <a:solidFill>
+                      <a:srgbClr val="000000"/>
+                    </a:solidFill>
+                  </a:rPr>
+                  <a:t>Nikon</a:t>
+                </a:r>
+              </a:p>
+              <a:p>
+                <a:pPr algn="ctr"/>
+                <a:r>
+                  <a:rPr lang="en-US" sz="1280" spc="-2" dirty="0">
+                    <a:solidFill>
+                      <a:srgbClr val="000000"/>
+                    </a:solidFill>
+                    <a:latin typeface="Arial"/>
+                  </a:rPr>
+                  <a:t>A-Format</a:t>
+                </a:r>
+                <a:endParaRPr lang="en-IN" sz="1280" spc="-2" dirty="0">
+                  <a:solidFill>
+                    <a:srgbClr val="000000"/>
+                  </a:solidFill>
+                  <a:latin typeface="Arial"/>
+                </a:endParaRPr>
+              </a:p>
+            </p:txBody>
+          </p:sp>
+          <p:sp>
+            <p:nvSpPr>
+              <p:cNvPr id="44" name="CustomShape 8">
+                <a:extLst>
+                  <a:ext uri="{FF2B5EF4-FFF2-40B4-BE49-F238E27FC236}">
+                    <a16:creationId xmlns:a16="http://schemas.microsoft.com/office/drawing/2014/main" id="{0F9232B9-A9C5-4DDA-B5BF-882722F6F902}"/>
+                  </a:ext>
+                </a:extLst>
+              </p:cNvPr>
+              <p:cNvSpPr/>
+              <p:nvPr/>
+            </p:nvSpPr>
+            <p:spPr>
+              <a:xfrm>
+                <a:off x="4309019" y="1577836"/>
+                <a:ext cx="1012511" cy="474753"/>
+              </a:xfrm>
+              <a:prstGeom prst="rect">
+                <a:avLst/>
+              </a:prstGeom>
+              <a:solidFill>
+                <a:srgbClr val="00B0F0"/>
+              </a:solidFill>
+              <a:ln>
+                <a:noFill/>
+              </a:ln>
+              <a:effectLst>
+                <a:outerShdw blurRad="50760" dist="37674" dir="2700000" algn="tl" rotWithShape="0">
+                  <a:srgbClr val="000000">
+                    <a:alpha val="40000"/>
+                  </a:srgbClr>
+                </a:outerShdw>
+              </a:effectLst>
+            </p:spPr>
+            <p:style>
+              <a:lnRef idx="2">
+                <a:schemeClr val="accent1">
+                  <a:shade val="50000"/>
+                </a:schemeClr>
+              </a:lnRef>
+              <a:fillRef idx="1">
+                <a:schemeClr val="accent1"/>
+              </a:fillRef>
+              <a:effectRef idx="0">
+                <a:schemeClr val="accent1"/>
+              </a:effectRef>
+              <a:fontRef idx="minor"/>
+            </p:style>
+            <p:txBody>
+              <a:bodyPr lIns="90000" tIns="45000" rIns="90000" bIns="45000" anchor="ctr">
+                <a:noAutofit/>
+              </a:bodyPr>
+              <a:lstStyle/>
+              <a:p>
+                <a:pPr algn="ctr"/>
+                <a:r>
+                  <a:rPr lang="en-IN" sz="1280" spc="-2" dirty="0">
+                    <a:solidFill>
+                      <a:srgbClr val="000000"/>
+                    </a:solidFill>
+                    <a:latin typeface="Arial"/>
+                  </a:rPr>
+                  <a:t>HDSL</a:t>
+                </a:r>
+              </a:p>
+            </p:txBody>
+          </p:sp>
+          <p:sp>
+            <p:nvSpPr>
+              <p:cNvPr id="46" name="CustomShape 15">
+                <a:extLst>
+                  <a:ext uri="{FF2B5EF4-FFF2-40B4-BE49-F238E27FC236}">
+                    <a16:creationId xmlns:a16="http://schemas.microsoft.com/office/drawing/2014/main" id="{03CE2D63-51C3-4ACB-975B-DDC41E0B9A6E}"/>
+                  </a:ext>
+                </a:extLst>
+              </p:cNvPr>
+              <p:cNvSpPr/>
+              <p:nvPr/>
+            </p:nvSpPr>
+            <p:spPr>
+              <a:xfrm>
+                <a:off x="6686355" y="1577028"/>
+                <a:ext cx="1028181" cy="474753"/>
+              </a:xfrm>
+              <a:prstGeom prst="rect">
+                <a:avLst/>
+              </a:prstGeom>
+              <a:solidFill>
+                <a:srgbClr val="00B0F0"/>
+              </a:solidFill>
+              <a:ln>
+                <a:noFill/>
+              </a:ln>
+              <a:effectLst>
+                <a:outerShdw blurRad="50760" dist="37674" dir="2700000" algn="tl" rotWithShape="0">
+                  <a:srgbClr val="000000">
+                    <a:alpha val="40000"/>
+                  </a:srgbClr>
+                </a:outerShdw>
+              </a:effectLst>
+            </p:spPr>
+            <p:style>
+              <a:lnRef idx="2">
+                <a:schemeClr val="accent1">
+                  <a:shade val="50000"/>
+                </a:schemeClr>
+              </a:lnRef>
+              <a:fillRef idx="1">
+                <a:schemeClr val="accent1"/>
+              </a:fillRef>
+              <a:effectRef idx="0">
+                <a:schemeClr val="accent1"/>
+              </a:effectRef>
+              <a:fontRef idx="minor"/>
+            </p:style>
+            <p:txBody>
+              <a:bodyPr wrap="none" lIns="90000" tIns="45000" rIns="90000" bIns="45000" anchor="ctr">
+                <a:noAutofit/>
+              </a:bodyPr>
+              <a:lstStyle/>
+              <a:p>
+                <a:pPr algn="ctr"/>
+                <a:r>
+                  <a:rPr lang="en-IN" sz="1280" spc="-2" dirty="0">
+                    <a:solidFill>
+                      <a:srgbClr val="000000"/>
+                    </a:solidFill>
+                    <a:latin typeface="Arial"/>
+                  </a:rPr>
+                  <a:t>Tamagawa</a:t>
+                </a:r>
+              </a:p>
+            </p:txBody>
+          </p:sp>
+          <p:sp>
+            <p:nvSpPr>
+              <p:cNvPr id="48" name="CustomShape 8">
+                <a:extLst>
+                  <a:ext uri="{FF2B5EF4-FFF2-40B4-BE49-F238E27FC236}">
+                    <a16:creationId xmlns:a16="http://schemas.microsoft.com/office/drawing/2014/main" id="{F3F13926-7868-4E7A-AEB6-0A4ECC0A31BA}"/>
+                  </a:ext>
+                </a:extLst>
+              </p:cNvPr>
+              <p:cNvSpPr/>
+              <p:nvPr/>
+            </p:nvSpPr>
+            <p:spPr>
+              <a:xfrm>
+                <a:off x="3141326" y="1583042"/>
+                <a:ext cx="1031760" cy="464863"/>
+              </a:xfrm>
+              <a:prstGeom prst="rect">
+                <a:avLst/>
+              </a:prstGeom>
+              <a:solidFill>
+                <a:srgbClr val="92D050"/>
+              </a:solidFill>
+              <a:ln>
+                <a:noFill/>
+              </a:ln>
+              <a:effectLst>
+                <a:outerShdw blurRad="50760" dist="37674" dir="2700000" algn="tl" rotWithShape="0">
+                  <a:srgbClr val="000000">
+                    <a:alpha val="40000"/>
+                  </a:srgbClr>
+                </a:outerShdw>
+              </a:effectLst>
+            </p:spPr>
+            <p:style>
+              <a:lnRef idx="2">
+                <a:schemeClr val="accent1">
+                  <a:shade val="50000"/>
+                </a:schemeClr>
+              </a:lnRef>
+              <a:fillRef idx="1">
+                <a:schemeClr val="accent1"/>
+              </a:fillRef>
+              <a:effectRef idx="0">
+                <a:schemeClr val="accent1"/>
+              </a:effectRef>
+              <a:fontRef idx="minor"/>
+            </p:style>
+            <p:txBody>
+              <a:bodyPr lIns="90000" tIns="45000" rIns="90000" bIns="45000" anchor="ctr">
+                <a:noAutofit/>
+              </a:bodyPr>
+              <a:lstStyle/>
+              <a:p>
+                <a:pPr algn="ctr"/>
+                <a:r>
+                  <a:rPr lang="en-IN" sz="1280" spc="-2" dirty="0">
+                    <a:solidFill>
+                      <a:srgbClr val="000000"/>
+                    </a:solidFill>
+                    <a:latin typeface="Arial"/>
+                  </a:rPr>
+                  <a:t>IOLINK</a:t>
+                </a:r>
+              </a:p>
+            </p:txBody>
+          </p:sp>
+        </p:grpSp>
+      </p:grpSp>
+      <p:grpSp>
+        <p:nvGrpSpPr>
+          <p:cNvPr id="3" name="Group 2">
+            <a:extLst>
+              <a:ext uri="{FF2B5EF4-FFF2-40B4-BE49-F238E27FC236}">
+                <a16:creationId xmlns:a16="http://schemas.microsoft.com/office/drawing/2014/main" id="{0FA211B7-424C-4DDC-A434-438DFA87E82C}"/>
+              </a:ext>
+            </a:extLst>
+          </p:cNvPr>
+          <p:cNvGrpSpPr/>
+          <p:nvPr/>
+        </p:nvGrpSpPr>
+        <p:grpSpPr>
+          <a:xfrm>
+            <a:off x="1852003" y="981374"/>
+            <a:ext cx="5751316" cy="478788"/>
+            <a:chOff x="1961861" y="936270"/>
+            <a:chExt cx="5751316" cy="478788"/>
+          </a:xfrm>
+        </p:grpSpPr>
+        <p:sp>
+          <p:nvSpPr>
+            <p:cNvPr id="99" name="CustomShape 8">
+              <a:extLst>
+                <a:ext uri="{FF2B5EF4-FFF2-40B4-BE49-F238E27FC236}">
+                  <a16:creationId xmlns:a16="http://schemas.microsoft.com/office/drawing/2014/main" id="{300ACF90-638E-45E4-AA50-B7E85398CF97}"/>
+                </a:ext>
+              </a:extLst>
+            </p:cNvPr>
+            <p:cNvSpPr/>
+            <p:nvPr/>
+          </p:nvSpPr>
+          <p:spPr>
+            <a:xfrm>
+              <a:off x="1961861" y="936270"/>
+              <a:ext cx="1031758" cy="449641"/>
+            </a:xfrm>
+            <a:prstGeom prst="rect">
+              <a:avLst/>
+            </a:prstGeom>
+            <a:solidFill>
+              <a:schemeClr val="bg2"/>
+            </a:solidFill>
+            <a:ln>
+              <a:noFill/>
+            </a:ln>
+            <a:effectLst>
+              <a:outerShdw blurRad="50760" dist="37674" dir="2700000" algn="tl" rotWithShape="0">
+                <a:srgbClr val="000000">
+                  <a:alpha val="40000"/>
+                </a:srgbClr>
+              </a:outerShdw>
+            </a:effectLst>
+          </p:spPr>
+          <p:style>
+            <a:lnRef idx="2">
+              <a:schemeClr val="accent1">
+                <a:shade val="50000"/>
+              </a:schemeClr>
+            </a:lnRef>
+            <a:fillRef idx="1">
+              <a:schemeClr val="accent1"/>
+            </a:fillRef>
+            <a:effectRef idx="0">
+              <a:schemeClr val="accent1"/>
+            </a:effectRef>
+            <a:fontRef idx="minor"/>
+          </p:style>
+          <p:txBody>
+            <a:bodyPr lIns="90000" tIns="45000" rIns="90000" bIns="45000" anchor="ctr">
+              <a:noAutofit/>
+            </a:bodyPr>
+            <a:lstStyle/>
+            <a:p>
+              <a:pPr algn="ctr"/>
+              <a:r>
+                <a:rPr lang="en-US" sz="1280" spc="-2" dirty="0">
+                  <a:solidFill>
+                    <a:srgbClr val="FFFFFF"/>
+                  </a:solidFill>
+                  <a:latin typeface="Arial"/>
+                </a:rPr>
+                <a:t>Examples</a:t>
+              </a:r>
+              <a:endParaRPr lang="en-IN" sz="1280" spc="-2" dirty="0">
+                <a:solidFill>
+                  <a:srgbClr val="FFFFFF"/>
+                </a:solidFill>
+                <a:latin typeface="Arial"/>
+              </a:endParaRPr>
+            </a:p>
+          </p:txBody>
+        </p:sp>
+        <p:sp>
+          <p:nvSpPr>
+            <p:cNvPr id="142" name="CustomShape 8">
+              <a:extLst>
+                <a:ext uri="{FF2B5EF4-FFF2-40B4-BE49-F238E27FC236}">
+                  <a16:creationId xmlns:a16="http://schemas.microsoft.com/office/drawing/2014/main" id="{84F12E88-D8B0-41DD-AAA0-7C765BE9231D}"/>
+                </a:ext>
+              </a:extLst>
+            </p:cNvPr>
+            <p:cNvSpPr/>
+            <p:nvPr/>
+          </p:nvSpPr>
+          <p:spPr>
+            <a:xfrm>
+              <a:off x="3125816" y="939643"/>
+              <a:ext cx="1031759" cy="455099"/>
+            </a:xfrm>
+            <a:prstGeom prst="rect">
+              <a:avLst/>
+            </a:prstGeom>
+            <a:solidFill>
+              <a:srgbClr val="92D050"/>
+            </a:solidFill>
+            <a:ln>
+              <a:noFill/>
+            </a:ln>
+            <a:effectLst>
+              <a:outerShdw blurRad="50760" dist="37674" dir="2700000" algn="tl" rotWithShape="0">
+                <a:srgbClr val="000000">
+                  <a:alpha val="40000"/>
+                </a:srgbClr>
+              </a:outerShdw>
+            </a:effectLst>
+          </p:spPr>
+          <p:style>
+            <a:lnRef idx="2">
+              <a:schemeClr val="accent1">
+                <a:shade val="50000"/>
+              </a:schemeClr>
+            </a:lnRef>
+            <a:fillRef idx="1">
+              <a:schemeClr val="accent1"/>
+            </a:fillRef>
+            <a:effectRef idx="0">
+              <a:schemeClr val="accent1"/>
+            </a:effectRef>
+            <a:fontRef idx="minor"/>
+          </p:style>
+          <p:txBody>
+            <a:bodyPr lIns="90000" tIns="45000" rIns="90000" bIns="45000" anchor="ctr">
+              <a:noAutofit/>
+            </a:bodyPr>
+            <a:lstStyle/>
+            <a:p>
+              <a:pPr algn="ctr"/>
+              <a:r>
+                <a:rPr lang="en-IN" sz="1280" spc="-2" dirty="0">
+                  <a:solidFill>
+                    <a:srgbClr val="000000"/>
+                  </a:solidFill>
+                  <a:latin typeface="Arial"/>
+                </a:rPr>
+                <a:t>EtherCAT</a:t>
+              </a:r>
+            </a:p>
+          </p:txBody>
+        </p:sp>
+        <p:sp>
+          <p:nvSpPr>
+            <p:cNvPr id="70" name="CustomShape 8">
+              <a:extLst>
+                <a:ext uri="{FF2B5EF4-FFF2-40B4-BE49-F238E27FC236}">
+                  <a16:creationId xmlns:a16="http://schemas.microsoft.com/office/drawing/2014/main" id="{ACF071DC-726D-42F2-B042-ED4EC811037C}"/>
+                </a:ext>
+              </a:extLst>
+            </p:cNvPr>
+            <p:cNvSpPr/>
+            <p:nvPr/>
+          </p:nvSpPr>
+          <p:spPr>
+            <a:xfrm>
+              <a:off x="5441757" y="943439"/>
+              <a:ext cx="1031759" cy="449639"/>
+            </a:xfrm>
+            <a:prstGeom prst="rect">
+              <a:avLst/>
+            </a:prstGeom>
+            <a:solidFill>
+              <a:srgbClr val="00B0F0"/>
+            </a:solidFill>
+            <a:ln>
+              <a:noFill/>
+            </a:ln>
+            <a:effectLst>
+              <a:outerShdw blurRad="50760" dist="37674" dir="2700000" algn="tl" rotWithShape="0">
+                <a:srgbClr val="000000">
+                  <a:alpha val="40000"/>
+                </a:srgbClr>
+              </a:outerShdw>
+            </a:effectLst>
+          </p:spPr>
+          <p:style>
+            <a:lnRef idx="2">
+              <a:schemeClr val="accent1">
+                <a:shade val="50000"/>
+              </a:schemeClr>
+            </a:lnRef>
+            <a:fillRef idx="1">
+              <a:schemeClr val="accent1"/>
+            </a:fillRef>
+            <a:effectRef idx="0">
+              <a:schemeClr val="accent1"/>
+            </a:effectRef>
+            <a:fontRef idx="minor"/>
+          </p:style>
+          <p:txBody>
+            <a:bodyPr lIns="90000" tIns="45000" rIns="90000" bIns="45000" anchor="ctr">
+              <a:noAutofit/>
+            </a:bodyPr>
+            <a:lstStyle/>
+            <a:p>
+              <a:pPr algn="ctr"/>
+              <a:r>
+                <a:rPr lang="en-IN" sz="1280" spc="-2" dirty="0">
+                  <a:solidFill>
+                    <a:srgbClr val="000000"/>
+                  </a:solidFill>
+                  <a:latin typeface="Arial"/>
+                </a:rPr>
+                <a:t>BiSS-C</a:t>
+              </a:r>
+            </a:p>
+          </p:txBody>
+        </p:sp>
+        <p:sp>
+          <p:nvSpPr>
+            <p:cNvPr id="45" name="CustomShape 8">
+              <a:extLst>
+                <a:ext uri="{FF2B5EF4-FFF2-40B4-BE49-F238E27FC236}">
+                  <a16:creationId xmlns:a16="http://schemas.microsoft.com/office/drawing/2014/main" id="{3D881E8A-9BCF-435B-A691-F10F34FEB88B}"/>
+                </a:ext>
+              </a:extLst>
+            </p:cNvPr>
+            <p:cNvSpPr/>
+            <p:nvPr/>
+          </p:nvSpPr>
+          <p:spPr>
+            <a:xfrm>
+              <a:off x="6684443" y="936270"/>
+              <a:ext cx="1028734" cy="478788"/>
+            </a:xfrm>
+            <a:prstGeom prst="rect">
+              <a:avLst/>
+            </a:prstGeom>
+            <a:solidFill>
+              <a:srgbClr val="00B0F0"/>
+            </a:solidFill>
+            <a:ln>
+              <a:noFill/>
+            </a:ln>
+            <a:effectLst>
+              <a:outerShdw blurRad="50760" dist="37674" dir="2700000" algn="tl" rotWithShape="0">
+                <a:srgbClr val="000000">
+                  <a:alpha val="40000"/>
+                </a:srgbClr>
+              </a:outerShdw>
+            </a:effectLst>
+          </p:spPr>
+          <p:style>
+            <a:lnRef idx="2">
+              <a:schemeClr val="accent1">
+                <a:shade val="50000"/>
+              </a:schemeClr>
+            </a:lnRef>
+            <a:fillRef idx="1">
+              <a:schemeClr val="accent1"/>
+            </a:fillRef>
+            <a:effectRef idx="0">
+              <a:schemeClr val="accent1"/>
+            </a:effectRef>
+            <a:fontRef idx="minor"/>
+          </p:style>
+          <p:txBody>
+            <a:bodyPr lIns="90000" tIns="45000" rIns="90000" bIns="45000" anchor="ctr">
+              <a:noAutofit/>
+            </a:bodyPr>
+            <a:lstStyle/>
+            <a:p>
+              <a:pPr algn="ctr"/>
+              <a:r>
+                <a:rPr lang="en-US" sz="1280" spc="-2" dirty="0">
+                  <a:solidFill>
+                    <a:srgbClr val="000000"/>
+                  </a:solidFill>
+                </a:rPr>
+                <a:t>EnDat</a:t>
+              </a:r>
+              <a:endParaRPr lang="en-IN" sz="1280" spc="-2" dirty="0">
+                <a:solidFill>
+                  <a:srgbClr val="000000"/>
+                </a:solidFill>
+              </a:endParaRPr>
+            </a:p>
+          </p:txBody>
+        </p:sp>
+        <p:sp>
+          <p:nvSpPr>
+            <p:cNvPr id="49" name="CustomShape 8">
+              <a:extLst>
+                <a:ext uri="{FF2B5EF4-FFF2-40B4-BE49-F238E27FC236}">
+                  <a16:creationId xmlns:a16="http://schemas.microsoft.com/office/drawing/2014/main" id="{7128BE07-6182-46ED-8561-79949810231D}"/>
+                </a:ext>
+              </a:extLst>
+            </p:cNvPr>
+            <p:cNvSpPr/>
+            <p:nvPr/>
+          </p:nvSpPr>
+          <p:spPr>
+            <a:xfrm>
+              <a:off x="4289771" y="936271"/>
+              <a:ext cx="1031759" cy="474752"/>
+            </a:xfrm>
+            <a:prstGeom prst="rect">
+              <a:avLst/>
+            </a:prstGeom>
+            <a:solidFill>
+              <a:srgbClr val="92D050"/>
+            </a:solidFill>
+            <a:ln>
+              <a:noFill/>
+            </a:ln>
+            <a:effectLst>
+              <a:outerShdw blurRad="50760" dist="37674" dir="2700000" algn="tl" rotWithShape="0">
+                <a:srgbClr val="000000">
+                  <a:alpha val="40000"/>
+                </a:srgbClr>
+              </a:outerShdw>
+            </a:effectLst>
+          </p:spPr>
+          <p:style>
+            <a:lnRef idx="2">
+              <a:schemeClr val="accent1">
+                <a:shade val="50000"/>
+              </a:schemeClr>
+            </a:lnRef>
+            <a:fillRef idx="1">
+              <a:schemeClr val="accent1"/>
+            </a:fillRef>
+            <a:effectRef idx="0">
+              <a:schemeClr val="accent1"/>
+            </a:effectRef>
+            <a:fontRef idx="minor"/>
+          </p:style>
+          <p:txBody>
+            <a:bodyPr lIns="90000" tIns="45000" rIns="90000" bIns="45000" anchor="ctr">
+              <a:noAutofit/>
+            </a:bodyPr>
+            <a:lstStyle/>
+            <a:p>
+              <a:pPr algn="ctr"/>
+              <a:r>
+                <a:rPr lang="en-IN" sz="1280" spc="-2" dirty="0">
+                  <a:solidFill>
+                    <a:srgbClr val="000000"/>
+                  </a:solidFill>
+                  <a:latin typeface="Arial"/>
+                </a:rPr>
+                <a:t>EtherNet/IP</a:t>
+              </a:r>
+            </a:p>
+          </p:txBody>
+        </p:sp>
+      </p:grpSp>
+      <p:grpSp>
+        <p:nvGrpSpPr>
+          <p:cNvPr id="6" name="Group 5">
+            <a:extLst>
+              <a:ext uri="{FF2B5EF4-FFF2-40B4-BE49-F238E27FC236}">
+                <a16:creationId xmlns:a16="http://schemas.microsoft.com/office/drawing/2014/main" id="{2F1C7046-C779-4CDE-89D7-5E6DA3716311}"/>
+              </a:ext>
+            </a:extLst>
+          </p:cNvPr>
+          <p:cNvGrpSpPr/>
+          <p:nvPr/>
+        </p:nvGrpSpPr>
+        <p:grpSpPr>
+          <a:xfrm>
+            <a:off x="7961208" y="1508610"/>
+            <a:ext cx="1133304" cy="4249228"/>
+            <a:chOff x="7962195" y="1177283"/>
+            <a:chExt cx="1133304" cy="4249228"/>
           </a:xfrm>
         </p:grpSpPr>
         <p:sp>
@@ -13224,7 +13219,7 @@
           </p:nvSpPr>
           <p:spPr>
             <a:xfrm>
-              <a:off x="7974028" y="2854862"/>
+              <a:off x="7970653" y="4416651"/>
               <a:ext cx="1114418" cy="370347"/>
             </a:xfrm>
             <a:prstGeom prst="rect">
@@ -13297,7 +13292,7 @@
           </p:nvSpPr>
           <p:spPr>
             <a:xfrm>
-              <a:off x="7978379" y="1413194"/>
+              <a:off x="7981081" y="1831081"/>
               <a:ext cx="1114418" cy="370347"/>
             </a:xfrm>
             <a:prstGeom prst="rect">
@@ -13364,7 +13359,7 @@
           </p:nvSpPr>
           <p:spPr>
             <a:xfrm>
-              <a:off x="7974028" y="2148191"/>
+              <a:off x="7976203" y="3777138"/>
               <a:ext cx="1114418" cy="370347"/>
             </a:xfrm>
             <a:prstGeom prst="rect">
@@ -13420,6 +13415,1216 @@
                 </a:solidFill>
                 <a:latin typeface="Arial"/>
               </a:endParaRPr>
+            </a:p>
+          </p:txBody>
+        </p:sp>
+        <p:sp>
+          <p:nvSpPr>
+            <p:cNvPr id="50" name="CustomShape 8">
+              <a:extLst>
+                <a:ext uri="{FF2B5EF4-FFF2-40B4-BE49-F238E27FC236}">
+                  <a16:creationId xmlns:a16="http://schemas.microsoft.com/office/drawing/2014/main" id="{E055C7A8-A374-428A-9BE3-DEE183B5BC39}"/>
+                </a:ext>
+              </a:extLst>
+            </p:cNvPr>
+            <p:cNvSpPr/>
+            <p:nvPr/>
+          </p:nvSpPr>
+          <p:spPr>
+            <a:xfrm>
+              <a:off x="7978379" y="5056164"/>
+              <a:ext cx="1114418" cy="370347"/>
+            </a:xfrm>
+            <a:prstGeom prst="rect">
+              <a:avLst/>
+            </a:prstGeom>
+            <a:solidFill>
+              <a:srgbClr val="92D050"/>
+            </a:solidFill>
+            <a:ln>
+              <a:noFill/>
+            </a:ln>
+            <a:effectLst>
+              <a:outerShdw blurRad="50760" dist="37674" dir="2700000" algn="tl" rotWithShape="0">
+                <a:srgbClr val="000000">
+                  <a:alpha val="40000"/>
+                </a:srgbClr>
+              </a:outerShdw>
+            </a:effectLst>
+          </p:spPr>
+          <p:style>
+            <a:lnRef idx="2">
+              <a:schemeClr val="accent1">
+                <a:shade val="50000"/>
+              </a:schemeClr>
+            </a:lnRef>
+            <a:fillRef idx="1">
+              <a:schemeClr val="accent1"/>
+            </a:fillRef>
+            <a:effectRef idx="0">
+              <a:schemeClr val="accent1"/>
+            </a:effectRef>
+            <a:fontRef idx="minor"/>
+          </p:style>
+          <p:txBody>
+            <a:bodyPr lIns="56250" tIns="28125" rIns="56250" bIns="28125" anchor="ctr">
+              <a:noAutofit/>
+            </a:bodyPr>
+            <a:lstStyle/>
+            <a:p>
+              <a:pPr algn="ctr"/>
+              <a:r>
+                <a:rPr lang="en-US" sz="1280" spc="-1" dirty="0">
+                  <a:solidFill>
+                    <a:srgbClr val="000000"/>
+                  </a:solidFill>
+                  <a:latin typeface="Arial"/>
+                </a:rPr>
+                <a:t>EtherNet/IP</a:t>
+              </a:r>
+              <a:endParaRPr lang="en-IN" sz="1280" spc="-1" dirty="0">
+                <a:solidFill>
+                  <a:srgbClr val="000000"/>
+                </a:solidFill>
+                <a:latin typeface="Arial"/>
+              </a:endParaRPr>
+            </a:p>
+          </p:txBody>
+        </p:sp>
+        <p:sp>
+          <p:nvSpPr>
+            <p:cNvPr id="54" name="CustomShape 8">
+              <a:extLst>
+                <a:ext uri="{FF2B5EF4-FFF2-40B4-BE49-F238E27FC236}">
+                  <a16:creationId xmlns:a16="http://schemas.microsoft.com/office/drawing/2014/main" id="{980E2E52-C826-4B80-B1A4-EF165478BC32}"/>
+                </a:ext>
+              </a:extLst>
+            </p:cNvPr>
+            <p:cNvSpPr/>
+            <p:nvPr/>
+          </p:nvSpPr>
+          <p:spPr>
+            <a:xfrm>
+              <a:off x="7976203" y="2484353"/>
+              <a:ext cx="1114418" cy="370347"/>
+            </a:xfrm>
+            <a:prstGeom prst="rect">
+              <a:avLst/>
+            </a:prstGeom>
+            <a:solidFill>
+              <a:srgbClr val="00B0F0"/>
+            </a:solidFill>
+            <a:ln>
+              <a:noFill/>
+            </a:ln>
+            <a:effectLst>
+              <a:outerShdw blurRad="50760" dist="37674" dir="2700000" algn="tl" rotWithShape="0">
+                <a:srgbClr val="000000">
+                  <a:alpha val="40000"/>
+                </a:srgbClr>
+              </a:outerShdw>
+            </a:effectLst>
+          </p:spPr>
+          <p:style>
+            <a:lnRef idx="2">
+              <a:schemeClr val="accent1">
+                <a:shade val="50000"/>
+              </a:schemeClr>
+            </a:lnRef>
+            <a:fillRef idx="1">
+              <a:schemeClr val="accent1"/>
+            </a:fillRef>
+            <a:effectRef idx="0">
+              <a:schemeClr val="accent1"/>
+            </a:effectRef>
+            <a:fontRef idx="minor"/>
+          </p:style>
+          <p:txBody>
+            <a:bodyPr lIns="90000" tIns="45000" rIns="90000" bIns="45000" anchor="ctr">
+              <a:noAutofit/>
+            </a:bodyPr>
+            <a:lstStyle/>
+            <a:p>
+              <a:pPr algn="ctr"/>
+              <a:r>
+                <a:rPr lang="en-IN" sz="1280" spc="-2" dirty="0">
+                  <a:solidFill>
+                    <a:srgbClr val="000000"/>
+                  </a:solidFill>
+                  <a:latin typeface="Arial"/>
+                </a:rPr>
+                <a:t>HDSL</a:t>
+              </a:r>
+            </a:p>
+          </p:txBody>
+        </p:sp>
+        <p:sp>
+          <p:nvSpPr>
+            <p:cNvPr id="55" name="CustomShape 8">
+              <a:extLst>
+                <a:ext uri="{FF2B5EF4-FFF2-40B4-BE49-F238E27FC236}">
+                  <a16:creationId xmlns:a16="http://schemas.microsoft.com/office/drawing/2014/main" id="{94AD24C4-6F29-4547-8CCD-1924B387D323}"/>
+                </a:ext>
+              </a:extLst>
+            </p:cNvPr>
+            <p:cNvSpPr/>
+            <p:nvPr/>
+          </p:nvSpPr>
+          <p:spPr>
+            <a:xfrm>
+              <a:off x="7962195" y="3137625"/>
+              <a:ext cx="1114418" cy="370347"/>
+            </a:xfrm>
+            <a:prstGeom prst="rect">
+              <a:avLst/>
+            </a:prstGeom>
+            <a:solidFill>
+              <a:srgbClr val="00B0F0"/>
+            </a:solidFill>
+            <a:ln>
+              <a:noFill/>
+            </a:ln>
+            <a:effectLst>
+              <a:outerShdw blurRad="50760" dist="37674" dir="2700000" algn="tl" rotWithShape="0">
+                <a:srgbClr val="000000">
+                  <a:alpha val="40000"/>
+                </a:srgbClr>
+              </a:outerShdw>
+            </a:effectLst>
+          </p:spPr>
+          <p:style>
+            <a:lnRef idx="2">
+              <a:schemeClr val="accent1">
+                <a:shade val="50000"/>
+              </a:schemeClr>
+            </a:lnRef>
+            <a:fillRef idx="1">
+              <a:schemeClr val="accent1"/>
+            </a:fillRef>
+            <a:effectRef idx="0">
+              <a:schemeClr val="accent1"/>
+            </a:effectRef>
+            <a:fontRef idx="minor"/>
+          </p:style>
+          <p:txBody>
+            <a:bodyPr lIns="90000" tIns="45000" rIns="90000" bIns="45000" anchor="ctr">
+              <a:noAutofit/>
+            </a:bodyPr>
+            <a:lstStyle/>
+            <a:p>
+              <a:pPr algn="ctr"/>
+              <a:r>
+                <a:rPr lang="en-IN" sz="1280" spc="-2" dirty="0">
+                  <a:solidFill>
+                    <a:srgbClr val="000000"/>
+                  </a:solidFill>
+                  <a:latin typeface="Arial"/>
+                </a:rPr>
+                <a:t>Nikon A-Format</a:t>
+              </a:r>
+            </a:p>
+          </p:txBody>
+        </p:sp>
+        <p:sp>
+          <p:nvSpPr>
+            <p:cNvPr id="56" name="CustomShape 8">
+              <a:extLst>
+                <a:ext uri="{FF2B5EF4-FFF2-40B4-BE49-F238E27FC236}">
+                  <a16:creationId xmlns:a16="http://schemas.microsoft.com/office/drawing/2014/main" id="{786CFDC0-B554-4AE6-9E15-6FBE01A3C35D}"/>
+                </a:ext>
+              </a:extLst>
+            </p:cNvPr>
+            <p:cNvSpPr/>
+            <p:nvPr/>
+          </p:nvSpPr>
+          <p:spPr>
+            <a:xfrm>
+              <a:off x="7976203" y="1177283"/>
+              <a:ext cx="1114418" cy="370347"/>
+            </a:xfrm>
+            <a:prstGeom prst="rect">
+              <a:avLst/>
+            </a:prstGeom>
+            <a:solidFill>
+              <a:srgbClr val="00B0F0"/>
+            </a:solidFill>
+            <a:ln>
+              <a:noFill/>
+            </a:ln>
+            <a:effectLst>
+              <a:outerShdw blurRad="50760" dist="37674" dir="2700000" algn="tl" rotWithShape="0">
+                <a:srgbClr val="000000">
+                  <a:alpha val="40000"/>
+                </a:srgbClr>
+              </a:outerShdw>
+            </a:effectLst>
+          </p:spPr>
+          <p:style>
+            <a:lnRef idx="2">
+              <a:schemeClr val="accent1">
+                <a:shade val="50000"/>
+              </a:schemeClr>
+            </a:lnRef>
+            <a:fillRef idx="1">
+              <a:schemeClr val="accent1"/>
+            </a:fillRef>
+            <a:effectRef idx="0">
+              <a:schemeClr val="accent1"/>
+            </a:effectRef>
+            <a:fontRef idx="minor"/>
+          </p:style>
+          <p:txBody>
+            <a:bodyPr lIns="90000" tIns="45000" rIns="90000" bIns="45000" anchor="ctr">
+              <a:noAutofit/>
+            </a:bodyPr>
+            <a:lstStyle/>
+            <a:p>
+              <a:pPr algn="ctr"/>
+              <a:r>
+                <a:rPr lang="en-IN" sz="1280" spc="-2" dirty="0">
+                  <a:solidFill>
+                    <a:srgbClr val="000000"/>
+                  </a:solidFill>
+                  <a:latin typeface="Arial"/>
+                </a:rPr>
+                <a:t>BiSS-C</a:t>
+              </a:r>
+            </a:p>
+          </p:txBody>
+        </p:sp>
+      </p:grpSp>
+      <p:sp>
+        <p:nvSpPr>
+          <p:cNvPr id="57" name="CustomShape 8">
+            <a:extLst>
+              <a:ext uri="{FF2B5EF4-FFF2-40B4-BE49-F238E27FC236}">
+                <a16:creationId xmlns:a16="http://schemas.microsoft.com/office/drawing/2014/main" id="{D798A839-FA43-43D6-9B44-013BA7192AA1}"/>
+              </a:ext>
+            </a:extLst>
+          </p:cNvPr>
+          <p:cNvSpPr/>
+          <p:nvPr/>
+        </p:nvSpPr>
+        <p:spPr>
+          <a:xfrm>
+            <a:off x="4997630" y="2641531"/>
+            <a:ext cx="1052746" cy="449640"/>
+          </a:xfrm>
+          <a:prstGeom prst="rect">
+            <a:avLst/>
+          </a:prstGeom>
+          <a:solidFill>
+            <a:srgbClr val="92D050"/>
+          </a:solidFill>
+          <a:ln>
+            <a:noFill/>
+          </a:ln>
+          <a:effectLst>
+            <a:outerShdw blurRad="50760" dist="37674" dir="2700000" algn="tl" rotWithShape="0">
+              <a:srgbClr val="000000">
+                <a:alpha val="40000"/>
+              </a:srgbClr>
+            </a:outerShdw>
+          </a:effectLst>
+        </p:spPr>
+        <p:style>
+          <a:lnRef idx="2">
+            <a:schemeClr val="accent1">
+              <a:shade val="50000"/>
+            </a:schemeClr>
+          </a:lnRef>
+          <a:fillRef idx="1">
+            <a:schemeClr val="accent1"/>
+          </a:fillRef>
+          <a:effectRef idx="0">
+            <a:schemeClr val="accent1"/>
+          </a:effectRef>
+          <a:fontRef idx="minor"/>
+        </p:style>
+        <p:txBody>
+          <a:bodyPr lIns="90000" tIns="45000" rIns="90000" bIns="45000" anchor="ctr">
+            <a:noAutofit/>
+          </a:bodyPr>
+          <a:lstStyle/>
+          <a:p>
+            <a:pPr algn="ctr"/>
+            <a:r>
+              <a:rPr lang="en-IN" sz="1280" spc="-2" dirty="0">
+                <a:solidFill>
+                  <a:srgbClr val="000000"/>
+                </a:solidFill>
+                <a:latin typeface="Arial"/>
+              </a:rPr>
+              <a:t>EtherNet/IP</a:t>
+            </a:r>
+          </a:p>
+        </p:txBody>
+      </p:sp>
+      <p:sp>
+        <p:nvSpPr>
+          <p:cNvPr id="58" name="CustomShape 8">
+            <a:extLst>
+              <a:ext uri="{FF2B5EF4-FFF2-40B4-BE49-F238E27FC236}">
+                <a16:creationId xmlns:a16="http://schemas.microsoft.com/office/drawing/2014/main" id="{F5AC420F-1776-463C-8A04-434D48B15D33}"/>
+              </a:ext>
+            </a:extLst>
+          </p:cNvPr>
+          <p:cNvSpPr/>
+          <p:nvPr/>
+        </p:nvSpPr>
+        <p:spPr>
+          <a:xfrm>
+            <a:off x="6363658" y="2632443"/>
+            <a:ext cx="1052746" cy="449640"/>
+          </a:xfrm>
+          <a:prstGeom prst="rect">
+            <a:avLst/>
+          </a:prstGeom>
+          <a:solidFill>
+            <a:srgbClr val="92D050"/>
+          </a:solidFill>
+          <a:ln>
+            <a:noFill/>
+          </a:ln>
+          <a:effectLst>
+            <a:outerShdw blurRad="50760" dist="37674" dir="2700000" algn="tl" rotWithShape="0">
+              <a:srgbClr val="000000">
+                <a:alpha val="40000"/>
+              </a:srgbClr>
+            </a:outerShdw>
+          </a:effectLst>
+        </p:spPr>
+        <p:style>
+          <a:lnRef idx="2">
+            <a:schemeClr val="accent1">
+              <a:shade val="50000"/>
+            </a:schemeClr>
+          </a:lnRef>
+          <a:fillRef idx="1">
+            <a:schemeClr val="accent1"/>
+          </a:fillRef>
+          <a:effectRef idx="0">
+            <a:schemeClr val="accent1"/>
+          </a:effectRef>
+          <a:fontRef idx="minor"/>
+        </p:style>
+        <p:txBody>
+          <a:bodyPr lIns="90000" tIns="45000" rIns="90000" bIns="45000" anchor="ctr">
+            <a:noAutofit/>
+          </a:bodyPr>
+          <a:lstStyle/>
+          <a:p>
+            <a:pPr algn="ctr"/>
+            <a:r>
+              <a:rPr lang="en-IN" sz="1280" spc="-2" dirty="0">
+                <a:solidFill>
+                  <a:srgbClr val="000000"/>
+                </a:solidFill>
+                <a:latin typeface="Arial"/>
+              </a:rPr>
+              <a:t>IOLINK</a:t>
+            </a:r>
+          </a:p>
+        </p:txBody>
+      </p:sp>
+      <p:grpSp>
+        <p:nvGrpSpPr>
+          <p:cNvPr id="60" name="Group 59">
+            <a:extLst>
+              <a:ext uri="{FF2B5EF4-FFF2-40B4-BE49-F238E27FC236}">
+                <a16:creationId xmlns:a16="http://schemas.microsoft.com/office/drawing/2014/main" id="{D1CF6A8E-81FC-43B5-91CD-15C96B3711AD}"/>
+              </a:ext>
+            </a:extLst>
+          </p:cNvPr>
+          <p:cNvGrpSpPr/>
+          <p:nvPr/>
+        </p:nvGrpSpPr>
+        <p:grpSpPr>
+          <a:xfrm>
+            <a:off x="1846518" y="4317636"/>
+            <a:ext cx="5750763" cy="489936"/>
+            <a:chOff x="1963773" y="1577028"/>
+            <a:chExt cx="5750763" cy="489936"/>
+          </a:xfrm>
+        </p:grpSpPr>
+        <p:sp>
+          <p:nvSpPr>
+            <p:cNvPr id="61" name="CustomShape 24">
+              <a:extLst>
+                <a:ext uri="{FF2B5EF4-FFF2-40B4-BE49-F238E27FC236}">
+                  <a16:creationId xmlns:a16="http://schemas.microsoft.com/office/drawing/2014/main" id="{53FCD6D3-9AD4-4E4D-8472-F54472750528}"/>
+                </a:ext>
+              </a:extLst>
+            </p:cNvPr>
+            <p:cNvSpPr/>
+            <p:nvPr/>
+          </p:nvSpPr>
+          <p:spPr>
+            <a:xfrm>
+              <a:off x="1963773" y="1594157"/>
+              <a:ext cx="1031760" cy="448541"/>
+            </a:xfrm>
+            <a:prstGeom prst="rect">
+              <a:avLst/>
+            </a:prstGeom>
+            <a:solidFill>
+              <a:schemeClr val="bg2"/>
+            </a:solidFill>
+            <a:ln>
+              <a:noFill/>
+            </a:ln>
+            <a:effectLst>
+              <a:outerShdw blurRad="50760" dist="37674" dir="2700000" algn="tl" rotWithShape="0">
+                <a:srgbClr val="000000">
+                  <a:alpha val="40000"/>
+                </a:srgbClr>
+              </a:outerShdw>
+            </a:effectLst>
+          </p:spPr>
+          <p:style>
+            <a:lnRef idx="2">
+              <a:schemeClr val="accent1">
+                <a:shade val="50000"/>
+              </a:schemeClr>
+            </a:lnRef>
+            <a:fillRef idx="1">
+              <a:schemeClr val="accent1"/>
+            </a:fillRef>
+            <a:effectRef idx="0">
+              <a:schemeClr val="accent1"/>
+            </a:effectRef>
+            <a:fontRef idx="minor"/>
+          </p:style>
+          <p:txBody>
+            <a:bodyPr lIns="90000" tIns="45000" rIns="90000" bIns="45000" anchor="ctr">
+              <a:noAutofit/>
+            </a:bodyPr>
+            <a:lstStyle/>
+            <a:p>
+              <a:pPr algn="ctr"/>
+              <a:r>
+                <a:rPr lang="en-US" sz="1280" spc="-2" dirty="0">
+                  <a:solidFill>
+                    <a:srgbClr val="FFFFFF"/>
+                  </a:solidFill>
+                  <a:latin typeface="Arial"/>
+                </a:rPr>
+                <a:t>SOC Peripheral</a:t>
+              </a:r>
+              <a:endParaRPr lang="en-IN" sz="1280" spc="-2" dirty="0">
+                <a:solidFill>
+                  <a:srgbClr val="FFFFFF"/>
+                </a:solidFill>
+                <a:latin typeface="Arial"/>
+              </a:endParaRPr>
+            </a:p>
+          </p:txBody>
+        </p:sp>
+        <p:grpSp>
+          <p:nvGrpSpPr>
+            <p:cNvPr id="62" name="Group 61">
+              <a:extLst>
+                <a:ext uri="{FF2B5EF4-FFF2-40B4-BE49-F238E27FC236}">
+                  <a16:creationId xmlns:a16="http://schemas.microsoft.com/office/drawing/2014/main" id="{B0B78FDD-639E-4C75-BDED-5733B237707E}"/>
+                </a:ext>
+              </a:extLst>
+            </p:cNvPr>
+            <p:cNvGrpSpPr/>
+            <p:nvPr/>
+          </p:nvGrpSpPr>
+          <p:grpSpPr>
+            <a:xfrm>
+              <a:off x="3141326" y="1577028"/>
+              <a:ext cx="4573210" cy="489936"/>
+              <a:chOff x="3141326" y="1577028"/>
+              <a:chExt cx="4573210" cy="489936"/>
+            </a:xfrm>
+          </p:grpSpPr>
+          <p:sp>
+            <p:nvSpPr>
+              <p:cNvPr id="63" name="CustomShape 15">
+                <a:extLst>
+                  <a:ext uri="{FF2B5EF4-FFF2-40B4-BE49-F238E27FC236}">
+                    <a16:creationId xmlns:a16="http://schemas.microsoft.com/office/drawing/2014/main" id="{8CC10D8F-E662-40FF-B96F-632AFB9532F3}"/>
+                  </a:ext>
+                </a:extLst>
+              </p:cNvPr>
+              <p:cNvSpPr/>
+              <p:nvPr/>
+            </p:nvSpPr>
+            <p:spPr>
+              <a:xfrm>
+                <a:off x="5454077" y="1577836"/>
+                <a:ext cx="1031759" cy="489128"/>
+              </a:xfrm>
+              <a:prstGeom prst="rect">
+                <a:avLst/>
+              </a:prstGeom>
+              <a:solidFill>
+                <a:srgbClr val="00B0F0"/>
+              </a:solidFill>
+              <a:ln>
+                <a:noFill/>
+              </a:ln>
+              <a:effectLst>
+                <a:outerShdw blurRad="50760" dist="37674" dir="2700000" algn="tl" rotWithShape="0">
+                  <a:srgbClr val="000000">
+                    <a:alpha val="40000"/>
+                  </a:srgbClr>
+                </a:outerShdw>
+              </a:effectLst>
+            </p:spPr>
+            <p:style>
+              <a:lnRef idx="2">
+                <a:schemeClr val="accent1">
+                  <a:shade val="50000"/>
+                </a:schemeClr>
+              </a:lnRef>
+              <a:fillRef idx="1">
+                <a:schemeClr val="accent1"/>
+              </a:fillRef>
+              <a:effectRef idx="0">
+                <a:schemeClr val="accent1"/>
+              </a:effectRef>
+              <a:fontRef idx="minor"/>
+            </p:style>
+            <p:txBody>
+              <a:bodyPr lIns="90000" tIns="45000" rIns="90000" bIns="45000" anchor="ctr">
+                <a:noAutofit/>
+              </a:bodyPr>
+              <a:lstStyle/>
+              <a:p>
+                <a:pPr algn="ctr"/>
+                <a:r>
+                  <a:rPr lang="en-US" sz="1280" spc="-2" dirty="0">
+                    <a:solidFill>
+                      <a:srgbClr val="000000"/>
+                    </a:solidFill>
+                  </a:rPr>
+                  <a:t>Nikon</a:t>
+                </a:r>
+              </a:p>
+              <a:p>
+                <a:pPr algn="ctr"/>
+                <a:r>
+                  <a:rPr lang="en-US" sz="1280" spc="-2" dirty="0">
+                    <a:solidFill>
+                      <a:srgbClr val="000000"/>
+                    </a:solidFill>
+                    <a:latin typeface="Arial"/>
+                  </a:rPr>
+                  <a:t>A-Format</a:t>
+                </a:r>
+                <a:endParaRPr lang="en-IN" sz="1280" spc="-2" dirty="0">
+                  <a:solidFill>
+                    <a:srgbClr val="000000"/>
+                  </a:solidFill>
+                  <a:latin typeface="Arial"/>
+                </a:endParaRPr>
+              </a:p>
+            </p:txBody>
+          </p:sp>
+          <p:sp>
+            <p:nvSpPr>
+              <p:cNvPr id="64" name="CustomShape 8">
+                <a:extLst>
+                  <a:ext uri="{FF2B5EF4-FFF2-40B4-BE49-F238E27FC236}">
+                    <a16:creationId xmlns:a16="http://schemas.microsoft.com/office/drawing/2014/main" id="{DC61F9FB-ACE8-41DA-B31A-550723C32288}"/>
+                  </a:ext>
+                </a:extLst>
+              </p:cNvPr>
+              <p:cNvSpPr/>
+              <p:nvPr/>
+            </p:nvSpPr>
+            <p:spPr>
+              <a:xfrm>
+                <a:off x="4309019" y="1577836"/>
+                <a:ext cx="1012511" cy="474753"/>
+              </a:xfrm>
+              <a:prstGeom prst="rect">
+                <a:avLst/>
+              </a:prstGeom>
+              <a:solidFill>
+                <a:srgbClr val="00B0F0"/>
+              </a:solidFill>
+              <a:ln>
+                <a:noFill/>
+              </a:ln>
+              <a:effectLst>
+                <a:outerShdw blurRad="50760" dist="37674" dir="2700000" algn="tl" rotWithShape="0">
+                  <a:srgbClr val="000000">
+                    <a:alpha val="40000"/>
+                  </a:srgbClr>
+                </a:outerShdw>
+              </a:effectLst>
+            </p:spPr>
+            <p:style>
+              <a:lnRef idx="2">
+                <a:schemeClr val="accent1">
+                  <a:shade val="50000"/>
+                </a:schemeClr>
+              </a:lnRef>
+              <a:fillRef idx="1">
+                <a:schemeClr val="accent1"/>
+              </a:fillRef>
+              <a:effectRef idx="0">
+                <a:schemeClr val="accent1"/>
+              </a:effectRef>
+              <a:fontRef idx="minor"/>
+            </p:style>
+            <p:txBody>
+              <a:bodyPr lIns="90000" tIns="45000" rIns="90000" bIns="45000" anchor="ctr">
+                <a:noAutofit/>
+              </a:bodyPr>
+              <a:lstStyle/>
+              <a:p>
+                <a:pPr algn="ctr"/>
+                <a:r>
+                  <a:rPr lang="en-IN" sz="1280" spc="-2" dirty="0">
+                    <a:solidFill>
+                      <a:srgbClr val="000000"/>
+                    </a:solidFill>
+                    <a:latin typeface="Arial"/>
+                  </a:rPr>
+                  <a:t>HDSL</a:t>
+                </a:r>
+              </a:p>
+            </p:txBody>
+          </p:sp>
+          <p:sp>
+            <p:nvSpPr>
+              <p:cNvPr id="65" name="CustomShape 15">
+                <a:extLst>
+                  <a:ext uri="{FF2B5EF4-FFF2-40B4-BE49-F238E27FC236}">
+                    <a16:creationId xmlns:a16="http://schemas.microsoft.com/office/drawing/2014/main" id="{C3CD25CC-7DB8-4D0B-86FE-9377D8AA4106}"/>
+                  </a:ext>
+                </a:extLst>
+              </p:cNvPr>
+              <p:cNvSpPr/>
+              <p:nvPr/>
+            </p:nvSpPr>
+            <p:spPr>
+              <a:xfrm>
+                <a:off x="6686355" y="1577028"/>
+                <a:ext cx="1028181" cy="474753"/>
+              </a:xfrm>
+              <a:prstGeom prst="rect">
+                <a:avLst/>
+              </a:prstGeom>
+              <a:solidFill>
+                <a:srgbClr val="00B0F0"/>
+              </a:solidFill>
+              <a:ln>
+                <a:noFill/>
+              </a:ln>
+              <a:effectLst>
+                <a:outerShdw blurRad="50760" dist="37674" dir="2700000" algn="tl" rotWithShape="0">
+                  <a:srgbClr val="000000">
+                    <a:alpha val="40000"/>
+                  </a:srgbClr>
+                </a:outerShdw>
+              </a:effectLst>
+            </p:spPr>
+            <p:style>
+              <a:lnRef idx="2">
+                <a:schemeClr val="accent1">
+                  <a:shade val="50000"/>
+                </a:schemeClr>
+              </a:lnRef>
+              <a:fillRef idx="1">
+                <a:schemeClr val="accent1"/>
+              </a:fillRef>
+              <a:effectRef idx="0">
+                <a:schemeClr val="accent1"/>
+              </a:effectRef>
+              <a:fontRef idx="minor"/>
+            </p:style>
+            <p:txBody>
+              <a:bodyPr wrap="none" lIns="90000" tIns="45000" rIns="90000" bIns="45000" anchor="ctr">
+                <a:noAutofit/>
+              </a:bodyPr>
+              <a:lstStyle/>
+              <a:p>
+                <a:pPr algn="ctr"/>
+                <a:r>
+                  <a:rPr lang="en-IN" sz="1280" spc="-2" dirty="0">
+                    <a:solidFill>
+                      <a:srgbClr val="000000"/>
+                    </a:solidFill>
+                    <a:latin typeface="Arial"/>
+                  </a:rPr>
+                  <a:t>Tamagawa</a:t>
+                </a:r>
+              </a:p>
+            </p:txBody>
+          </p:sp>
+          <p:sp>
+            <p:nvSpPr>
+              <p:cNvPr id="66" name="CustomShape 8">
+                <a:extLst>
+                  <a:ext uri="{FF2B5EF4-FFF2-40B4-BE49-F238E27FC236}">
+                    <a16:creationId xmlns:a16="http://schemas.microsoft.com/office/drawing/2014/main" id="{9F0A6602-DFCC-4E1C-8AAF-B741A559F22A}"/>
+                  </a:ext>
+                </a:extLst>
+              </p:cNvPr>
+              <p:cNvSpPr/>
+              <p:nvPr/>
+            </p:nvSpPr>
+            <p:spPr>
+              <a:xfrm>
+                <a:off x="3141326" y="1583042"/>
+                <a:ext cx="1031760" cy="464863"/>
+              </a:xfrm>
+              <a:prstGeom prst="rect">
+                <a:avLst/>
+              </a:prstGeom>
+              <a:solidFill>
+                <a:srgbClr val="808080"/>
+              </a:solidFill>
+              <a:ln>
+                <a:noFill/>
+              </a:ln>
+              <a:effectLst>
+                <a:outerShdw blurRad="50760" dist="37674" dir="2700000" algn="tl" rotWithShape="0">
+                  <a:srgbClr val="000000">
+                    <a:alpha val="40000"/>
+                  </a:srgbClr>
+                </a:outerShdw>
+              </a:effectLst>
+            </p:spPr>
+            <p:style>
+              <a:lnRef idx="2">
+                <a:schemeClr val="accent1">
+                  <a:shade val="50000"/>
+                </a:schemeClr>
+              </a:lnRef>
+              <a:fillRef idx="1">
+                <a:schemeClr val="accent1"/>
+              </a:fillRef>
+              <a:effectRef idx="0">
+                <a:schemeClr val="accent1"/>
+              </a:effectRef>
+              <a:fontRef idx="minor"/>
+            </p:style>
+            <p:txBody>
+              <a:bodyPr lIns="90000" tIns="45000" rIns="90000" bIns="45000" anchor="ctr">
+                <a:noAutofit/>
+              </a:bodyPr>
+              <a:lstStyle/>
+              <a:p>
+                <a:pPr algn="ctr"/>
+                <a:r>
+                  <a:rPr lang="en-IN" sz="1280" spc="-2" dirty="0">
+                    <a:solidFill>
+                      <a:schemeClr val="bg1"/>
+                    </a:solidFill>
+                    <a:latin typeface="Arial"/>
+                  </a:rPr>
+                  <a:t>ICSS </a:t>
+                </a:r>
+              </a:p>
+              <a:p>
+                <a:pPr algn="ctr"/>
+                <a:r>
+                  <a:rPr lang="en-IN" sz="1280" spc="-2" dirty="0">
+                    <a:solidFill>
+                      <a:schemeClr val="bg1"/>
+                    </a:solidFill>
+                    <a:latin typeface="Arial"/>
+                  </a:rPr>
+                  <a:t>EMAC</a:t>
+                </a:r>
+              </a:p>
+            </p:txBody>
+          </p:sp>
+        </p:grpSp>
+      </p:grpSp>
+      <p:grpSp>
+        <p:nvGrpSpPr>
+          <p:cNvPr id="67" name="Group 66">
+            <a:extLst>
+              <a:ext uri="{FF2B5EF4-FFF2-40B4-BE49-F238E27FC236}">
+                <a16:creationId xmlns:a16="http://schemas.microsoft.com/office/drawing/2014/main" id="{DDDE8890-8368-4050-AA15-67C3B6ED0FA0}"/>
+              </a:ext>
+            </a:extLst>
+          </p:cNvPr>
+          <p:cNvGrpSpPr/>
+          <p:nvPr/>
+        </p:nvGrpSpPr>
+        <p:grpSpPr>
+          <a:xfrm>
+            <a:off x="1846518" y="3699484"/>
+            <a:ext cx="5751316" cy="478788"/>
+            <a:chOff x="1961861" y="936270"/>
+            <a:chExt cx="5751316" cy="478788"/>
+          </a:xfrm>
+        </p:grpSpPr>
+        <p:sp>
+          <p:nvSpPr>
+            <p:cNvPr id="68" name="CustomShape 8">
+              <a:extLst>
+                <a:ext uri="{FF2B5EF4-FFF2-40B4-BE49-F238E27FC236}">
+                  <a16:creationId xmlns:a16="http://schemas.microsoft.com/office/drawing/2014/main" id="{AEAB1A64-5AA7-4050-B2B5-DF1EB16ADEBA}"/>
+                </a:ext>
+              </a:extLst>
+            </p:cNvPr>
+            <p:cNvSpPr/>
+            <p:nvPr/>
+          </p:nvSpPr>
+          <p:spPr>
+            <a:xfrm>
+              <a:off x="1961861" y="936270"/>
+              <a:ext cx="1031758" cy="449641"/>
+            </a:xfrm>
+            <a:prstGeom prst="rect">
+              <a:avLst/>
+            </a:prstGeom>
+            <a:solidFill>
+              <a:schemeClr val="bg2"/>
+            </a:solidFill>
+            <a:ln>
+              <a:noFill/>
+            </a:ln>
+            <a:effectLst>
+              <a:outerShdw blurRad="50760" dist="37674" dir="2700000" algn="tl" rotWithShape="0">
+                <a:srgbClr val="000000">
+                  <a:alpha val="40000"/>
+                </a:srgbClr>
+              </a:outerShdw>
+            </a:effectLst>
+          </p:spPr>
+          <p:style>
+            <a:lnRef idx="2">
+              <a:schemeClr val="accent1">
+                <a:shade val="50000"/>
+              </a:schemeClr>
+            </a:lnRef>
+            <a:fillRef idx="1">
+              <a:schemeClr val="accent1"/>
+            </a:fillRef>
+            <a:effectRef idx="0">
+              <a:schemeClr val="accent1"/>
+            </a:effectRef>
+            <a:fontRef idx="minor"/>
+          </p:style>
+          <p:txBody>
+            <a:bodyPr lIns="90000" tIns="45000" rIns="90000" bIns="45000" anchor="ctr">
+              <a:noAutofit/>
+            </a:bodyPr>
+            <a:lstStyle/>
+            <a:p>
+              <a:pPr algn="ctr"/>
+              <a:r>
+                <a:rPr lang="en-US" sz="1280" spc="-2" dirty="0">
+                  <a:solidFill>
+                    <a:srgbClr val="FFFFFF"/>
+                  </a:solidFill>
+                  <a:latin typeface="Arial"/>
+                </a:rPr>
+                <a:t>Board Peripheral</a:t>
+              </a:r>
+              <a:endParaRPr lang="en-IN" sz="1280" spc="-2" dirty="0">
+                <a:solidFill>
+                  <a:srgbClr val="FFFFFF"/>
+                </a:solidFill>
+                <a:latin typeface="Arial"/>
+              </a:endParaRPr>
+            </a:p>
+          </p:txBody>
+        </p:sp>
+        <p:sp>
+          <p:nvSpPr>
+            <p:cNvPr id="72" name="CustomShape 8">
+              <a:extLst>
+                <a:ext uri="{FF2B5EF4-FFF2-40B4-BE49-F238E27FC236}">
+                  <a16:creationId xmlns:a16="http://schemas.microsoft.com/office/drawing/2014/main" id="{F580071E-2B18-4C88-A14A-DED8BFE56ADC}"/>
+                </a:ext>
+              </a:extLst>
+            </p:cNvPr>
+            <p:cNvSpPr/>
+            <p:nvPr/>
+          </p:nvSpPr>
+          <p:spPr>
+            <a:xfrm>
+              <a:off x="3125816" y="939643"/>
+              <a:ext cx="1031759" cy="455099"/>
+            </a:xfrm>
+            <a:prstGeom prst="rect">
+              <a:avLst/>
+            </a:prstGeom>
+            <a:solidFill>
+              <a:srgbClr val="92D050"/>
+            </a:solidFill>
+            <a:ln>
+              <a:noFill/>
+            </a:ln>
+            <a:effectLst>
+              <a:outerShdw blurRad="50760" dist="37674" dir="2700000" algn="tl" rotWithShape="0">
+                <a:srgbClr val="000000">
+                  <a:alpha val="40000"/>
+                </a:srgbClr>
+              </a:outerShdw>
+            </a:effectLst>
+          </p:spPr>
+          <p:style>
+            <a:lnRef idx="2">
+              <a:schemeClr val="accent1">
+                <a:shade val="50000"/>
+              </a:schemeClr>
+            </a:lnRef>
+            <a:fillRef idx="1">
+              <a:schemeClr val="accent1"/>
+            </a:fillRef>
+            <a:effectRef idx="0">
+              <a:schemeClr val="accent1"/>
+            </a:effectRef>
+            <a:fontRef idx="minor"/>
+          </p:style>
+          <p:txBody>
+            <a:bodyPr lIns="90000" tIns="45000" rIns="90000" bIns="45000" anchor="ctr">
+              <a:noAutofit/>
+            </a:bodyPr>
+            <a:lstStyle/>
+            <a:p>
+              <a:pPr algn="ctr"/>
+              <a:r>
+                <a:rPr lang="en-IN" sz="1280" spc="-2" dirty="0">
+                  <a:solidFill>
+                    <a:srgbClr val="000000"/>
+                  </a:solidFill>
+                  <a:latin typeface="Arial"/>
+                </a:rPr>
+                <a:t>EtherCAT</a:t>
+              </a:r>
+            </a:p>
+            <a:p>
+              <a:pPr algn="ctr"/>
+              <a:r>
+                <a:rPr lang="en-IN" sz="1280" spc="-2" dirty="0">
+                  <a:solidFill>
+                    <a:srgbClr val="000000"/>
+                  </a:solidFill>
+                  <a:latin typeface="Arial"/>
+                </a:rPr>
+                <a:t>FW HAL</a:t>
+              </a:r>
+            </a:p>
+          </p:txBody>
+        </p:sp>
+        <p:sp>
+          <p:nvSpPr>
+            <p:cNvPr id="73" name="CustomShape 8">
+              <a:extLst>
+                <a:ext uri="{FF2B5EF4-FFF2-40B4-BE49-F238E27FC236}">
+                  <a16:creationId xmlns:a16="http://schemas.microsoft.com/office/drawing/2014/main" id="{2A67C791-6F55-47C7-B1A6-7B46FB58B437}"/>
+                </a:ext>
+              </a:extLst>
+            </p:cNvPr>
+            <p:cNvSpPr/>
+            <p:nvPr/>
+          </p:nvSpPr>
+          <p:spPr>
+            <a:xfrm>
+              <a:off x="5441757" y="943439"/>
+              <a:ext cx="1031759" cy="449639"/>
+            </a:xfrm>
+            <a:prstGeom prst="rect">
+              <a:avLst/>
+            </a:prstGeom>
+            <a:solidFill>
+              <a:srgbClr val="00B0F0"/>
+            </a:solidFill>
+            <a:ln>
+              <a:noFill/>
+            </a:ln>
+            <a:effectLst>
+              <a:outerShdw blurRad="50760" dist="37674" dir="2700000" algn="tl" rotWithShape="0">
+                <a:srgbClr val="000000">
+                  <a:alpha val="40000"/>
+                </a:srgbClr>
+              </a:outerShdw>
+            </a:effectLst>
+          </p:spPr>
+          <p:style>
+            <a:lnRef idx="2">
+              <a:schemeClr val="accent1">
+                <a:shade val="50000"/>
+              </a:schemeClr>
+            </a:lnRef>
+            <a:fillRef idx="1">
+              <a:schemeClr val="accent1"/>
+            </a:fillRef>
+            <a:effectRef idx="0">
+              <a:schemeClr val="accent1"/>
+            </a:effectRef>
+            <a:fontRef idx="minor"/>
+          </p:style>
+          <p:txBody>
+            <a:bodyPr lIns="90000" tIns="45000" rIns="90000" bIns="45000" anchor="ctr">
+              <a:noAutofit/>
+            </a:bodyPr>
+            <a:lstStyle/>
+            <a:p>
+              <a:pPr algn="ctr"/>
+              <a:r>
+                <a:rPr lang="en-IN" sz="1280" spc="-2" dirty="0">
+                  <a:solidFill>
+                    <a:srgbClr val="000000"/>
+                  </a:solidFill>
+                  <a:latin typeface="Arial"/>
+                </a:rPr>
+                <a:t>BiSS-C</a:t>
+              </a:r>
+            </a:p>
+          </p:txBody>
+        </p:sp>
+        <p:sp>
+          <p:nvSpPr>
+            <p:cNvPr id="74" name="CustomShape 8">
+              <a:extLst>
+                <a:ext uri="{FF2B5EF4-FFF2-40B4-BE49-F238E27FC236}">
+                  <a16:creationId xmlns:a16="http://schemas.microsoft.com/office/drawing/2014/main" id="{2B228454-BCB9-489B-B719-40B8584D671E}"/>
+                </a:ext>
+              </a:extLst>
+            </p:cNvPr>
+            <p:cNvSpPr/>
+            <p:nvPr/>
+          </p:nvSpPr>
+          <p:spPr>
+            <a:xfrm>
+              <a:off x="6684443" y="936270"/>
+              <a:ext cx="1028734" cy="478788"/>
+            </a:xfrm>
+            <a:prstGeom prst="rect">
+              <a:avLst/>
+            </a:prstGeom>
+            <a:solidFill>
+              <a:srgbClr val="00B0F0"/>
+            </a:solidFill>
+            <a:ln>
+              <a:noFill/>
+            </a:ln>
+            <a:effectLst>
+              <a:outerShdw blurRad="50760" dist="37674" dir="2700000" algn="tl" rotWithShape="0">
+                <a:srgbClr val="000000">
+                  <a:alpha val="40000"/>
+                </a:srgbClr>
+              </a:outerShdw>
+            </a:effectLst>
+          </p:spPr>
+          <p:style>
+            <a:lnRef idx="2">
+              <a:schemeClr val="accent1">
+                <a:shade val="50000"/>
+              </a:schemeClr>
+            </a:lnRef>
+            <a:fillRef idx="1">
+              <a:schemeClr val="accent1"/>
+            </a:fillRef>
+            <a:effectRef idx="0">
+              <a:schemeClr val="accent1"/>
+            </a:effectRef>
+            <a:fontRef idx="minor"/>
+          </p:style>
+          <p:txBody>
+            <a:bodyPr lIns="90000" tIns="45000" rIns="90000" bIns="45000" anchor="ctr">
+              <a:noAutofit/>
+            </a:bodyPr>
+            <a:lstStyle/>
+            <a:p>
+              <a:pPr algn="ctr"/>
+              <a:r>
+                <a:rPr lang="en-US" sz="1280" spc="-2" dirty="0">
+                  <a:solidFill>
+                    <a:srgbClr val="000000"/>
+                  </a:solidFill>
+                </a:rPr>
+                <a:t>EnDat</a:t>
+              </a:r>
+              <a:endParaRPr lang="en-IN" sz="1280" spc="-2" dirty="0">
+                <a:solidFill>
+                  <a:srgbClr val="000000"/>
+                </a:solidFill>
+              </a:endParaRPr>
+            </a:p>
+          </p:txBody>
+        </p:sp>
+        <p:sp>
+          <p:nvSpPr>
+            <p:cNvPr id="75" name="CustomShape 8">
+              <a:extLst>
+                <a:ext uri="{FF2B5EF4-FFF2-40B4-BE49-F238E27FC236}">
+                  <a16:creationId xmlns:a16="http://schemas.microsoft.com/office/drawing/2014/main" id="{F8370D72-890A-416C-8661-621C2D086D65}"/>
+                </a:ext>
+              </a:extLst>
+            </p:cNvPr>
+            <p:cNvSpPr/>
+            <p:nvPr/>
+          </p:nvSpPr>
+          <p:spPr>
+            <a:xfrm>
+              <a:off x="4289771" y="936271"/>
+              <a:ext cx="1031759" cy="474752"/>
+            </a:xfrm>
+            <a:prstGeom prst="rect">
+              <a:avLst/>
+            </a:prstGeom>
+            <a:solidFill>
+              <a:srgbClr val="92D050"/>
+            </a:solidFill>
+            <a:ln>
+              <a:noFill/>
+            </a:ln>
+            <a:effectLst>
+              <a:outerShdw blurRad="50760" dist="37674" dir="2700000" algn="tl" rotWithShape="0">
+                <a:srgbClr val="000000">
+                  <a:alpha val="40000"/>
+                </a:srgbClr>
+              </a:outerShdw>
+            </a:effectLst>
+          </p:spPr>
+          <p:style>
+            <a:lnRef idx="2">
+              <a:schemeClr val="accent1">
+                <a:shade val="50000"/>
+              </a:schemeClr>
+            </a:lnRef>
+            <a:fillRef idx="1">
+              <a:schemeClr val="accent1"/>
+            </a:fillRef>
+            <a:effectRef idx="0">
+              <a:schemeClr val="accent1"/>
+            </a:effectRef>
+            <a:fontRef idx="minor"/>
+          </p:style>
+          <p:txBody>
+            <a:bodyPr lIns="90000" tIns="45000" rIns="90000" bIns="45000" anchor="ctr">
+              <a:noAutofit/>
+            </a:bodyPr>
+            <a:lstStyle/>
+            <a:p>
+              <a:pPr algn="ctr"/>
+              <a:r>
+                <a:rPr lang="en-IN" sz="1280" spc="-2" dirty="0">
+                  <a:solidFill>
+                    <a:srgbClr val="000000"/>
+                  </a:solidFill>
+                  <a:latin typeface="Arial"/>
+                </a:rPr>
+                <a:t>EtherNet/IP</a:t>
+              </a:r>
+            </a:p>
+            <a:p>
+              <a:pPr algn="ctr"/>
+              <a:r>
+                <a:rPr lang="en-IN" sz="1280" spc="-2" dirty="0">
+                  <a:solidFill>
+                    <a:srgbClr val="000000"/>
+                  </a:solidFill>
+                  <a:latin typeface="Arial"/>
+                </a:rPr>
+                <a:t>FW HAL</a:t>
+              </a:r>
             </a:p>
           </p:txBody>
         </p:sp>

</xml_diff>

<commit_message>
am263px: docs: Update block diagram
- Remove profinet from block diagram

Fixes: PINDSW-9269

Signed-off-by: Dhaval Khandla <dhavaljk@ti.com>
</commit_message>
<xml_diff>
--- a/docs_src/docs/api_guide/images/images.pptx
+++ b/docs_src/docs/api_guide/images/images.pptx
@@ -11486,7 +11486,7 @@
         </p:nvGrpSpPr>
         <p:grpSpPr>
           <a:xfrm>
-            <a:off x="2600111" y="5252523"/>
+            <a:off x="2946446" y="5234693"/>
             <a:ext cx="5721806" cy="867130"/>
             <a:chOff x="1824621" y="5241908"/>
             <a:chExt cx="5721806" cy="867130"/>
@@ -13000,7 +13000,7 @@
         </p:nvSpPr>
         <p:spPr>
           <a:xfrm>
-            <a:off x="2261833" y="2679684"/>
+            <a:off x="2938232" y="2689436"/>
             <a:ext cx="1017301" cy="449641"/>
           </a:xfrm>
           <a:prstGeom prst="rect">
@@ -13085,7 +13085,7 @@
         </p:nvSpPr>
         <p:spPr>
           <a:xfrm>
-            <a:off x="3609198" y="2667525"/>
+            <a:off x="4553852" y="2666627"/>
             <a:ext cx="1035994" cy="449640"/>
           </a:xfrm>
           <a:prstGeom prst="rect">
@@ -13152,7 +13152,7 @@
         </p:nvSpPr>
         <p:spPr>
           <a:xfrm>
-            <a:off x="1894592" y="1612974"/>
+            <a:off x="2960891" y="1622266"/>
             <a:ext cx="903908" cy="393722"/>
           </a:xfrm>
           <a:prstGeom prst="rect">
@@ -13364,10 +13364,10 @@
       </p:sp>
       <p:sp>
         <p:nvSpPr>
-          <p:cNvPr id="48" name="CustomShape 8">
+          <p:cNvPr id="99" name="CustomShape 8">
             <a:extLst>
               <a:ext uri="{FF2B5EF4-FFF2-40B4-BE49-F238E27FC236}">
-                <a16:creationId xmlns:a16="http://schemas.microsoft.com/office/drawing/2014/main" id="{F3F13926-7868-4E7A-AEB6-0A4ECC0A31BA}"/>
+                <a16:creationId xmlns:a16="http://schemas.microsoft.com/office/drawing/2014/main" id="{300ACF90-638E-45E4-AA50-B7E85398CF97}"/>
               </a:ext>
             </a:extLst>
           </p:cNvPr>
@@ -13376,8 +13376,81 @@
         </p:nvSpPr>
         <p:spPr>
           <a:xfrm>
-            <a:off x="3051302" y="1616953"/>
-            <a:ext cx="903908" cy="408049"/>
+            <a:off x="2960891" y="986984"/>
+            <a:ext cx="903906" cy="394687"/>
+          </a:xfrm>
+          <a:prstGeom prst="rect">
+            <a:avLst/>
+          </a:prstGeom>
+          <a:solidFill>
+            <a:schemeClr val="bg2"/>
+          </a:solidFill>
+          <a:ln>
+            <a:noFill/>
+          </a:ln>
+          <a:effectLst>
+            <a:outerShdw blurRad="50760" dist="37674" dir="2700000" algn="tl" rotWithShape="0">
+              <a:srgbClr val="000000">
+                <a:alpha val="40000"/>
+              </a:srgbClr>
+            </a:outerShdw>
+          </a:effectLst>
+        </p:spPr>
+        <p:style>
+          <a:lnRef idx="2">
+            <a:schemeClr val="accent1">
+              <a:shade val="50000"/>
+            </a:schemeClr>
+          </a:lnRef>
+          <a:fillRef idx="1">
+            <a:schemeClr val="accent1"/>
+          </a:fillRef>
+          <a:effectRef idx="0">
+            <a:schemeClr val="accent1"/>
+          </a:effectRef>
+          <a:fontRef idx="minor"/>
+        </p:style>
+        <p:txBody>
+          <a:bodyPr lIns="90000" tIns="45000" rIns="90000" bIns="45000" anchor="ctr">
+            <a:noAutofit/>
+          </a:bodyPr>
+          <a:lstStyle/>
+          <a:p>
+            <a:pPr algn="ctr"/>
+            <a:r>
+              <a:rPr lang="en-US" sz="1200" spc="-2" dirty="0">
+                <a:solidFill>
+                  <a:srgbClr val="FFFFFF"/>
+                </a:solidFill>
+                <a:latin typeface="Arial"/>
+              </a:rPr>
+              <a:t>Examples</a:t>
+            </a:r>
+            <a:endParaRPr lang="en-IN" sz="1200" spc="-2" dirty="0">
+              <a:solidFill>
+                <a:srgbClr val="FFFFFF"/>
+              </a:solidFill>
+              <a:latin typeface="Arial"/>
+            </a:endParaRPr>
+          </a:p>
+        </p:txBody>
+      </p:sp>
+      <p:sp>
+        <p:nvSpPr>
+          <p:cNvPr id="142" name="CustomShape 8">
+            <a:extLst>
+              <a:ext uri="{FF2B5EF4-FFF2-40B4-BE49-F238E27FC236}">
+                <a16:creationId xmlns:a16="http://schemas.microsoft.com/office/drawing/2014/main" id="{84F12E88-D8B0-41DD-AAA0-7C765BE9231D}"/>
+              </a:ext>
+            </a:extLst>
+          </p:cNvPr>
+          <p:cNvSpPr/>
+          <p:nvPr/>
+        </p:nvSpPr>
+        <p:spPr>
+          <a:xfrm>
+            <a:off x="4116749" y="971905"/>
+            <a:ext cx="903907" cy="399478"/>
           </a:xfrm>
           <a:prstGeom prst="rect">
             <a:avLst/>
@@ -13411,7 +13484,7 @@
           <a:fontRef idx="minor"/>
         </p:style>
         <p:txBody>
-          <a:bodyPr wrap="none" lIns="90000" tIns="45000" rIns="90000" bIns="45000" anchor="ctr">
+          <a:bodyPr lIns="90000" tIns="45000" rIns="90000" bIns="45000" anchor="ctr">
             <a:noAutofit/>
           </a:bodyPr>
           <a:lstStyle/>
@@ -13424,17 +13497,17 @@
                 </a:solidFill>
                 <a:latin typeface="Arial"/>
               </a:rPr>
-              <a:t>PROFINET</a:t>
+              <a:t>EtherCAT</a:t>
             </a:r>
           </a:p>
         </p:txBody>
       </p:sp>
       <p:sp>
         <p:nvSpPr>
-          <p:cNvPr id="99" name="CustomShape 8">
+          <p:cNvPr id="70" name="CustomShape 8">
             <a:extLst>
               <a:ext uri="{FF2B5EF4-FFF2-40B4-BE49-F238E27FC236}">
-                <a16:creationId xmlns:a16="http://schemas.microsoft.com/office/drawing/2014/main" id="{300ACF90-638E-45E4-AA50-B7E85398CF97}"/>
+                <a16:creationId xmlns:a16="http://schemas.microsoft.com/office/drawing/2014/main" id="{ACF071DC-726D-42F2-B042-ED4EC811037C}"/>
               </a:ext>
             </a:extLst>
           </p:cNvPr>
@@ -13443,8 +13516,347 @@
         </p:nvSpPr>
         <p:spPr>
           <a:xfrm>
-            <a:off x="1894592" y="977692"/>
-            <a:ext cx="903906" cy="394687"/>
+            <a:off x="6476953" y="945827"/>
+            <a:ext cx="903907" cy="394685"/>
+          </a:xfrm>
+          <a:prstGeom prst="rect">
+            <a:avLst/>
+          </a:prstGeom>
+          <a:solidFill>
+            <a:srgbClr val="00B0F0"/>
+          </a:solidFill>
+          <a:ln>
+            <a:noFill/>
+          </a:ln>
+          <a:effectLst>
+            <a:outerShdw blurRad="50760" dist="37674" dir="2700000" algn="tl" rotWithShape="0">
+              <a:srgbClr val="000000">
+                <a:alpha val="40000"/>
+              </a:srgbClr>
+            </a:outerShdw>
+          </a:effectLst>
+        </p:spPr>
+        <p:style>
+          <a:lnRef idx="2">
+            <a:schemeClr val="accent1">
+              <a:shade val="50000"/>
+            </a:schemeClr>
+          </a:lnRef>
+          <a:fillRef idx="1">
+            <a:schemeClr val="accent1"/>
+          </a:fillRef>
+          <a:effectRef idx="0">
+            <a:schemeClr val="accent1"/>
+          </a:effectRef>
+          <a:fontRef idx="minor"/>
+        </p:style>
+        <p:txBody>
+          <a:bodyPr lIns="90000" tIns="45000" rIns="90000" bIns="45000" anchor="ctr">
+            <a:noAutofit/>
+          </a:bodyPr>
+          <a:lstStyle/>
+          <a:p>
+            <a:pPr algn="ctr"/>
+            <a:r>
+              <a:rPr lang="en-IN" sz="1200" spc="-2" dirty="0">
+                <a:solidFill>
+                  <a:srgbClr val="000000"/>
+                </a:solidFill>
+                <a:latin typeface="Arial"/>
+              </a:rPr>
+              <a:t>BiSS-C</a:t>
+            </a:r>
+          </a:p>
+        </p:txBody>
+      </p:sp>
+      <p:sp>
+        <p:nvSpPr>
+          <p:cNvPr id="45" name="CustomShape 8">
+            <a:extLst>
+              <a:ext uri="{FF2B5EF4-FFF2-40B4-BE49-F238E27FC236}">
+                <a16:creationId xmlns:a16="http://schemas.microsoft.com/office/drawing/2014/main" id="{3D881E8A-9BCF-435B-A691-F10F34FEB88B}"/>
+              </a:ext>
+            </a:extLst>
+          </p:cNvPr>
+          <p:cNvSpPr/>
+          <p:nvPr/>
+        </p:nvSpPr>
+        <p:spPr>
+          <a:xfrm>
+            <a:off x="7644056" y="952083"/>
+            <a:ext cx="901256" cy="420272"/>
+          </a:xfrm>
+          <a:prstGeom prst="rect">
+            <a:avLst/>
+          </a:prstGeom>
+          <a:solidFill>
+            <a:srgbClr val="00B0F0"/>
+          </a:solidFill>
+          <a:ln>
+            <a:noFill/>
+          </a:ln>
+          <a:effectLst>
+            <a:outerShdw blurRad="50760" dist="37674" dir="2700000" algn="tl" rotWithShape="0">
+              <a:srgbClr val="000000">
+                <a:alpha val="40000"/>
+              </a:srgbClr>
+            </a:outerShdw>
+          </a:effectLst>
+        </p:spPr>
+        <p:style>
+          <a:lnRef idx="2">
+            <a:schemeClr val="accent1">
+              <a:shade val="50000"/>
+            </a:schemeClr>
+          </a:lnRef>
+          <a:fillRef idx="1">
+            <a:schemeClr val="accent1"/>
+          </a:fillRef>
+          <a:effectRef idx="0">
+            <a:schemeClr val="accent1"/>
+          </a:effectRef>
+          <a:fontRef idx="minor"/>
+        </p:style>
+        <p:txBody>
+          <a:bodyPr lIns="90000" tIns="45000" rIns="90000" bIns="45000" anchor="ctr">
+            <a:noAutofit/>
+          </a:bodyPr>
+          <a:lstStyle/>
+          <a:p>
+            <a:pPr algn="ctr"/>
+            <a:r>
+              <a:rPr lang="en-US" sz="1200" spc="-2" dirty="0">
+                <a:solidFill>
+                  <a:srgbClr val="000000"/>
+                </a:solidFill>
+              </a:rPr>
+              <a:t>EnDat</a:t>
+            </a:r>
+            <a:endParaRPr lang="en-IN" sz="1200" spc="-2" dirty="0">
+              <a:solidFill>
+                <a:srgbClr val="000000"/>
+              </a:solidFill>
+            </a:endParaRPr>
+          </a:p>
+        </p:txBody>
+      </p:sp>
+      <p:sp>
+        <p:nvSpPr>
+          <p:cNvPr id="49" name="CustomShape 8">
+            <a:extLst>
+              <a:ext uri="{FF2B5EF4-FFF2-40B4-BE49-F238E27FC236}">
+                <a16:creationId xmlns:a16="http://schemas.microsoft.com/office/drawing/2014/main" id="{7128BE07-6182-46ED-8561-79949810231D}"/>
+              </a:ext>
+            </a:extLst>
+          </p:cNvPr>
+          <p:cNvSpPr/>
+          <p:nvPr/>
+        </p:nvSpPr>
+        <p:spPr>
+          <a:xfrm>
+            <a:off x="5302861" y="964592"/>
+            <a:ext cx="901257" cy="416729"/>
+          </a:xfrm>
+          <a:prstGeom prst="rect">
+            <a:avLst/>
+          </a:prstGeom>
+          <a:solidFill>
+            <a:srgbClr val="92D050"/>
+          </a:solidFill>
+          <a:ln>
+            <a:noFill/>
+          </a:ln>
+          <a:effectLst>
+            <a:outerShdw blurRad="50760" dist="37674" dir="2700000" algn="tl" rotWithShape="0">
+              <a:srgbClr val="000000">
+                <a:alpha val="40000"/>
+              </a:srgbClr>
+            </a:outerShdw>
+          </a:effectLst>
+        </p:spPr>
+        <p:style>
+          <a:lnRef idx="2">
+            <a:schemeClr val="accent1">
+              <a:shade val="50000"/>
+            </a:schemeClr>
+          </a:lnRef>
+          <a:fillRef idx="1">
+            <a:schemeClr val="accent1"/>
+          </a:fillRef>
+          <a:effectRef idx="0">
+            <a:schemeClr val="accent1"/>
+          </a:effectRef>
+          <a:fontRef idx="minor"/>
+        </p:style>
+        <p:txBody>
+          <a:bodyPr wrap="none" lIns="90000" tIns="45000" rIns="90000" bIns="45000" anchor="ctr">
+            <a:noAutofit/>
+          </a:bodyPr>
+          <a:lstStyle/>
+          <a:p>
+            <a:pPr algn="ctr"/>
+            <a:r>
+              <a:rPr lang="en-IN" sz="1200" spc="-2" dirty="0">
+                <a:solidFill>
+                  <a:srgbClr val="000000"/>
+                </a:solidFill>
+                <a:latin typeface="Arial"/>
+              </a:rPr>
+              <a:t>EtherNet/IP</a:t>
+            </a:r>
+          </a:p>
+        </p:txBody>
+      </p:sp>
+      <p:sp>
+        <p:nvSpPr>
+          <p:cNvPr id="57" name="CustomShape 8">
+            <a:extLst>
+              <a:ext uri="{FF2B5EF4-FFF2-40B4-BE49-F238E27FC236}">
+                <a16:creationId xmlns:a16="http://schemas.microsoft.com/office/drawing/2014/main" id="{D798A839-FA43-43D6-9B44-013BA7192AA1}"/>
+              </a:ext>
+            </a:extLst>
+          </p:cNvPr>
+          <p:cNvSpPr/>
+          <p:nvPr/>
+        </p:nvSpPr>
+        <p:spPr>
+          <a:xfrm>
+            <a:off x="6136945" y="2689436"/>
+            <a:ext cx="1035994" cy="449640"/>
+          </a:xfrm>
+          <a:prstGeom prst="rect">
+            <a:avLst/>
+          </a:prstGeom>
+          <a:solidFill>
+            <a:srgbClr val="92D050"/>
+          </a:solidFill>
+          <a:ln>
+            <a:noFill/>
+          </a:ln>
+          <a:effectLst>
+            <a:outerShdw blurRad="50760" dist="37674" dir="2700000" algn="tl" rotWithShape="0">
+              <a:srgbClr val="000000">
+                <a:alpha val="40000"/>
+              </a:srgbClr>
+            </a:outerShdw>
+          </a:effectLst>
+        </p:spPr>
+        <p:style>
+          <a:lnRef idx="2">
+            <a:schemeClr val="accent1">
+              <a:shade val="50000"/>
+            </a:schemeClr>
+          </a:lnRef>
+          <a:fillRef idx="1">
+            <a:schemeClr val="accent1"/>
+          </a:fillRef>
+          <a:effectRef idx="0">
+            <a:schemeClr val="accent1"/>
+          </a:effectRef>
+          <a:fontRef idx="minor"/>
+        </p:style>
+        <p:txBody>
+          <a:bodyPr lIns="90000" tIns="45000" rIns="90000" bIns="45000" anchor="ctr">
+            <a:noAutofit/>
+          </a:bodyPr>
+          <a:lstStyle/>
+          <a:p>
+            <a:pPr algn="ctr"/>
+            <a:r>
+              <a:rPr lang="en-IN" sz="1280" spc="-2" dirty="0">
+                <a:solidFill>
+                  <a:srgbClr val="000000"/>
+                </a:solidFill>
+                <a:latin typeface="Arial"/>
+              </a:rPr>
+              <a:t>EtherNet/IP</a:t>
+            </a:r>
+          </a:p>
+        </p:txBody>
+      </p:sp>
+      <p:sp>
+        <p:nvSpPr>
+          <p:cNvPr id="58" name="CustomShape 8">
+            <a:extLst>
+              <a:ext uri="{FF2B5EF4-FFF2-40B4-BE49-F238E27FC236}">
+                <a16:creationId xmlns:a16="http://schemas.microsoft.com/office/drawing/2014/main" id="{F5AC420F-1776-463C-8A04-434D48B15D33}"/>
+              </a:ext>
+            </a:extLst>
+          </p:cNvPr>
+          <p:cNvSpPr/>
+          <p:nvPr/>
+        </p:nvSpPr>
+        <p:spPr>
+          <a:xfrm>
+            <a:off x="7773286" y="2646651"/>
+            <a:ext cx="1035994" cy="449640"/>
+          </a:xfrm>
+          <a:prstGeom prst="rect">
+            <a:avLst/>
+          </a:prstGeom>
+          <a:solidFill>
+            <a:srgbClr val="92D050"/>
+          </a:solidFill>
+          <a:ln>
+            <a:noFill/>
+          </a:ln>
+          <a:effectLst>
+            <a:outerShdw blurRad="50760" dist="37674" dir="2700000" algn="tl" rotWithShape="0">
+              <a:srgbClr val="000000">
+                <a:alpha val="40000"/>
+              </a:srgbClr>
+            </a:outerShdw>
+          </a:effectLst>
+        </p:spPr>
+        <p:style>
+          <a:lnRef idx="2">
+            <a:schemeClr val="accent1">
+              <a:shade val="50000"/>
+            </a:schemeClr>
+          </a:lnRef>
+          <a:fillRef idx="1">
+            <a:schemeClr val="accent1"/>
+          </a:fillRef>
+          <a:effectRef idx="0">
+            <a:schemeClr val="accent1"/>
+          </a:effectRef>
+          <a:fontRef idx="minor"/>
+        </p:style>
+        <p:txBody>
+          <a:bodyPr lIns="90000" tIns="45000" rIns="90000" bIns="45000" anchor="ctr">
+            <a:noAutofit/>
+          </a:bodyPr>
+          <a:lstStyle/>
+          <a:p>
+            <a:pPr algn="ctr"/>
+            <a:r>
+              <a:rPr lang="en-IN" sz="1280" spc="-2" dirty="0">
+                <a:solidFill>
+                  <a:srgbClr val="000000"/>
+                </a:solidFill>
+                <a:latin typeface="Arial"/>
+              </a:rPr>
+              <a:t>IOLINK</a:t>
+            </a:r>
+          </a:p>
+        </p:txBody>
+      </p:sp>
+      <p:sp>
+        <p:nvSpPr>
+          <p:cNvPr id="61" name="CustomShape 24">
+            <a:extLst>
+              <a:ext uri="{FF2B5EF4-FFF2-40B4-BE49-F238E27FC236}">
+                <a16:creationId xmlns:a16="http://schemas.microsoft.com/office/drawing/2014/main" id="{53FCD6D3-9AD4-4E4D-8472-F54472750528}"/>
+              </a:ext>
+            </a:extLst>
+          </p:cNvPr>
+          <p:cNvSpPr/>
+          <p:nvPr/>
+        </p:nvSpPr>
+        <p:spPr>
+          <a:xfrm>
+            <a:off x="2946446" y="4346292"/>
+            <a:ext cx="1031760" cy="448541"/>
           </a:xfrm>
           <a:prstGeom prst="rect">
             <a:avLst/>
@@ -13485,15 +13897,15 @@
           <a:p>
             <a:pPr algn="ctr"/>
             <a:r>
-              <a:rPr lang="en-US" sz="1200" spc="-2" dirty="0">
+              <a:rPr lang="en-US" sz="1280" spc="-2" dirty="0">
                 <a:solidFill>
                   <a:srgbClr val="FFFFFF"/>
                 </a:solidFill>
                 <a:latin typeface="Arial"/>
               </a:rPr>
-              <a:t>Examples</a:t>
-            </a:r>
-            <a:endParaRPr lang="en-IN" sz="1200" spc="-2" dirty="0">
+              <a:t>SOC Peripheral</a:t>
+            </a:r>
+            <a:endParaRPr lang="en-IN" sz="1280" spc="-2" dirty="0">
               <a:solidFill>
                 <a:srgbClr val="FFFFFF"/>
               </a:solidFill>
@@ -13504,10 +13916,10 @@
       </p:sp>
       <p:sp>
         <p:nvSpPr>
-          <p:cNvPr id="142" name="CustomShape 8">
+          <p:cNvPr id="63" name="CustomShape 15">
             <a:extLst>
               <a:ext uri="{FF2B5EF4-FFF2-40B4-BE49-F238E27FC236}">
-                <a16:creationId xmlns:a16="http://schemas.microsoft.com/office/drawing/2014/main" id="{84F12E88-D8B0-41DD-AAA0-7C765BE9231D}"/>
+                <a16:creationId xmlns:a16="http://schemas.microsoft.com/office/drawing/2014/main" id="{8CC10D8F-E662-40FF-B96F-632AFB9532F3}"/>
               </a:ext>
             </a:extLst>
           </p:cNvPr>
@@ -13516,8 +13928,311 @@
         </p:nvSpPr>
         <p:spPr>
           <a:xfrm>
-            <a:off x="3039793" y="973218"/>
-            <a:ext cx="903907" cy="399478"/>
+            <a:off x="6575549" y="4326095"/>
+            <a:ext cx="1031759" cy="489128"/>
+          </a:xfrm>
+          <a:prstGeom prst="rect">
+            <a:avLst/>
+          </a:prstGeom>
+          <a:solidFill>
+            <a:srgbClr val="00B0F0"/>
+          </a:solidFill>
+          <a:ln>
+            <a:noFill/>
+          </a:ln>
+          <a:effectLst>
+            <a:outerShdw blurRad="50760" dist="37674" dir="2700000" algn="tl" rotWithShape="0">
+              <a:srgbClr val="000000">
+                <a:alpha val="40000"/>
+              </a:srgbClr>
+            </a:outerShdw>
+          </a:effectLst>
+        </p:spPr>
+        <p:style>
+          <a:lnRef idx="2">
+            <a:schemeClr val="accent1">
+              <a:shade val="50000"/>
+            </a:schemeClr>
+          </a:lnRef>
+          <a:fillRef idx="1">
+            <a:schemeClr val="accent1"/>
+          </a:fillRef>
+          <a:effectRef idx="0">
+            <a:schemeClr val="accent1"/>
+          </a:effectRef>
+          <a:fontRef idx="minor"/>
+        </p:style>
+        <p:txBody>
+          <a:bodyPr lIns="90000" tIns="45000" rIns="90000" bIns="45000" anchor="ctr">
+            <a:noAutofit/>
+          </a:bodyPr>
+          <a:lstStyle/>
+          <a:p>
+            <a:pPr algn="ctr"/>
+            <a:r>
+              <a:rPr lang="en-US" sz="1280" spc="-2" dirty="0">
+                <a:solidFill>
+                  <a:srgbClr val="000000"/>
+                </a:solidFill>
+              </a:rPr>
+              <a:t>Nikon</a:t>
+            </a:r>
+          </a:p>
+          <a:p>
+            <a:pPr algn="ctr"/>
+            <a:r>
+              <a:rPr lang="en-US" sz="1280" spc="-2" dirty="0">
+                <a:solidFill>
+                  <a:srgbClr val="000000"/>
+                </a:solidFill>
+                <a:latin typeface="Arial"/>
+              </a:rPr>
+              <a:t>A-format</a:t>
+            </a:r>
+            <a:endParaRPr lang="en-IN" sz="1280" spc="-2" dirty="0">
+              <a:solidFill>
+                <a:srgbClr val="000000"/>
+              </a:solidFill>
+              <a:latin typeface="Arial"/>
+            </a:endParaRPr>
+          </a:p>
+        </p:txBody>
+      </p:sp>
+      <p:sp>
+        <p:nvSpPr>
+          <p:cNvPr id="65" name="CustomShape 15">
+            <a:extLst>
+              <a:ext uri="{FF2B5EF4-FFF2-40B4-BE49-F238E27FC236}">
+                <a16:creationId xmlns:a16="http://schemas.microsoft.com/office/drawing/2014/main" id="{C3CD25CC-7DB8-4D0B-86FE-9377D8AA4106}"/>
+              </a:ext>
+            </a:extLst>
+          </p:cNvPr>
+          <p:cNvSpPr/>
+          <p:nvPr/>
+        </p:nvSpPr>
+        <p:spPr>
+          <a:xfrm>
+            <a:off x="7807827" y="4325287"/>
+            <a:ext cx="1028181" cy="474753"/>
+          </a:xfrm>
+          <a:prstGeom prst="rect">
+            <a:avLst/>
+          </a:prstGeom>
+          <a:solidFill>
+            <a:srgbClr val="00B0F0"/>
+          </a:solidFill>
+          <a:ln>
+            <a:noFill/>
+          </a:ln>
+          <a:effectLst>
+            <a:outerShdw blurRad="50760" dist="37674" dir="2700000" algn="tl" rotWithShape="0">
+              <a:srgbClr val="000000">
+                <a:alpha val="40000"/>
+              </a:srgbClr>
+            </a:outerShdw>
+          </a:effectLst>
+        </p:spPr>
+        <p:style>
+          <a:lnRef idx="2">
+            <a:schemeClr val="accent1">
+              <a:shade val="50000"/>
+            </a:schemeClr>
+          </a:lnRef>
+          <a:fillRef idx="1">
+            <a:schemeClr val="accent1"/>
+          </a:fillRef>
+          <a:effectRef idx="0">
+            <a:schemeClr val="accent1"/>
+          </a:effectRef>
+          <a:fontRef idx="minor"/>
+        </p:style>
+        <p:txBody>
+          <a:bodyPr wrap="none" lIns="90000" tIns="45000" rIns="90000" bIns="45000" anchor="ctr">
+            <a:noAutofit/>
+          </a:bodyPr>
+          <a:lstStyle/>
+          <a:p>
+            <a:pPr algn="ctr"/>
+            <a:r>
+              <a:rPr lang="en-IN" sz="1280" spc="-2" dirty="0">
+                <a:solidFill>
+                  <a:srgbClr val="000000"/>
+                </a:solidFill>
+                <a:latin typeface="Arial"/>
+              </a:rPr>
+              <a:t>Tamagawa</a:t>
+            </a:r>
+          </a:p>
+        </p:txBody>
+      </p:sp>
+      <p:sp>
+        <p:nvSpPr>
+          <p:cNvPr id="66" name="CustomShape 8">
+            <a:extLst>
+              <a:ext uri="{FF2B5EF4-FFF2-40B4-BE49-F238E27FC236}">
+                <a16:creationId xmlns:a16="http://schemas.microsoft.com/office/drawing/2014/main" id="{9F0A6602-DFCC-4E1C-8AAF-B741A559F22A}"/>
+              </a:ext>
+            </a:extLst>
+          </p:cNvPr>
+          <p:cNvSpPr/>
+          <p:nvPr/>
+        </p:nvSpPr>
+        <p:spPr>
+          <a:xfrm>
+            <a:off x="4123999" y="4335177"/>
+            <a:ext cx="1031760" cy="464863"/>
+          </a:xfrm>
+          <a:prstGeom prst="rect">
+            <a:avLst/>
+          </a:prstGeom>
+          <a:solidFill>
+            <a:srgbClr val="808080"/>
+          </a:solidFill>
+          <a:ln>
+            <a:noFill/>
+          </a:ln>
+          <a:effectLst>
+            <a:outerShdw blurRad="50760" dist="37674" dir="2700000" algn="tl" rotWithShape="0">
+              <a:srgbClr val="000000">
+                <a:alpha val="40000"/>
+              </a:srgbClr>
+            </a:outerShdw>
+          </a:effectLst>
+        </p:spPr>
+        <p:style>
+          <a:lnRef idx="2">
+            <a:schemeClr val="accent1">
+              <a:shade val="50000"/>
+            </a:schemeClr>
+          </a:lnRef>
+          <a:fillRef idx="1">
+            <a:schemeClr val="accent1"/>
+          </a:fillRef>
+          <a:effectRef idx="0">
+            <a:schemeClr val="accent1"/>
+          </a:effectRef>
+          <a:fontRef idx="minor"/>
+        </p:style>
+        <p:txBody>
+          <a:bodyPr lIns="90000" tIns="45000" rIns="90000" bIns="45000" anchor="ctr">
+            <a:noAutofit/>
+          </a:bodyPr>
+          <a:lstStyle/>
+          <a:p>
+            <a:pPr algn="ctr"/>
+            <a:r>
+              <a:rPr lang="en-IN" sz="1280" spc="-2" dirty="0">
+                <a:solidFill>
+                  <a:schemeClr val="bg1"/>
+                </a:solidFill>
+                <a:latin typeface="Arial"/>
+              </a:rPr>
+              <a:t>ICSS </a:t>
+            </a:r>
+          </a:p>
+          <a:p>
+            <a:pPr algn="ctr"/>
+            <a:r>
+              <a:rPr lang="en-IN" sz="1280" spc="-2" dirty="0">
+                <a:solidFill>
+                  <a:schemeClr val="bg1"/>
+                </a:solidFill>
+                <a:latin typeface="Arial"/>
+              </a:rPr>
+              <a:t>EMAC</a:t>
+            </a:r>
+          </a:p>
+        </p:txBody>
+      </p:sp>
+      <p:sp>
+        <p:nvSpPr>
+          <p:cNvPr id="68" name="CustomShape 8">
+            <a:extLst>
+              <a:ext uri="{FF2B5EF4-FFF2-40B4-BE49-F238E27FC236}">
+                <a16:creationId xmlns:a16="http://schemas.microsoft.com/office/drawing/2014/main" id="{AEAB1A64-5AA7-4050-B2B5-DF1EB16ADEBA}"/>
+              </a:ext>
+            </a:extLst>
+          </p:cNvPr>
+          <p:cNvSpPr/>
+          <p:nvPr/>
+        </p:nvSpPr>
+        <p:spPr>
+          <a:xfrm>
+            <a:off x="2946446" y="3711011"/>
+            <a:ext cx="1031758" cy="449641"/>
+          </a:xfrm>
+          <a:prstGeom prst="rect">
+            <a:avLst/>
+          </a:prstGeom>
+          <a:solidFill>
+            <a:schemeClr val="bg2"/>
+          </a:solidFill>
+          <a:ln>
+            <a:noFill/>
+          </a:ln>
+          <a:effectLst>
+            <a:outerShdw blurRad="50760" dist="37674" dir="2700000" algn="tl" rotWithShape="0">
+              <a:srgbClr val="000000">
+                <a:alpha val="40000"/>
+              </a:srgbClr>
+            </a:outerShdw>
+          </a:effectLst>
+        </p:spPr>
+        <p:style>
+          <a:lnRef idx="2">
+            <a:schemeClr val="accent1">
+              <a:shade val="50000"/>
+            </a:schemeClr>
+          </a:lnRef>
+          <a:fillRef idx="1">
+            <a:schemeClr val="accent1"/>
+          </a:fillRef>
+          <a:effectRef idx="0">
+            <a:schemeClr val="accent1"/>
+          </a:effectRef>
+          <a:fontRef idx="minor"/>
+        </p:style>
+        <p:txBody>
+          <a:bodyPr lIns="90000" tIns="45000" rIns="90000" bIns="45000" anchor="ctr">
+            <a:noAutofit/>
+          </a:bodyPr>
+          <a:lstStyle/>
+          <a:p>
+            <a:pPr algn="ctr"/>
+            <a:r>
+              <a:rPr lang="en-US" sz="1280" spc="-2" dirty="0">
+                <a:solidFill>
+                  <a:srgbClr val="FFFFFF"/>
+                </a:solidFill>
+                <a:latin typeface="Arial"/>
+              </a:rPr>
+              <a:t>Board Peripheral</a:t>
+            </a:r>
+            <a:endParaRPr lang="en-IN" sz="1280" spc="-2" dirty="0">
+              <a:solidFill>
+                <a:srgbClr val="FFFFFF"/>
+              </a:solidFill>
+              <a:latin typeface="Arial"/>
+            </a:endParaRPr>
+          </a:p>
+        </p:txBody>
+      </p:sp>
+      <p:sp>
+        <p:nvSpPr>
+          <p:cNvPr id="72" name="CustomShape 8">
+            <a:extLst>
+              <a:ext uri="{FF2B5EF4-FFF2-40B4-BE49-F238E27FC236}">
+                <a16:creationId xmlns:a16="http://schemas.microsoft.com/office/drawing/2014/main" id="{F580071E-2B18-4C88-A14A-DED8BFE56ADC}"/>
+              </a:ext>
+            </a:extLst>
+          </p:cNvPr>
+          <p:cNvSpPr/>
+          <p:nvPr/>
+        </p:nvSpPr>
+        <p:spPr>
+          <a:xfrm>
+            <a:off x="4110401" y="3714384"/>
+            <a:ext cx="1031759" cy="455099"/>
           </a:xfrm>
           <a:prstGeom prst="rect">
             <a:avLst/>
@@ -13558,23 +14273,35 @@
           <a:p>
             <a:pPr algn="ctr"/>
             <a:r>
-              <a:rPr lang="en-IN" sz="1200" spc="-2" dirty="0">
+              <a:rPr lang="en-IN" sz="1280" spc="-2" dirty="0">
                 <a:solidFill>
                   <a:srgbClr val="000000"/>
                 </a:solidFill>
                 <a:latin typeface="Arial"/>
               </a:rPr>
               <a:t>EtherCAT</a:t>
+            </a:r>
+          </a:p>
+          <a:p>
+            <a:pPr algn="ctr"/>
+            <a:r>
+              <a:rPr lang="en-IN" sz="1280" spc="-2" dirty="0">
+                <a:solidFill>
+                  <a:srgbClr val="000000"/>
+                </a:solidFill>
+                <a:latin typeface="Arial"/>
+              </a:rPr>
+              <a:t>FW HAL</a:t>
             </a:r>
           </a:p>
         </p:txBody>
       </p:sp>
       <p:sp>
         <p:nvSpPr>
-          <p:cNvPr id="70" name="CustomShape 8">
+          <p:cNvPr id="73" name="CustomShape 8">
             <a:extLst>
               <a:ext uri="{FF2B5EF4-FFF2-40B4-BE49-F238E27FC236}">
-                <a16:creationId xmlns:a16="http://schemas.microsoft.com/office/drawing/2014/main" id="{ACF071DC-726D-42F2-B042-ED4EC811037C}"/>
+                <a16:creationId xmlns:a16="http://schemas.microsoft.com/office/drawing/2014/main" id="{2A67C791-6F55-47C7-B1A6-7B46FB58B437}"/>
               </a:ext>
             </a:extLst>
           </p:cNvPr>
@@ -13583,8 +14310,8 @@
         </p:nvSpPr>
         <p:spPr>
           <a:xfrm>
-            <a:off x="6476953" y="945827"/>
-            <a:ext cx="903907" cy="394685"/>
+            <a:off x="6565141" y="3714304"/>
+            <a:ext cx="1031759" cy="449639"/>
           </a:xfrm>
           <a:prstGeom prst="rect">
             <a:avLst/>
@@ -13625,7 +14352,7 @@
           <a:p>
             <a:pPr algn="ctr"/>
             <a:r>
-              <a:rPr lang="en-IN" sz="1200" spc="-2" dirty="0">
+              <a:rPr lang="en-IN" sz="1280" spc="-2" dirty="0">
                 <a:solidFill>
                   <a:srgbClr val="000000"/>
                 </a:solidFill>
@@ -13638,10 +14365,10 @@
       </p:sp>
       <p:sp>
         <p:nvSpPr>
-          <p:cNvPr id="45" name="CustomShape 8">
+          <p:cNvPr id="74" name="CustomShape 8">
             <a:extLst>
               <a:ext uri="{FF2B5EF4-FFF2-40B4-BE49-F238E27FC236}">
-                <a16:creationId xmlns:a16="http://schemas.microsoft.com/office/drawing/2014/main" id="{3D881E8A-9BCF-435B-A691-F10F34FEB88B}"/>
+                <a16:creationId xmlns:a16="http://schemas.microsoft.com/office/drawing/2014/main" id="{2B228454-BCB9-489B-B719-40B8584D671E}"/>
               </a:ext>
             </a:extLst>
           </p:cNvPr>
@@ -13650,8 +14377,8 @@
         </p:nvSpPr>
         <p:spPr>
           <a:xfrm>
-            <a:off x="7644056" y="952083"/>
-            <a:ext cx="901256" cy="420272"/>
+            <a:off x="7807827" y="3707135"/>
+            <a:ext cx="1028734" cy="478788"/>
           </a:xfrm>
           <a:prstGeom prst="rect">
             <a:avLst/>
@@ -13692,14 +14419,14 @@
           <a:p>
             <a:pPr algn="ctr"/>
             <a:r>
-              <a:rPr lang="en-US" sz="1200" spc="-2" dirty="0">
+              <a:rPr lang="en-US" sz="1280" spc="-2" dirty="0">
                 <a:solidFill>
                   <a:srgbClr val="000000"/>
                 </a:solidFill>
               </a:rPr>
               <a:t>EnDat</a:t>
             </a:r>
-            <a:endParaRPr lang="en-IN" sz="1200" spc="-2" dirty="0">
+            <a:endParaRPr lang="en-IN" sz="1280" spc="-2" dirty="0">
               <a:solidFill>
                 <a:srgbClr val="000000"/>
               </a:solidFill>
@@ -13709,10 +14436,10 @@
       </p:sp>
       <p:sp>
         <p:nvSpPr>
-          <p:cNvPr id="49" name="CustomShape 8">
+          <p:cNvPr id="75" name="CustomShape 8">
             <a:extLst>
               <a:ext uri="{FF2B5EF4-FFF2-40B4-BE49-F238E27FC236}">
-                <a16:creationId xmlns:a16="http://schemas.microsoft.com/office/drawing/2014/main" id="{7128BE07-6182-46ED-8561-79949810231D}"/>
+                <a16:creationId xmlns:a16="http://schemas.microsoft.com/office/drawing/2014/main" id="{F8370D72-890A-416C-8661-621C2D086D65}"/>
               </a:ext>
             </a:extLst>
           </p:cNvPr>
@@ -13721,8 +14448,8 @@
         </p:nvSpPr>
         <p:spPr>
           <a:xfrm>
-            <a:off x="4194546" y="954300"/>
-            <a:ext cx="901257" cy="416729"/>
+            <a:off x="5352894" y="3690041"/>
+            <a:ext cx="1031759" cy="474752"/>
           </a:xfrm>
           <a:prstGeom prst="rect">
             <a:avLst/>
@@ -13756,30 +14483,42 @@
           <a:fontRef idx="minor"/>
         </p:style>
         <p:txBody>
-          <a:bodyPr wrap="none" lIns="90000" tIns="45000" rIns="90000" bIns="45000" anchor="ctr">
+          <a:bodyPr lIns="90000" tIns="45000" rIns="90000" bIns="45000" anchor="ctr">
             <a:noAutofit/>
           </a:bodyPr>
           <a:lstStyle/>
           <a:p>
             <a:pPr algn="ctr"/>
             <a:r>
-              <a:rPr lang="en-IN" sz="1200" spc="-2" dirty="0">
+              <a:rPr lang="en-IN" sz="1280" spc="-2" dirty="0">
                 <a:solidFill>
                   <a:srgbClr val="000000"/>
                 </a:solidFill>
                 <a:latin typeface="Arial"/>
               </a:rPr>
               <a:t>EtherNet/IP</a:t>
+            </a:r>
+          </a:p>
+          <a:p>
+            <a:pPr algn="ctr"/>
+            <a:r>
+              <a:rPr lang="en-IN" sz="1280" spc="-2" dirty="0">
+                <a:solidFill>
+                  <a:srgbClr val="000000"/>
+                </a:solidFill>
+                <a:latin typeface="Arial"/>
+              </a:rPr>
+              <a:t>FW HAL</a:t>
             </a:r>
           </a:p>
         </p:txBody>
       </p:sp>
       <p:sp>
         <p:nvSpPr>
-          <p:cNvPr id="57" name="CustomShape 8">
+          <p:cNvPr id="91" name="CustomShape 8">
             <a:extLst>
               <a:ext uri="{FF2B5EF4-FFF2-40B4-BE49-F238E27FC236}">
-                <a16:creationId xmlns:a16="http://schemas.microsoft.com/office/drawing/2014/main" id="{D798A839-FA43-43D6-9B44-013BA7192AA1}"/>
+                <a16:creationId xmlns:a16="http://schemas.microsoft.com/office/drawing/2014/main" id="{8A63F40F-EA38-4A0D-9D2C-F4506ABF8E71}"/>
               </a:ext>
             </a:extLst>
           </p:cNvPr>
@@ -13788,8 +14527,8 @@
         </p:nvSpPr>
         <p:spPr>
           <a:xfrm>
-            <a:off x="5010968" y="2674508"/>
-            <a:ext cx="1035994" cy="449640"/>
+            <a:off x="4153272" y="1622266"/>
+            <a:ext cx="903907" cy="408049"/>
           </a:xfrm>
           <a:prstGeom prst="rect">
             <a:avLst/>
@@ -13830,23 +14569,23 @@
           <a:p>
             <a:pPr algn="ctr"/>
             <a:r>
-              <a:rPr lang="en-IN" sz="1280" spc="-2" dirty="0">
+              <a:rPr lang="en-IN" sz="1200" spc="-2" dirty="0">
                 <a:solidFill>
                   <a:srgbClr val="000000"/>
                 </a:solidFill>
                 <a:latin typeface="Arial"/>
               </a:rPr>
-              <a:t>EtherNet/IP</a:t>
+              <a:t>IOLINK</a:t>
             </a:r>
           </a:p>
         </p:txBody>
       </p:sp>
       <p:sp>
         <p:nvSpPr>
-          <p:cNvPr id="58" name="CustomShape 8">
+          <p:cNvPr id="102" name="CustomShape 8">
             <a:extLst>
               <a:ext uri="{FF2B5EF4-FFF2-40B4-BE49-F238E27FC236}">
-                <a16:creationId xmlns:a16="http://schemas.microsoft.com/office/drawing/2014/main" id="{F5AC420F-1776-463C-8A04-434D48B15D33}"/>
+                <a16:creationId xmlns:a16="http://schemas.microsoft.com/office/drawing/2014/main" id="{4A6996EB-9DD4-4FE9-BEC8-6A591048BBDD}"/>
               </a:ext>
             </a:extLst>
           </p:cNvPr>
@@ -13855,148 +14594,8 @@
         </p:nvSpPr>
         <p:spPr>
           <a:xfrm>
-            <a:off x="7773286" y="2646651"/>
-            <a:ext cx="1035994" cy="449640"/>
-          </a:xfrm>
-          <a:prstGeom prst="rect">
-            <a:avLst/>
-          </a:prstGeom>
-          <a:solidFill>
-            <a:srgbClr val="92D050"/>
-          </a:solidFill>
-          <a:ln>
-            <a:noFill/>
-          </a:ln>
-          <a:effectLst>
-            <a:outerShdw blurRad="50760" dist="37674" dir="2700000" algn="tl" rotWithShape="0">
-              <a:srgbClr val="000000">
-                <a:alpha val="40000"/>
-              </a:srgbClr>
-            </a:outerShdw>
-          </a:effectLst>
-        </p:spPr>
-        <p:style>
-          <a:lnRef idx="2">
-            <a:schemeClr val="accent1">
-              <a:shade val="50000"/>
-            </a:schemeClr>
-          </a:lnRef>
-          <a:fillRef idx="1">
-            <a:schemeClr val="accent1"/>
-          </a:fillRef>
-          <a:effectRef idx="0">
-            <a:schemeClr val="accent1"/>
-          </a:effectRef>
-          <a:fontRef idx="minor"/>
-        </p:style>
-        <p:txBody>
-          <a:bodyPr lIns="90000" tIns="45000" rIns="90000" bIns="45000" anchor="ctr">
-            <a:noAutofit/>
-          </a:bodyPr>
-          <a:lstStyle/>
-          <a:p>
-            <a:pPr algn="ctr"/>
-            <a:r>
-              <a:rPr lang="en-IN" sz="1280" spc="-2" dirty="0">
-                <a:solidFill>
-                  <a:srgbClr val="000000"/>
-                </a:solidFill>
-                <a:latin typeface="Arial"/>
-              </a:rPr>
-              <a:t>IOLINK</a:t>
-            </a:r>
-          </a:p>
-        </p:txBody>
-      </p:sp>
-      <p:sp>
-        <p:nvSpPr>
-          <p:cNvPr id="61" name="CustomShape 24">
-            <a:extLst>
-              <a:ext uri="{FF2B5EF4-FFF2-40B4-BE49-F238E27FC236}">
-                <a16:creationId xmlns:a16="http://schemas.microsoft.com/office/drawing/2014/main" id="{53FCD6D3-9AD4-4E4D-8472-F54472750528}"/>
-              </a:ext>
-            </a:extLst>
-          </p:cNvPr>
-          <p:cNvSpPr/>
-          <p:nvPr/>
-        </p:nvSpPr>
-        <p:spPr>
-          <a:xfrm>
-            <a:off x="1846518" y="4334765"/>
-            <a:ext cx="1031760" cy="448541"/>
-          </a:xfrm>
-          <a:prstGeom prst="rect">
-            <a:avLst/>
-          </a:prstGeom>
-          <a:solidFill>
-            <a:schemeClr val="bg2"/>
-          </a:solidFill>
-          <a:ln>
-            <a:noFill/>
-          </a:ln>
-          <a:effectLst>
-            <a:outerShdw blurRad="50760" dist="37674" dir="2700000" algn="tl" rotWithShape="0">
-              <a:srgbClr val="000000">
-                <a:alpha val="40000"/>
-              </a:srgbClr>
-            </a:outerShdw>
-          </a:effectLst>
-        </p:spPr>
-        <p:style>
-          <a:lnRef idx="2">
-            <a:schemeClr val="accent1">
-              <a:shade val="50000"/>
-            </a:schemeClr>
-          </a:lnRef>
-          <a:fillRef idx="1">
-            <a:schemeClr val="accent1"/>
-          </a:fillRef>
-          <a:effectRef idx="0">
-            <a:schemeClr val="accent1"/>
-          </a:effectRef>
-          <a:fontRef idx="minor"/>
-        </p:style>
-        <p:txBody>
-          <a:bodyPr lIns="90000" tIns="45000" rIns="90000" bIns="45000" anchor="ctr">
-            <a:noAutofit/>
-          </a:bodyPr>
-          <a:lstStyle/>
-          <a:p>
-            <a:pPr algn="ctr"/>
-            <a:r>
-              <a:rPr lang="en-US" sz="1280" spc="-2" dirty="0">
-                <a:solidFill>
-                  <a:srgbClr val="FFFFFF"/>
-                </a:solidFill>
-                <a:latin typeface="Arial"/>
-              </a:rPr>
-              <a:t>SOC Peripheral</a:t>
-            </a:r>
-            <a:endParaRPr lang="en-IN" sz="1280" spc="-2" dirty="0">
-              <a:solidFill>
-                <a:srgbClr val="FFFFFF"/>
-              </a:solidFill>
-              <a:latin typeface="Arial"/>
-            </a:endParaRPr>
-          </a:p>
-        </p:txBody>
-      </p:sp>
-      <p:sp>
-        <p:nvSpPr>
-          <p:cNvPr id="63" name="CustomShape 15">
-            <a:extLst>
-              <a:ext uri="{FF2B5EF4-FFF2-40B4-BE49-F238E27FC236}">
-                <a16:creationId xmlns:a16="http://schemas.microsoft.com/office/drawing/2014/main" id="{8CC10D8F-E662-40FF-B96F-632AFB9532F3}"/>
-              </a:ext>
-            </a:extLst>
-          </p:cNvPr>
-          <p:cNvSpPr/>
-          <p:nvPr/>
-        </p:nvSpPr>
-        <p:spPr>
-          <a:xfrm>
-            <a:off x="6575549" y="4326095"/>
-            <a:ext cx="1031759" cy="489128"/>
+            <a:off x="5309968" y="1570236"/>
+            <a:ext cx="887044" cy="416730"/>
           </a:xfrm>
           <a:prstGeom prst="rect">
             <a:avLst/>
@@ -14037,40 +14636,23 @@
           <a:p>
             <a:pPr algn="ctr"/>
             <a:r>
-              <a:rPr lang="en-US" sz="1280" spc="-2" dirty="0">
-                <a:solidFill>
-                  <a:srgbClr val="000000"/>
-                </a:solidFill>
-              </a:rPr>
-              <a:t>Nikon</a:t>
-            </a:r>
-          </a:p>
-          <a:p>
-            <a:pPr algn="ctr"/>
-            <a:r>
-              <a:rPr lang="en-US" sz="1280" spc="-2" dirty="0">
+              <a:rPr lang="en-IN" sz="1200" spc="-2" dirty="0">
                 <a:solidFill>
                   <a:srgbClr val="000000"/>
                 </a:solidFill>
                 <a:latin typeface="Arial"/>
               </a:rPr>
-              <a:t>A-format</a:t>
-            </a:r>
-            <a:endParaRPr lang="en-IN" sz="1280" spc="-2" dirty="0">
-              <a:solidFill>
-                <a:srgbClr val="000000"/>
-              </a:solidFill>
-              <a:latin typeface="Arial"/>
-            </a:endParaRPr>
+              <a:t>RTLibs</a:t>
+            </a:r>
           </a:p>
         </p:txBody>
       </p:sp>
       <p:sp>
         <p:nvSpPr>
-          <p:cNvPr id="65" name="CustomShape 15">
+          <p:cNvPr id="103" name="CustomShape 8">
             <a:extLst>
               <a:ext uri="{FF2B5EF4-FFF2-40B4-BE49-F238E27FC236}">
-                <a16:creationId xmlns:a16="http://schemas.microsoft.com/office/drawing/2014/main" id="{C3CD25CC-7DB8-4D0B-86FE-9377D8AA4106}"/>
+                <a16:creationId xmlns:a16="http://schemas.microsoft.com/office/drawing/2014/main" id="{5EA3E176-BC57-480C-ACFE-C9A6288FD716}"/>
               </a:ext>
             </a:extLst>
           </p:cNvPr>
@@ -14079,8 +14661,8 @@
         </p:nvSpPr>
         <p:spPr>
           <a:xfrm>
-            <a:off x="7807827" y="4325287"/>
-            <a:ext cx="1028181" cy="474753"/>
+            <a:off x="5362519" y="4318704"/>
+            <a:ext cx="1012511" cy="474753"/>
           </a:xfrm>
           <a:prstGeom prst="rect">
             <a:avLst/>
@@ -14114,73 +14696,6 @@
           <a:fontRef idx="minor"/>
         </p:style>
         <p:txBody>
-          <a:bodyPr wrap="none" lIns="90000" tIns="45000" rIns="90000" bIns="45000" anchor="ctr">
-            <a:noAutofit/>
-          </a:bodyPr>
-          <a:lstStyle/>
-          <a:p>
-            <a:pPr algn="ctr"/>
-            <a:r>
-              <a:rPr lang="en-IN" sz="1280" spc="-2" dirty="0">
-                <a:solidFill>
-                  <a:srgbClr val="000000"/>
-                </a:solidFill>
-                <a:latin typeface="Arial"/>
-              </a:rPr>
-              <a:t>Tamagawa</a:t>
-            </a:r>
-          </a:p>
-        </p:txBody>
-      </p:sp>
-      <p:sp>
-        <p:nvSpPr>
-          <p:cNvPr id="66" name="CustomShape 8">
-            <a:extLst>
-              <a:ext uri="{FF2B5EF4-FFF2-40B4-BE49-F238E27FC236}">
-                <a16:creationId xmlns:a16="http://schemas.microsoft.com/office/drawing/2014/main" id="{9F0A6602-DFCC-4E1C-8AAF-B741A559F22A}"/>
-              </a:ext>
-            </a:extLst>
-          </p:cNvPr>
-          <p:cNvSpPr/>
-          <p:nvPr/>
-        </p:nvSpPr>
-        <p:spPr>
-          <a:xfrm>
-            <a:off x="3024071" y="4323650"/>
-            <a:ext cx="1031760" cy="464863"/>
-          </a:xfrm>
-          <a:prstGeom prst="rect">
-            <a:avLst/>
-          </a:prstGeom>
-          <a:solidFill>
-            <a:srgbClr val="808080"/>
-          </a:solidFill>
-          <a:ln>
-            <a:noFill/>
-          </a:ln>
-          <a:effectLst>
-            <a:outerShdw blurRad="50760" dist="37674" dir="2700000" algn="tl" rotWithShape="0">
-              <a:srgbClr val="000000">
-                <a:alpha val="40000"/>
-              </a:srgbClr>
-            </a:outerShdw>
-          </a:effectLst>
-        </p:spPr>
-        <p:style>
-          <a:lnRef idx="2">
-            <a:schemeClr val="accent1">
-              <a:shade val="50000"/>
-            </a:schemeClr>
-          </a:lnRef>
-          <a:fillRef idx="1">
-            <a:schemeClr val="accent1"/>
-          </a:fillRef>
-          <a:effectRef idx="0">
-            <a:schemeClr val="accent1"/>
-          </a:effectRef>
-          <a:fontRef idx="minor"/>
-        </p:style>
-        <p:txBody>
           <a:bodyPr lIns="90000" tIns="45000" rIns="90000" bIns="45000" anchor="ctr">
             <a:noAutofit/>
           </a:bodyPr>
@@ -14190,749 +14705,21 @@
             <a:r>
               <a:rPr lang="en-IN" sz="1280" spc="-2" dirty="0">
                 <a:solidFill>
-                  <a:schemeClr val="bg1"/>
-                </a:solidFill>
-                <a:latin typeface="Arial"/>
-              </a:rPr>
-              <a:t>ICSS </a:t>
-            </a:r>
-          </a:p>
-          <a:p>
-            <a:pPr algn="ctr"/>
-            <a:r>
-              <a:rPr lang="en-IN" sz="1280" spc="-2" dirty="0">
-                <a:solidFill>
-                  <a:schemeClr val="bg1"/>
-                </a:solidFill>
-                <a:latin typeface="Arial"/>
-              </a:rPr>
-              <a:t>EMAC</a:t>
-            </a:r>
-          </a:p>
-        </p:txBody>
-      </p:sp>
-      <p:sp>
-        <p:nvSpPr>
-          <p:cNvPr id="68" name="CustomShape 8">
-            <a:extLst>
-              <a:ext uri="{FF2B5EF4-FFF2-40B4-BE49-F238E27FC236}">
-                <a16:creationId xmlns:a16="http://schemas.microsoft.com/office/drawing/2014/main" id="{AEAB1A64-5AA7-4050-B2B5-DF1EB16ADEBA}"/>
-              </a:ext>
-            </a:extLst>
-          </p:cNvPr>
-          <p:cNvSpPr/>
-          <p:nvPr/>
-        </p:nvSpPr>
-        <p:spPr>
-          <a:xfrm>
-            <a:off x="1846518" y="3699484"/>
-            <a:ext cx="1031758" cy="449641"/>
-          </a:xfrm>
-          <a:prstGeom prst="rect">
-            <a:avLst/>
-          </a:prstGeom>
-          <a:solidFill>
-            <a:schemeClr val="bg2"/>
-          </a:solidFill>
-          <a:ln>
-            <a:noFill/>
-          </a:ln>
-          <a:effectLst>
-            <a:outerShdw blurRad="50760" dist="37674" dir="2700000" algn="tl" rotWithShape="0">
-              <a:srgbClr val="000000">
-                <a:alpha val="40000"/>
-              </a:srgbClr>
-            </a:outerShdw>
-          </a:effectLst>
-        </p:spPr>
-        <p:style>
-          <a:lnRef idx="2">
-            <a:schemeClr val="accent1">
-              <a:shade val="50000"/>
-            </a:schemeClr>
-          </a:lnRef>
-          <a:fillRef idx="1">
-            <a:schemeClr val="accent1"/>
-          </a:fillRef>
-          <a:effectRef idx="0">
-            <a:schemeClr val="accent1"/>
-          </a:effectRef>
-          <a:fontRef idx="minor"/>
-        </p:style>
-        <p:txBody>
-          <a:bodyPr lIns="90000" tIns="45000" rIns="90000" bIns="45000" anchor="ctr">
-            <a:noAutofit/>
-          </a:bodyPr>
-          <a:lstStyle/>
-          <a:p>
-            <a:pPr algn="ctr"/>
-            <a:r>
-              <a:rPr lang="en-US" sz="1280" spc="-2" dirty="0">
-                <a:solidFill>
-                  <a:srgbClr val="FFFFFF"/>
-                </a:solidFill>
-                <a:latin typeface="Arial"/>
-              </a:rPr>
-              <a:t>Board Peripheral</a:t>
-            </a:r>
-            <a:endParaRPr lang="en-IN" sz="1280" spc="-2" dirty="0">
-              <a:solidFill>
-                <a:srgbClr val="FFFFFF"/>
-              </a:solidFill>
-              <a:latin typeface="Arial"/>
-            </a:endParaRPr>
-          </a:p>
-        </p:txBody>
-      </p:sp>
-      <p:sp>
-        <p:nvSpPr>
-          <p:cNvPr id="72" name="CustomShape 8">
-            <a:extLst>
-              <a:ext uri="{FF2B5EF4-FFF2-40B4-BE49-F238E27FC236}">
-                <a16:creationId xmlns:a16="http://schemas.microsoft.com/office/drawing/2014/main" id="{F580071E-2B18-4C88-A14A-DED8BFE56ADC}"/>
-              </a:ext>
-            </a:extLst>
-          </p:cNvPr>
-          <p:cNvSpPr/>
-          <p:nvPr/>
-        </p:nvSpPr>
-        <p:spPr>
-          <a:xfrm>
-            <a:off x="3010473" y="3702857"/>
-            <a:ext cx="1031759" cy="455099"/>
-          </a:xfrm>
-          <a:prstGeom prst="rect">
-            <a:avLst/>
-          </a:prstGeom>
-          <a:solidFill>
-            <a:srgbClr val="92D050"/>
-          </a:solidFill>
-          <a:ln>
-            <a:noFill/>
-          </a:ln>
-          <a:effectLst>
-            <a:outerShdw blurRad="50760" dist="37674" dir="2700000" algn="tl" rotWithShape="0">
-              <a:srgbClr val="000000">
-                <a:alpha val="40000"/>
-              </a:srgbClr>
-            </a:outerShdw>
-          </a:effectLst>
-        </p:spPr>
-        <p:style>
-          <a:lnRef idx="2">
-            <a:schemeClr val="accent1">
-              <a:shade val="50000"/>
-            </a:schemeClr>
-          </a:lnRef>
-          <a:fillRef idx="1">
-            <a:schemeClr val="accent1"/>
-          </a:fillRef>
-          <a:effectRef idx="0">
-            <a:schemeClr val="accent1"/>
-          </a:effectRef>
-          <a:fontRef idx="minor"/>
-        </p:style>
-        <p:txBody>
-          <a:bodyPr lIns="90000" tIns="45000" rIns="90000" bIns="45000" anchor="ctr">
-            <a:noAutofit/>
-          </a:bodyPr>
-          <a:lstStyle/>
-          <a:p>
-            <a:pPr algn="ctr"/>
-            <a:r>
-              <a:rPr lang="en-IN" sz="1280" spc="-2" dirty="0">
-                <a:solidFill>
-                  <a:srgbClr val="000000"/>
-                </a:solidFill>
-                <a:latin typeface="Arial"/>
-              </a:rPr>
-              <a:t>EtherCAT</a:t>
-            </a:r>
-          </a:p>
-          <a:p>
-            <a:pPr algn="ctr"/>
-            <a:r>
-              <a:rPr lang="en-IN" sz="1280" spc="-2" dirty="0">
-                <a:solidFill>
-                  <a:srgbClr val="000000"/>
-                </a:solidFill>
-                <a:latin typeface="Arial"/>
-              </a:rPr>
-              <a:t>FW HAL</a:t>
-            </a:r>
-          </a:p>
-        </p:txBody>
-      </p:sp>
-      <p:sp>
-        <p:nvSpPr>
-          <p:cNvPr id="73" name="CustomShape 8">
-            <a:extLst>
-              <a:ext uri="{FF2B5EF4-FFF2-40B4-BE49-F238E27FC236}">
-                <a16:creationId xmlns:a16="http://schemas.microsoft.com/office/drawing/2014/main" id="{2A67C791-6F55-47C7-B1A6-7B46FB58B437}"/>
-              </a:ext>
-            </a:extLst>
-          </p:cNvPr>
-          <p:cNvSpPr/>
-          <p:nvPr/>
-        </p:nvSpPr>
-        <p:spPr>
-          <a:xfrm>
-            <a:off x="6565141" y="3714304"/>
-            <a:ext cx="1031759" cy="449639"/>
-          </a:xfrm>
-          <a:prstGeom prst="rect">
-            <a:avLst/>
-          </a:prstGeom>
-          <a:solidFill>
-            <a:srgbClr val="00B0F0"/>
-          </a:solidFill>
-          <a:ln>
-            <a:noFill/>
-          </a:ln>
-          <a:effectLst>
-            <a:outerShdw blurRad="50760" dist="37674" dir="2700000" algn="tl" rotWithShape="0">
-              <a:srgbClr val="000000">
-                <a:alpha val="40000"/>
-              </a:srgbClr>
-            </a:outerShdw>
-          </a:effectLst>
-        </p:spPr>
-        <p:style>
-          <a:lnRef idx="2">
-            <a:schemeClr val="accent1">
-              <a:shade val="50000"/>
-            </a:schemeClr>
-          </a:lnRef>
-          <a:fillRef idx="1">
-            <a:schemeClr val="accent1"/>
-          </a:fillRef>
-          <a:effectRef idx="0">
-            <a:schemeClr val="accent1"/>
-          </a:effectRef>
-          <a:fontRef idx="minor"/>
-        </p:style>
-        <p:txBody>
-          <a:bodyPr lIns="90000" tIns="45000" rIns="90000" bIns="45000" anchor="ctr">
-            <a:noAutofit/>
-          </a:bodyPr>
-          <a:lstStyle/>
-          <a:p>
-            <a:pPr algn="ctr"/>
-            <a:r>
-              <a:rPr lang="en-IN" sz="1280" spc="-2" dirty="0">
-                <a:solidFill>
-                  <a:srgbClr val="000000"/>
-                </a:solidFill>
-                <a:latin typeface="Arial"/>
-              </a:rPr>
-              <a:t>BiSS-C</a:t>
-            </a:r>
-          </a:p>
-        </p:txBody>
-      </p:sp>
-      <p:sp>
-        <p:nvSpPr>
-          <p:cNvPr id="74" name="CustomShape 8">
-            <a:extLst>
-              <a:ext uri="{FF2B5EF4-FFF2-40B4-BE49-F238E27FC236}">
-                <a16:creationId xmlns:a16="http://schemas.microsoft.com/office/drawing/2014/main" id="{2B228454-BCB9-489B-B719-40B8584D671E}"/>
-              </a:ext>
-            </a:extLst>
-          </p:cNvPr>
-          <p:cNvSpPr/>
-          <p:nvPr/>
-        </p:nvSpPr>
-        <p:spPr>
-          <a:xfrm>
-            <a:off x="7807827" y="3707135"/>
-            <a:ext cx="1028734" cy="478788"/>
-          </a:xfrm>
-          <a:prstGeom prst="rect">
-            <a:avLst/>
-          </a:prstGeom>
-          <a:solidFill>
-            <a:srgbClr val="00B0F0"/>
-          </a:solidFill>
-          <a:ln>
-            <a:noFill/>
-          </a:ln>
-          <a:effectLst>
-            <a:outerShdw blurRad="50760" dist="37674" dir="2700000" algn="tl" rotWithShape="0">
-              <a:srgbClr val="000000">
-                <a:alpha val="40000"/>
-              </a:srgbClr>
-            </a:outerShdw>
-          </a:effectLst>
-        </p:spPr>
-        <p:style>
-          <a:lnRef idx="2">
-            <a:schemeClr val="accent1">
-              <a:shade val="50000"/>
-            </a:schemeClr>
-          </a:lnRef>
-          <a:fillRef idx="1">
-            <a:schemeClr val="accent1"/>
-          </a:fillRef>
-          <a:effectRef idx="0">
-            <a:schemeClr val="accent1"/>
-          </a:effectRef>
-          <a:fontRef idx="minor"/>
-        </p:style>
-        <p:txBody>
-          <a:bodyPr lIns="90000" tIns="45000" rIns="90000" bIns="45000" anchor="ctr">
-            <a:noAutofit/>
-          </a:bodyPr>
-          <a:lstStyle/>
-          <a:p>
-            <a:pPr algn="ctr"/>
-            <a:r>
-              <a:rPr lang="en-US" sz="1280" spc="-2" dirty="0">
-                <a:solidFill>
-                  <a:srgbClr val="000000"/>
-                </a:solidFill>
-              </a:rPr>
-              <a:t>EnDat</a:t>
-            </a:r>
-            <a:endParaRPr lang="en-IN" sz="1280" spc="-2" dirty="0">
-              <a:solidFill>
-                <a:srgbClr val="000000"/>
-              </a:solidFill>
-            </a:endParaRPr>
-          </a:p>
-        </p:txBody>
-      </p:sp>
-      <p:sp>
-        <p:nvSpPr>
-          <p:cNvPr id="75" name="CustomShape 8">
-            <a:extLst>
-              <a:ext uri="{FF2B5EF4-FFF2-40B4-BE49-F238E27FC236}">
-                <a16:creationId xmlns:a16="http://schemas.microsoft.com/office/drawing/2014/main" id="{F8370D72-890A-416C-8661-621C2D086D65}"/>
-              </a:ext>
-            </a:extLst>
-          </p:cNvPr>
-          <p:cNvSpPr/>
-          <p:nvPr/>
-        </p:nvSpPr>
-        <p:spPr>
-          <a:xfrm>
-            <a:off x="4174428" y="3699485"/>
-            <a:ext cx="1031759" cy="474752"/>
-          </a:xfrm>
-          <a:prstGeom prst="rect">
-            <a:avLst/>
-          </a:prstGeom>
-          <a:solidFill>
-            <a:srgbClr val="92D050"/>
-          </a:solidFill>
-          <a:ln>
-            <a:noFill/>
-          </a:ln>
-          <a:effectLst>
-            <a:outerShdw blurRad="50760" dist="37674" dir="2700000" algn="tl" rotWithShape="0">
-              <a:srgbClr val="000000">
-                <a:alpha val="40000"/>
-              </a:srgbClr>
-            </a:outerShdw>
-          </a:effectLst>
-        </p:spPr>
-        <p:style>
-          <a:lnRef idx="2">
-            <a:schemeClr val="accent1">
-              <a:shade val="50000"/>
-            </a:schemeClr>
-          </a:lnRef>
-          <a:fillRef idx="1">
-            <a:schemeClr val="accent1"/>
-          </a:fillRef>
-          <a:effectRef idx="0">
-            <a:schemeClr val="accent1"/>
-          </a:effectRef>
-          <a:fontRef idx="minor"/>
-        </p:style>
-        <p:txBody>
-          <a:bodyPr lIns="90000" tIns="45000" rIns="90000" bIns="45000" anchor="ctr">
-            <a:noAutofit/>
-          </a:bodyPr>
-          <a:lstStyle/>
-          <a:p>
-            <a:pPr algn="ctr"/>
-            <a:r>
-              <a:rPr lang="en-IN" sz="1280" spc="-2" dirty="0">
-                <a:solidFill>
-                  <a:srgbClr val="000000"/>
-                </a:solidFill>
-                <a:latin typeface="Arial"/>
-              </a:rPr>
-              <a:t>EtherNet/IP</a:t>
-            </a:r>
-          </a:p>
-          <a:p>
-            <a:pPr algn="ctr"/>
-            <a:r>
-              <a:rPr lang="en-IN" sz="1280" spc="-2" dirty="0">
-                <a:solidFill>
-                  <a:srgbClr val="000000"/>
-                </a:solidFill>
-                <a:latin typeface="Arial"/>
-              </a:rPr>
-              <a:t>FW HAL</a:t>
-            </a:r>
-          </a:p>
-        </p:txBody>
-      </p:sp>
-      <p:sp>
-        <p:nvSpPr>
-          <p:cNvPr id="91" name="CustomShape 8">
-            <a:extLst>
-              <a:ext uri="{FF2B5EF4-FFF2-40B4-BE49-F238E27FC236}">
-                <a16:creationId xmlns:a16="http://schemas.microsoft.com/office/drawing/2014/main" id="{8A63F40F-EA38-4A0D-9D2C-F4506ABF8E71}"/>
-              </a:ext>
-            </a:extLst>
-          </p:cNvPr>
-          <p:cNvSpPr/>
-          <p:nvPr/>
-        </p:nvSpPr>
-        <p:spPr>
-          <a:xfrm>
-            <a:off x="4202854" y="1632204"/>
-            <a:ext cx="903907" cy="408049"/>
-          </a:xfrm>
-          <a:prstGeom prst="rect">
-            <a:avLst/>
-          </a:prstGeom>
-          <a:solidFill>
-            <a:srgbClr val="92D050"/>
-          </a:solidFill>
-          <a:ln>
-            <a:noFill/>
-          </a:ln>
-          <a:effectLst>
-            <a:outerShdw blurRad="50760" dist="37674" dir="2700000" algn="tl" rotWithShape="0">
-              <a:srgbClr val="000000">
-                <a:alpha val="40000"/>
-              </a:srgbClr>
-            </a:outerShdw>
-          </a:effectLst>
-        </p:spPr>
-        <p:style>
-          <a:lnRef idx="2">
-            <a:schemeClr val="accent1">
-              <a:shade val="50000"/>
-            </a:schemeClr>
-          </a:lnRef>
-          <a:fillRef idx="1">
-            <a:schemeClr val="accent1"/>
-          </a:fillRef>
-          <a:effectRef idx="0">
-            <a:schemeClr val="accent1"/>
-          </a:effectRef>
-          <a:fontRef idx="minor"/>
-        </p:style>
-        <p:txBody>
-          <a:bodyPr lIns="90000" tIns="45000" rIns="90000" bIns="45000" anchor="ctr">
-            <a:noAutofit/>
-          </a:bodyPr>
-          <a:lstStyle/>
-          <a:p>
-            <a:pPr algn="ctr"/>
-            <a:r>
-              <a:rPr lang="en-IN" sz="1200" spc="-2" dirty="0">
-                <a:solidFill>
-                  <a:srgbClr val="000000"/>
-                </a:solidFill>
-                <a:latin typeface="Arial"/>
-              </a:rPr>
-              <a:t>IOLINK</a:t>
-            </a:r>
-          </a:p>
-        </p:txBody>
-      </p:sp>
-      <p:sp>
-        <p:nvSpPr>
-          <p:cNvPr id="101" name="CustomShape 8">
-            <a:extLst>
-              <a:ext uri="{FF2B5EF4-FFF2-40B4-BE49-F238E27FC236}">
-                <a16:creationId xmlns:a16="http://schemas.microsoft.com/office/drawing/2014/main" id="{4FD09517-BB27-4743-B00C-3AE6EA856D28}"/>
-              </a:ext>
-            </a:extLst>
-          </p:cNvPr>
-          <p:cNvSpPr/>
-          <p:nvPr/>
-        </p:nvSpPr>
-        <p:spPr>
-          <a:xfrm>
-            <a:off x="6377026" y="2646651"/>
-            <a:ext cx="1035994" cy="449640"/>
-          </a:xfrm>
-          <a:prstGeom prst="rect">
-            <a:avLst/>
-          </a:prstGeom>
-          <a:solidFill>
-            <a:srgbClr val="92D050"/>
-          </a:solidFill>
-          <a:ln>
-            <a:noFill/>
-          </a:ln>
-          <a:effectLst>
-            <a:outerShdw blurRad="50760" dist="37674" dir="2700000" algn="tl" rotWithShape="0">
-              <a:srgbClr val="000000">
-                <a:alpha val="40000"/>
-              </a:srgbClr>
-            </a:outerShdw>
-          </a:effectLst>
-        </p:spPr>
-        <p:style>
-          <a:lnRef idx="2">
-            <a:schemeClr val="accent1">
-              <a:shade val="50000"/>
-            </a:schemeClr>
-          </a:lnRef>
-          <a:fillRef idx="1">
-            <a:schemeClr val="accent1"/>
-          </a:fillRef>
-          <a:effectRef idx="0">
-            <a:schemeClr val="accent1"/>
-          </a:effectRef>
-          <a:fontRef idx="minor"/>
-        </p:style>
-        <p:txBody>
-          <a:bodyPr lIns="90000" tIns="45000" rIns="90000" bIns="45000" anchor="ctr">
-            <a:noAutofit/>
-          </a:bodyPr>
-          <a:lstStyle/>
-          <a:p>
-            <a:pPr algn="ctr"/>
-            <a:r>
-              <a:rPr lang="en-IN" sz="1280" spc="-2" dirty="0">
-                <a:solidFill>
-                  <a:srgbClr val="000000"/>
-                </a:solidFill>
-                <a:latin typeface="Arial"/>
-              </a:rPr>
-              <a:t>PROFINET</a:t>
-            </a:r>
-          </a:p>
-        </p:txBody>
-      </p:sp>
-      <p:sp>
-        <p:nvSpPr>
-          <p:cNvPr id="102" name="CustomShape 8">
-            <a:extLst>
-              <a:ext uri="{FF2B5EF4-FFF2-40B4-BE49-F238E27FC236}">
-                <a16:creationId xmlns:a16="http://schemas.microsoft.com/office/drawing/2014/main" id="{4A6996EB-9DD4-4FE9-BEC8-6A591048BBDD}"/>
-              </a:ext>
-            </a:extLst>
-          </p:cNvPr>
-          <p:cNvSpPr/>
-          <p:nvPr/>
-        </p:nvSpPr>
-        <p:spPr>
-          <a:xfrm>
-            <a:off x="5337120" y="1323019"/>
-            <a:ext cx="887044" cy="416730"/>
-          </a:xfrm>
-          <a:prstGeom prst="rect">
-            <a:avLst/>
-          </a:prstGeom>
-          <a:solidFill>
-            <a:srgbClr val="00B0F0"/>
-          </a:solidFill>
-          <a:ln>
-            <a:noFill/>
-          </a:ln>
-          <a:effectLst>
-            <a:outerShdw blurRad="50760" dist="37674" dir="2700000" algn="tl" rotWithShape="0">
-              <a:srgbClr val="000000">
-                <a:alpha val="40000"/>
-              </a:srgbClr>
-            </a:outerShdw>
-          </a:effectLst>
-        </p:spPr>
-        <p:style>
-          <a:lnRef idx="2">
-            <a:schemeClr val="accent1">
-              <a:shade val="50000"/>
-            </a:schemeClr>
-          </a:lnRef>
-          <a:fillRef idx="1">
-            <a:schemeClr val="accent1"/>
-          </a:fillRef>
-          <a:effectRef idx="0">
-            <a:schemeClr val="accent1"/>
-          </a:effectRef>
-          <a:fontRef idx="minor"/>
-        </p:style>
-        <p:txBody>
-          <a:bodyPr lIns="90000" tIns="45000" rIns="90000" bIns="45000" anchor="ctr">
-            <a:noAutofit/>
-          </a:bodyPr>
-          <a:lstStyle/>
-          <a:p>
-            <a:pPr algn="ctr"/>
-            <a:r>
-              <a:rPr lang="en-IN" sz="1200" spc="-2" dirty="0">
-                <a:solidFill>
                   <a:srgbClr val="000000"/>
                 </a:solidFill>
                 <a:latin typeface="Arial"/>
               </a:rPr>
               <a:t>RTLibs</a:t>
-            </a:r>
-          </a:p>
-        </p:txBody>
-      </p:sp>
-      <p:sp>
-        <p:nvSpPr>
-          <p:cNvPr id="103" name="CustomShape 8">
-            <a:extLst>
-              <a:ext uri="{FF2B5EF4-FFF2-40B4-BE49-F238E27FC236}">
-                <a16:creationId xmlns:a16="http://schemas.microsoft.com/office/drawing/2014/main" id="{5EA3E176-BC57-480C-ACFE-C9A6288FD716}"/>
-              </a:ext>
-            </a:extLst>
-          </p:cNvPr>
-          <p:cNvSpPr/>
-          <p:nvPr/>
-        </p:nvSpPr>
-        <p:spPr>
-          <a:xfrm>
-            <a:off x="5370887" y="4039101"/>
-            <a:ext cx="1012511" cy="474753"/>
-          </a:xfrm>
-          <a:prstGeom prst="rect">
-            <a:avLst/>
-          </a:prstGeom>
-          <a:solidFill>
-            <a:srgbClr val="00B0F0"/>
-          </a:solidFill>
-          <a:ln>
-            <a:noFill/>
-          </a:ln>
-          <a:effectLst>
-            <a:outerShdw blurRad="50760" dist="37674" dir="2700000" algn="tl" rotWithShape="0">
-              <a:srgbClr val="000000">
-                <a:alpha val="40000"/>
-              </a:srgbClr>
-            </a:outerShdw>
-          </a:effectLst>
-        </p:spPr>
-        <p:style>
-          <a:lnRef idx="2">
-            <a:schemeClr val="accent1">
-              <a:shade val="50000"/>
-            </a:schemeClr>
-          </a:lnRef>
-          <a:fillRef idx="1">
-            <a:schemeClr val="accent1"/>
-          </a:fillRef>
-          <a:effectRef idx="0">
-            <a:schemeClr val="accent1"/>
-          </a:effectRef>
-          <a:fontRef idx="minor"/>
-        </p:style>
-        <p:txBody>
-          <a:bodyPr lIns="90000" tIns="45000" rIns="90000" bIns="45000" anchor="ctr">
-            <a:noAutofit/>
-          </a:bodyPr>
-          <a:lstStyle/>
-          <a:p>
-            <a:pPr algn="ctr"/>
-            <a:r>
-              <a:rPr lang="en-IN" sz="1280" spc="-2" dirty="0">
-                <a:solidFill>
-                  <a:srgbClr val="000000"/>
-                </a:solidFill>
-                <a:latin typeface="Arial"/>
-              </a:rPr>
-              <a:t>RTLibs</a:t>
-            </a:r>
-          </a:p>
-        </p:txBody>
-      </p:sp>
-      <p:sp>
-        <p:nvSpPr>
-          <p:cNvPr id="104" name="CustomShape 8">
-            <a:extLst>
-              <a:ext uri="{FF2B5EF4-FFF2-40B4-BE49-F238E27FC236}">
-                <a16:creationId xmlns:a16="http://schemas.microsoft.com/office/drawing/2014/main" id="{5A3D3998-6F2D-4DAA-8D23-D1F33405E6E7}"/>
-              </a:ext>
-            </a:extLst>
-          </p:cNvPr>
-          <p:cNvSpPr/>
-          <p:nvPr/>
-        </p:nvSpPr>
-        <p:spPr>
-          <a:xfrm>
-            <a:off x="4200689" y="4357280"/>
-            <a:ext cx="1031759" cy="474752"/>
-          </a:xfrm>
-          <a:prstGeom prst="rect">
-            <a:avLst/>
-          </a:prstGeom>
-          <a:solidFill>
-            <a:srgbClr val="92D050"/>
-          </a:solidFill>
-          <a:ln>
-            <a:noFill/>
-          </a:ln>
-          <a:effectLst>
-            <a:outerShdw blurRad="50760" dist="37674" dir="2700000" algn="tl" rotWithShape="0">
-              <a:srgbClr val="000000">
-                <a:alpha val="40000"/>
-              </a:srgbClr>
-            </a:outerShdw>
-          </a:effectLst>
-        </p:spPr>
-        <p:style>
-          <a:lnRef idx="2">
-            <a:schemeClr val="accent1">
-              <a:shade val="50000"/>
-            </a:schemeClr>
-          </a:lnRef>
-          <a:fillRef idx="1">
-            <a:schemeClr val="accent1"/>
-          </a:fillRef>
-          <a:effectRef idx="0">
-            <a:schemeClr val="accent1"/>
-          </a:effectRef>
-          <a:fontRef idx="minor"/>
-        </p:style>
-        <p:txBody>
-          <a:bodyPr lIns="90000" tIns="45000" rIns="90000" bIns="45000" anchor="ctr">
-            <a:noAutofit/>
-          </a:bodyPr>
-          <a:lstStyle/>
-          <a:p>
-            <a:pPr algn="ctr"/>
-            <a:r>
-              <a:rPr lang="en-IN" sz="1280" spc="-2" dirty="0">
-                <a:solidFill>
-                  <a:srgbClr val="000000"/>
-                </a:solidFill>
-                <a:latin typeface="Arial"/>
-              </a:rPr>
-              <a:t>PROFINET</a:t>
-            </a:r>
-          </a:p>
-          <a:p>
-            <a:pPr algn="ctr"/>
-            <a:r>
-              <a:rPr lang="en-IN" sz="1280" spc="-2" dirty="0">
-                <a:solidFill>
-                  <a:srgbClr val="000000"/>
-                </a:solidFill>
-                <a:latin typeface="Arial"/>
-              </a:rPr>
-              <a:t>FW HAL</a:t>
             </a:r>
           </a:p>
         </p:txBody>
       </p:sp>
       <p:grpSp>
         <p:nvGrpSpPr>
-          <p:cNvPr id="7" name="Group 6">
+          <p:cNvPr id="6" name="Group 5">
             <a:extLst>
               <a:ext uri="{FF2B5EF4-FFF2-40B4-BE49-F238E27FC236}">
-                <a16:creationId xmlns:a16="http://schemas.microsoft.com/office/drawing/2014/main" id="{67A4F7D4-C33E-4B26-9D7C-C884A14DF543}"/>
+                <a16:creationId xmlns:a16="http://schemas.microsoft.com/office/drawing/2014/main" id="{2F1C7046-C779-4CDE-89D7-5E6DA3716311}"/>
               </a:ext>
             </a:extLst>
           </p:cNvPr>
@@ -14942,470 +14729,17 @@
         <p:grpSpPr>
           <a:xfrm>
             <a:off x="9461856" y="1555106"/>
-            <a:ext cx="1130602" cy="4044596"/>
-            <a:chOff x="9452859" y="1986347"/>
-            <a:chExt cx="1130602" cy="4044596"/>
+            <a:ext cx="1130602" cy="3496089"/>
+            <a:chOff x="7962195" y="1930422"/>
+            <a:chExt cx="1130602" cy="3496089"/>
           </a:xfrm>
         </p:grpSpPr>
-        <p:grpSp>
-          <p:nvGrpSpPr>
-            <p:cNvPr id="6" name="Group 5">
+        <p:sp>
+          <p:nvSpPr>
+            <p:cNvPr id="40" name="CustomShape 8">
               <a:extLst>
                 <a:ext uri="{FF2B5EF4-FFF2-40B4-BE49-F238E27FC236}">
-                  <a16:creationId xmlns:a16="http://schemas.microsoft.com/office/drawing/2014/main" id="{2F1C7046-C779-4CDE-89D7-5E6DA3716311}"/>
-                </a:ext>
-              </a:extLst>
-            </p:cNvPr>
-            <p:cNvGrpSpPr/>
-            <p:nvPr/>
-          </p:nvGrpSpPr>
-          <p:grpSpPr>
-            <a:xfrm>
-              <a:off x="9452859" y="1986347"/>
-              <a:ext cx="1130602" cy="3496089"/>
-              <a:chOff x="7962195" y="1930422"/>
-              <a:chExt cx="1130602" cy="3496089"/>
-            </a:xfrm>
-          </p:grpSpPr>
-          <p:sp>
-            <p:nvSpPr>
-              <p:cNvPr id="40" name="CustomShape 8">
-                <a:extLst>
-                  <a:ext uri="{FF2B5EF4-FFF2-40B4-BE49-F238E27FC236}">
-                    <a16:creationId xmlns:a16="http://schemas.microsoft.com/office/drawing/2014/main" id="{01121847-31DF-46AA-B838-EAFA788320FD}"/>
-                  </a:ext>
-                </a:extLst>
-              </p:cNvPr>
-              <p:cNvSpPr/>
-              <p:nvPr/>
-            </p:nvSpPr>
-            <p:spPr>
-              <a:xfrm>
-                <a:off x="7970653" y="4416651"/>
-                <a:ext cx="1114418" cy="370347"/>
-              </a:xfrm>
-              <a:prstGeom prst="rect">
-                <a:avLst/>
-              </a:prstGeom>
-              <a:solidFill>
-                <a:srgbClr val="92D050"/>
-              </a:solidFill>
-              <a:ln>
-                <a:noFill/>
-              </a:ln>
-              <a:effectLst>
-                <a:outerShdw blurRad="50760" dist="37674" dir="2700000" algn="tl" rotWithShape="0">
-                  <a:srgbClr val="000000">
-                    <a:alpha val="40000"/>
-                  </a:srgbClr>
-                </a:outerShdw>
-              </a:effectLst>
-            </p:spPr>
-            <p:style>
-              <a:lnRef idx="2">
-                <a:schemeClr val="accent1">
-                  <a:shade val="50000"/>
-                </a:schemeClr>
-              </a:lnRef>
-              <a:fillRef idx="1">
-                <a:schemeClr val="accent1"/>
-              </a:fillRef>
-              <a:effectRef idx="0">
-                <a:schemeClr val="accent1"/>
-              </a:effectRef>
-              <a:fontRef idx="minor"/>
-            </p:style>
-            <p:txBody>
-              <a:bodyPr lIns="56250" tIns="28125" rIns="56250" bIns="28125" anchor="ctr">
-                <a:noAutofit/>
-              </a:bodyPr>
-              <a:lstStyle/>
-              <a:p>
-                <a:pPr algn="ctr"/>
-                <a:r>
-                  <a:rPr lang="en-US" sz="1200" spc="-1" dirty="0">
-                    <a:solidFill>
-                      <a:srgbClr val="000000"/>
-                    </a:solidFill>
-                    <a:latin typeface="Arial"/>
-                  </a:rPr>
-                  <a:t>EtherCAT</a:t>
-                </a:r>
-                <a:endParaRPr lang="en-IN" sz="1200" spc="-1" dirty="0">
-                  <a:solidFill>
-                    <a:srgbClr val="000000"/>
-                  </a:solidFill>
-                  <a:latin typeface="Arial"/>
-                </a:endParaRPr>
-              </a:p>
-            </p:txBody>
-          </p:sp>
-          <p:sp>
-            <p:nvSpPr>
-              <p:cNvPr id="43" name="CustomShape 8">
-                <a:extLst>
-                  <a:ext uri="{FF2B5EF4-FFF2-40B4-BE49-F238E27FC236}">
-                    <a16:creationId xmlns:a16="http://schemas.microsoft.com/office/drawing/2014/main" id="{21E969EE-BA3E-4C5C-9730-05841FA4B7E2}"/>
-                  </a:ext>
-                </a:extLst>
-              </p:cNvPr>
-              <p:cNvSpPr/>
-              <p:nvPr/>
-            </p:nvSpPr>
-            <p:spPr>
-              <a:xfrm>
-                <a:off x="7976203" y="3777138"/>
-                <a:ext cx="1114418" cy="370347"/>
-              </a:xfrm>
-              <a:prstGeom prst="rect">
-                <a:avLst/>
-              </a:prstGeom>
-              <a:solidFill>
-                <a:srgbClr val="00B0F0"/>
-              </a:solidFill>
-              <a:ln>
-                <a:noFill/>
-              </a:ln>
-              <a:effectLst>
-                <a:outerShdw blurRad="50760" dist="37674" dir="2700000" algn="tl" rotWithShape="0">
-                  <a:srgbClr val="000000">
-                    <a:alpha val="40000"/>
-                  </a:srgbClr>
-                </a:outerShdw>
-              </a:effectLst>
-            </p:spPr>
-            <p:style>
-              <a:lnRef idx="2">
-                <a:schemeClr val="accent1">
-                  <a:shade val="50000"/>
-                </a:schemeClr>
-              </a:lnRef>
-              <a:fillRef idx="1">
-                <a:schemeClr val="accent1"/>
-              </a:fillRef>
-              <a:effectRef idx="0">
-                <a:schemeClr val="accent1"/>
-              </a:effectRef>
-              <a:fontRef idx="minor"/>
-            </p:style>
-            <p:txBody>
-              <a:bodyPr lIns="90000" tIns="45000" rIns="90000" bIns="45000" anchor="ctr">
-                <a:noAutofit/>
-              </a:bodyPr>
-              <a:lstStyle/>
-              <a:p>
-                <a:pPr algn="ctr"/>
-                <a:r>
-                  <a:rPr lang="en-US" sz="1200" spc="-2" dirty="0">
-                    <a:solidFill>
-                      <a:srgbClr val="000000"/>
-                    </a:solidFill>
-                    <a:latin typeface="Arial"/>
-                  </a:rPr>
-                  <a:t>Tamagawa</a:t>
-                </a:r>
-                <a:endParaRPr lang="en-IN" sz="1200" spc="-2" dirty="0">
-                  <a:solidFill>
-                    <a:srgbClr val="000000"/>
-                  </a:solidFill>
-                  <a:latin typeface="Arial"/>
-                </a:endParaRPr>
-              </a:p>
-            </p:txBody>
-          </p:sp>
-          <p:sp>
-            <p:nvSpPr>
-              <p:cNvPr id="50" name="CustomShape 8">
-                <a:extLst>
-                  <a:ext uri="{FF2B5EF4-FFF2-40B4-BE49-F238E27FC236}">
-                    <a16:creationId xmlns:a16="http://schemas.microsoft.com/office/drawing/2014/main" id="{E055C7A8-A374-428A-9BE3-DEE183B5BC39}"/>
-                  </a:ext>
-                </a:extLst>
-              </p:cNvPr>
-              <p:cNvSpPr/>
-              <p:nvPr/>
-            </p:nvSpPr>
-            <p:spPr>
-              <a:xfrm>
-                <a:off x="7978379" y="5056164"/>
-                <a:ext cx="1114418" cy="370347"/>
-              </a:xfrm>
-              <a:prstGeom prst="rect">
-                <a:avLst/>
-              </a:prstGeom>
-              <a:solidFill>
-                <a:srgbClr val="92D050"/>
-              </a:solidFill>
-              <a:ln>
-                <a:noFill/>
-              </a:ln>
-              <a:effectLst>
-                <a:outerShdw blurRad="50760" dist="37674" dir="2700000" algn="tl" rotWithShape="0">
-                  <a:srgbClr val="000000">
-                    <a:alpha val="40000"/>
-                  </a:srgbClr>
-                </a:outerShdw>
-              </a:effectLst>
-            </p:spPr>
-            <p:style>
-              <a:lnRef idx="2">
-                <a:schemeClr val="accent1">
-                  <a:shade val="50000"/>
-                </a:schemeClr>
-              </a:lnRef>
-              <a:fillRef idx="1">
-                <a:schemeClr val="accent1"/>
-              </a:fillRef>
-              <a:effectRef idx="0">
-                <a:schemeClr val="accent1"/>
-              </a:effectRef>
-              <a:fontRef idx="minor"/>
-            </p:style>
-            <p:txBody>
-              <a:bodyPr lIns="56250" tIns="28125" rIns="56250" bIns="28125" anchor="ctr">
-                <a:noAutofit/>
-              </a:bodyPr>
-              <a:lstStyle/>
-              <a:p>
-                <a:pPr algn="ctr"/>
-                <a:r>
-                  <a:rPr lang="en-US" sz="1200" spc="-1" dirty="0">
-                    <a:solidFill>
-                      <a:srgbClr val="000000"/>
-                    </a:solidFill>
-                    <a:latin typeface="Arial"/>
-                  </a:rPr>
-                  <a:t>EtherNet/IP</a:t>
-                </a:r>
-                <a:endParaRPr lang="en-IN" sz="1200" spc="-1" dirty="0">
-                  <a:solidFill>
-                    <a:srgbClr val="000000"/>
-                  </a:solidFill>
-                  <a:latin typeface="Arial"/>
-                </a:endParaRPr>
-              </a:p>
-            </p:txBody>
-          </p:sp>
-          <p:sp>
-            <p:nvSpPr>
-              <p:cNvPr id="55" name="CustomShape 8">
-                <a:extLst>
-                  <a:ext uri="{FF2B5EF4-FFF2-40B4-BE49-F238E27FC236}">
-                    <a16:creationId xmlns:a16="http://schemas.microsoft.com/office/drawing/2014/main" id="{94AD24C4-6F29-4547-8CCD-1924B387D323}"/>
-                  </a:ext>
-                </a:extLst>
-              </p:cNvPr>
-              <p:cNvSpPr/>
-              <p:nvPr/>
-            </p:nvSpPr>
-            <p:spPr>
-              <a:xfrm>
-                <a:off x="7962195" y="3137625"/>
-                <a:ext cx="1114418" cy="370347"/>
-              </a:xfrm>
-              <a:prstGeom prst="rect">
-                <a:avLst/>
-              </a:prstGeom>
-              <a:solidFill>
-                <a:srgbClr val="00B0F0"/>
-              </a:solidFill>
-              <a:ln>
-                <a:noFill/>
-              </a:ln>
-              <a:effectLst>
-                <a:outerShdw blurRad="50760" dist="37674" dir="2700000" algn="tl" rotWithShape="0">
-                  <a:srgbClr val="000000">
-                    <a:alpha val="40000"/>
-                  </a:srgbClr>
-                </a:outerShdw>
-              </a:effectLst>
-            </p:spPr>
-            <p:style>
-              <a:lnRef idx="2">
-                <a:schemeClr val="accent1">
-                  <a:shade val="50000"/>
-                </a:schemeClr>
-              </a:lnRef>
-              <a:fillRef idx="1">
-                <a:schemeClr val="accent1"/>
-              </a:fillRef>
-              <a:effectRef idx="0">
-                <a:schemeClr val="accent1"/>
-              </a:effectRef>
-              <a:fontRef idx="minor"/>
-            </p:style>
-            <p:txBody>
-              <a:bodyPr lIns="90000" tIns="45000" rIns="90000" bIns="45000" anchor="ctr">
-                <a:noAutofit/>
-              </a:bodyPr>
-              <a:lstStyle/>
-              <a:p>
-                <a:pPr algn="ctr"/>
-                <a:r>
-                  <a:rPr lang="en-IN" sz="1200" spc="-2" dirty="0">
-                    <a:solidFill>
-                      <a:srgbClr val="000000"/>
-                    </a:solidFill>
-                    <a:latin typeface="Arial"/>
-                  </a:rPr>
-                  <a:t>Nikon </a:t>
-                </a:r>
-              </a:p>
-              <a:p>
-                <a:pPr algn="ctr"/>
-                <a:r>
-                  <a:rPr lang="en-IN" sz="1200" spc="-2" dirty="0">
-                    <a:solidFill>
-                      <a:srgbClr val="000000"/>
-                    </a:solidFill>
-                    <a:latin typeface="Arial"/>
-                  </a:rPr>
-                  <a:t>A-format</a:t>
-                </a:r>
-              </a:p>
-            </p:txBody>
-          </p:sp>
-          <p:sp>
-            <p:nvSpPr>
-              <p:cNvPr id="67" name="CustomShape 8">
-                <a:extLst>
-                  <a:ext uri="{FF2B5EF4-FFF2-40B4-BE49-F238E27FC236}">
-                    <a16:creationId xmlns:a16="http://schemas.microsoft.com/office/drawing/2014/main" id="{E85276C1-A842-4B4A-B8F5-01BA41C2250F}"/>
-                  </a:ext>
-                </a:extLst>
-              </p:cNvPr>
-              <p:cNvSpPr/>
-              <p:nvPr/>
-            </p:nvSpPr>
-            <p:spPr>
-              <a:xfrm>
-                <a:off x="7962195" y="2508883"/>
-                <a:ext cx="1114418" cy="370347"/>
-              </a:xfrm>
-              <a:prstGeom prst="rect">
-                <a:avLst/>
-              </a:prstGeom>
-              <a:solidFill>
-                <a:srgbClr val="00B0F0"/>
-              </a:solidFill>
-              <a:ln>
-                <a:noFill/>
-              </a:ln>
-              <a:effectLst>
-                <a:outerShdw blurRad="50760" dist="37674" dir="2700000" algn="tl" rotWithShape="0">
-                  <a:srgbClr val="000000">
-                    <a:alpha val="40000"/>
-                  </a:srgbClr>
-                </a:outerShdw>
-              </a:effectLst>
-            </p:spPr>
-            <p:style>
-              <a:lnRef idx="2">
-                <a:schemeClr val="accent1">
-                  <a:shade val="50000"/>
-                </a:schemeClr>
-              </a:lnRef>
-              <a:fillRef idx="1">
-                <a:schemeClr val="accent1"/>
-              </a:fillRef>
-              <a:effectRef idx="0">
-                <a:schemeClr val="accent1"/>
-              </a:effectRef>
-              <a:fontRef idx="minor"/>
-            </p:style>
-            <p:txBody>
-              <a:bodyPr lIns="90000" tIns="45000" rIns="90000" bIns="45000" anchor="ctr">
-                <a:noAutofit/>
-              </a:bodyPr>
-              <a:lstStyle/>
-              <a:p>
-                <a:pPr algn="ctr"/>
-                <a:r>
-                  <a:rPr lang="en-IN" sz="1200" spc="-2" dirty="0">
-                    <a:solidFill>
-                      <a:srgbClr val="000000"/>
-                    </a:solidFill>
-                    <a:latin typeface="Arial"/>
-                  </a:rPr>
-                  <a:t>EnDat</a:t>
-                </a:r>
-              </a:p>
-            </p:txBody>
-          </p:sp>
-          <p:sp>
-            <p:nvSpPr>
-              <p:cNvPr id="76" name="CustomShape 8">
-                <a:extLst>
-                  <a:ext uri="{FF2B5EF4-FFF2-40B4-BE49-F238E27FC236}">
-                    <a16:creationId xmlns:a16="http://schemas.microsoft.com/office/drawing/2014/main" id="{666C0C31-20D4-4DA5-BBF8-7351CC90AE0A}"/>
-                  </a:ext>
-                </a:extLst>
-              </p:cNvPr>
-              <p:cNvSpPr/>
-              <p:nvPr/>
-            </p:nvSpPr>
-            <p:spPr>
-              <a:xfrm>
-                <a:off x="7962195" y="1930422"/>
-                <a:ext cx="1114418" cy="370347"/>
-              </a:xfrm>
-              <a:prstGeom prst="rect">
-                <a:avLst/>
-              </a:prstGeom>
-              <a:solidFill>
-                <a:srgbClr val="00B0F0"/>
-              </a:solidFill>
-              <a:ln>
-                <a:noFill/>
-              </a:ln>
-              <a:effectLst>
-                <a:outerShdw blurRad="50760" dist="37674" dir="2700000" algn="tl" rotWithShape="0">
-                  <a:srgbClr val="000000">
-                    <a:alpha val="40000"/>
-                  </a:srgbClr>
-                </a:outerShdw>
-              </a:effectLst>
-            </p:spPr>
-            <p:style>
-              <a:lnRef idx="2">
-                <a:schemeClr val="accent1">
-                  <a:shade val="50000"/>
-                </a:schemeClr>
-              </a:lnRef>
-              <a:fillRef idx="1">
-                <a:schemeClr val="accent1"/>
-              </a:fillRef>
-              <a:effectRef idx="0">
-                <a:schemeClr val="accent1"/>
-              </a:effectRef>
-              <a:fontRef idx="minor"/>
-            </p:style>
-            <p:txBody>
-              <a:bodyPr lIns="90000" tIns="45000" rIns="90000" bIns="45000" anchor="ctr">
-                <a:noAutofit/>
-              </a:bodyPr>
-              <a:lstStyle/>
-              <a:p>
-                <a:pPr algn="ctr"/>
-                <a:r>
-                  <a:rPr lang="en-IN" sz="1200" spc="-2" dirty="0">
-                    <a:solidFill>
-                      <a:srgbClr val="000000"/>
-                    </a:solidFill>
-                    <a:latin typeface="Arial"/>
-                  </a:rPr>
-                  <a:t>BiSS-C</a:t>
-                </a:r>
-              </a:p>
-            </p:txBody>
-          </p:sp>
-        </p:grpSp>
-        <p:sp>
-          <p:nvSpPr>
-            <p:cNvPr id="115" name="CustomShape 8">
-              <a:extLst>
-                <a:ext uri="{FF2B5EF4-FFF2-40B4-BE49-F238E27FC236}">
-                  <a16:creationId xmlns:a16="http://schemas.microsoft.com/office/drawing/2014/main" id="{51DC56F3-820F-4E0B-A74D-69BE72723CB9}"/>
+                  <a16:creationId xmlns:a16="http://schemas.microsoft.com/office/drawing/2014/main" id="{01121847-31DF-46AA-B838-EAFA788320FD}"/>
                 </a:ext>
               </a:extLst>
             </p:cNvPr>
@@ -15414,7 +14748,7 @@
           </p:nvSpPr>
           <p:spPr>
             <a:xfrm>
-              <a:off x="9467314" y="5660596"/>
+              <a:off x="7970653" y="4416651"/>
               <a:ext cx="1114418" cy="370347"/>
             </a:xfrm>
             <a:prstGeom prst="rect">
@@ -15462,7 +14796,7 @@
                   </a:solidFill>
                   <a:latin typeface="Arial"/>
                 </a:rPr>
-                <a:t>PROFINET</a:t>
+                <a:t>EtherCAT</a:t>
               </a:r>
               <a:endParaRPr lang="en-IN" sz="1200" spc="-1" dirty="0">
                 <a:solidFill>
@@ -15470,6 +14804,365 @@
                 </a:solidFill>
                 <a:latin typeface="Arial"/>
               </a:endParaRPr>
+            </a:p>
+          </p:txBody>
+        </p:sp>
+        <p:sp>
+          <p:nvSpPr>
+            <p:cNvPr id="43" name="CustomShape 8">
+              <a:extLst>
+                <a:ext uri="{FF2B5EF4-FFF2-40B4-BE49-F238E27FC236}">
+                  <a16:creationId xmlns:a16="http://schemas.microsoft.com/office/drawing/2014/main" id="{21E969EE-BA3E-4C5C-9730-05841FA4B7E2}"/>
+                </a:ext>
+              </a:extLst>
+            </p:cNvPr>
+            <p:cNvSpPr/>
+            <p:nvPr/>
+          </p:nvSpPr>
+          <p:spPr>
+            <a:xfrm>
+              <a:off x="7976203" y="3777138"/>
+              <a:ext cx="1114418" cy="370347"/>
+            </a:xfrm>
+            <a:prstGeom prst="rect">
+              <a:avLst/>
+            </a:prstGeom>
+            <a:solidFill>
+              <a:srgbClr val="00B0F0"/>
+            </a:solidFill>
+            <a:ln>
+              <a:noFill/>
+            </a:ln>
+            <a:effectLst>
+              <a:outerShdw blurRad="50760" dist="37674" dir="2700000" algn="tl" rotWithShape="0">
+                <a:srgbClr val="000000">
+                  <a:alpha val="40000"/>
+                </a:srgbClr>
+              </a:outerShdw>
+            </a:effectLst>
+          </p:spPr>
+          <p:style>
+            <a:lnRef idx="2">
+              <a:schemeClr val="accent1">
+                <a:shade val="50000"/>
+              </a:schemeClr>
+            </a:lnRef>
+            <a:fillRef idx="1">
+              <a:schemeClr val="accent1"/>
+            </a:fillRef>
+            <a:effectRef idx="0">
+              <a:schemeClr val="accent1"/>
+            </a:effectRef>
+            <a:fontRef idx="minor"/>
+          </p:style>
+          <p:txBody>
+            <a:bodyPr lIns="90000" tIns="45000" rIns="90000" bIns="45000" anchor="ctr">
+              <a:noAutofit/>
+            </a:bodyPr>
+            <a:lstStyle/>
+            <a:p>
+              <a:pPr algn="ctr"/>
+              <a:r>
+                <a:rPr lang="en-US" sz="1200" spc="-2" dirty="0">
+                  <a:solidFill>
+                    <a:srgbClr val="000000"/>
+                  </a:solidFill>
+                  <a:latin typeface="Arial"/>
+                </a:rPr>
+                <a:t>Tamagawa</a:t>
+              </a:r>
+              <a:endParaRPr lang="en-IN" sz="1200" spc="-2" dirty="0">
+                <a:solidFill>
+                  <a:srgbClr val="000000"/>
+                </a:solidFill>
+                <a:latin typeface="Arial"/>
+              </a:endParaRPr>
+            </a:p>
+          </p:txBody>
+        </p:sp>
+        <p:sp>
+          <p:nvSpPr>
+            <p:cNvPr id="50" name="CustomShape 8">
+              <a:extLst>
+                <a:ext uri="{FF2B5EF4-FFF2-40B4-BE49-F238E27FC236}">
+                  <a16:creationId xmlns:a16="http://schemas.microsoft.com/office/drawing/2014/main" id="{E055C7A8-A374-428A-9BE3-DEE183B5BC39}"/>
+                </a:ext>
+              </a:extLst>
+            </p:cNvPr>
+            <p:cNvSpPr/>
+            <p:nvPr/>
+          </p:nvSpPr>
+          <p:spPr>
+            <a:xfrm>
+              <a:off x="7978379" y="5056164"/>
+              <a:ext cx="1114418" cy="370347"/>
+            </a:xfrm>
+            <a:prstGeom prst="rect">
+              <a:avLst/>
+            </a:prstGeom>
+            <a:solidFill>
+              <a:srgbClr val="92D050"/>
+            </a:solidFill>
+            <a:ln>
+              <a:noFill/>
+            </a:ln>
+            <a:effectLst>
+              <a:outerShdw blurRad="50760" dist="37674" dir="2700000" algn="tl" rotWithShape="0">
+                <a:srgbClr val="000000">
+                  <a:alpha val="40000"/>
+                </a:srgbClr>
+              </a:outerShdw>
+            </a:effectLst>
+          </p:spPr>
+          <p:style>
+            <a:lnRef idx="2">
+              <a:schemeClr val="accent1">
+                <a:shade val="50000"/>
+              </a:schemeClr>
+            </a:lnRef>
+            <a:fillRef idx="1">
+              <a:schemeClr val="accent1"/>
+            </a:fillRef>
+            <a:effectRef idx="0">
+              <a:schemeClr val="accent1"/>
+            </a:effectRef>
+            <a:fontRef idx="minor"/>
+          </p:style>
+          <p:txBody>
+            <a:bodyPr lIns="56250" tIns="28125" rIns="56250" bIns="28125" anchor="ctr">
+              <a:noAutofit/>
+            </a:bodyPr>
+            <a:lstStyle/>
+            <a:p>
+              <a:pPr algn="ctr"/>
+              <a:r>
+                <a:rPr lang="en-US" sz="1200" spc="-1" dirty="0">
+                  <a:solidFill>
+                    <a:srgbClr val="000000"/>
+                  </a:solidFill>
+                  <a:latin typeface="Arial"/>
+                </a:rPr>
+                <a:t>EtherNet/IP</a:t>
+              </a:r>
+              <a:endParaRPr lang="en-IN" sz="1200" spc="-1" dirty="0">
+                <a:solidFill>
+                  <a:srgbClr val="000000"/>
+                </a:solidFill>
+                <a:latin typeface="Arial"/>
+              </a:endParaRPr>
+            </a:p>
+          </p:txBody>
+        </p:sp>
+        <p:sp>
+          <p:nvSpPr>
+            <p:cNvPr id="55" name="CustomShape 8">
+              <a:extLst>
+                <a:ext uri="{FF2B5EF4-FFF2-40B4-BE49-F238E27FC236}">
+                  <a16:creationId xmlns:a16="http://schemas.microsoft.com/office/drawing/2014/main" id="{94AD24C4-6F29-4547-8CCD-1924B387D323}"/>
+                </a:ext>
+              </a:extLst>
+            </p:cNvPr>
+            <p:cNvSpPr/>
+            <p:nvPr/>
+          </p:nvSpPr>
+          <p:spPr>
+            <a:xfrm>
+              <a:off x="7962195" y="3137625"/>
+              <a:ext cx="1114418" cy="370347"/>
+            </a:xfrm>
+            <a:prstGeom prst="rect">
+              <a:avLst/>
+            </a:prstGeom>
+            <a:solidFill>
+              <a:srgbClr val="00B0F0"/>
+            </a:solidFill>
+            <a:ln>
+              <a:noFill/>
+            </a:ln>
+            <a:effectLst>
+              <a:outerShdw blurRad="50760" dist="37674" dir="2700000" algn="tl" rotWithShape="0">
+                <a:srgbClr val="000000">
+                  <a:alpha val="40000"/>
+                </a:srgbClr>
+              </a:outerShdw>
+            </a:effectLst>
+          </p:spPr>
+          <p:style>
+            <a:lnRef idx="2">
+              <a:schemeClr val="accent1">
+                <a:shade val="50000"/>
+              </a:schemeClr>
+            </a:lnRef>
+            <a:fillRef idx="1">
+              <a:schemeClr val="accent1"/>
+            </a:fillRef>
+            <a:effectRef idx="0">
+              <a:schemeClr val="accent1"/>
+            </a:effectRef>
+            <a:fontRef idx="minor"/>
+          </p:style>
+          <p:txBody>
+            <a:bodyPr lIns="90000" tIns="45000" rIns="90000" bIns="45000" anchor="ctr">
+              <a:noAutofit/>
+            </a:bodyPr>
+            <a:lstStyle/>
+            <a:p>
+              <a:pPr algn="ctr"/>
+              <a:r>
+                <a:rPr lang="en-IN" sz="1200" spc="-2" dirty="0">
+                  <a:solidFill>
+                    <a:srgbClr val="000000"/>
+                  </a:solidFill>
+                  <a:latin typeface="Arial"/>
+                </a:rPr>
+                <a:t>Nikon </a:t>
+              </a:r>
+            </a:p>
+            <a:p>
+              <a:pPr algn="ctr"/>
+              <a:r>
+                <a:rPr lang="en-IN" sz="1200" spc="-2" dirty="0">
+                  <a:solidFill>
+                    <a:srgbClr val="000000"/>
+                  </a:solidFill>
+                  <a:latin typeface="Arial"/>
+                </a:rPr>
+                <a:t>A-format</a:t>
+              </a:r>
+            </a:p>
+          </p:txBody>
+        </p:sp>
+        <p:sp>
+          <p:nvSpPr>
+            <p:cNvPr id="67" name="CustomShape 8">
+              <a:extLst>
+                <a:ext uri="{FF2B5EF4-FFF2-40B4-BE49-F238E27FC236}">
+                  <a16:creationId xmlns:a16="http://schemas.microsoft.com/office/drawing/2014/main" id="{E85276C1-A842-4B4A-B8F5-01BA41C2250F}"/>
+                </a:ext>
+              </a:extLst>
+            </p:cNvPr>
+            <p:cNvSpPr/>
+            <p:nvPr/>
+          </p:nvSpPr>
+          <p:spPr>
+            <a:xfrm>
+              <a:off x="7962195" y="2508883"/>
+              <a:ext cx="1114418" cy="370347"/>
+            </a:xfrm>
+            <a:prstGeom prst="rect">
+              <a:avLst/>
+            </a:prstGeom>
+            <a:solidFill>
+              <a:srgbClr val="00B0F0"/>
+            </a:solidFill>
+            <a:ln>
+              <a:noFill/>
+            </a:ln>
+            <a:effectLst>
+              <a:outerShdw blurRad="50760" dist="37674" dir="2700000" algn="tl" rotWithShape="0">
+                <a:srgbClr val="000000">
+                  <a:alpha val="40000"/>
+                </a:srgbClr>
+              </a:outerShdw>
+            </a:effectLst>
+          </p:spPr>
+          <p:style>
+            <a:lnRef idx="2">
+              <a:schemeClr val="accent1">
+                <a:shade val="50000"/>
+              </a:schemeClr>
+            </a:lnRef>
+            <a:fillRef idx="1">
+              <a:schemeClr val="accent1"/>
+            </a:fillRef>
+            <a:effectRef idx="0">
+              <a:schemeClr val="accent1"/>
+            </a:effectRef>
+            <a:fontRef idx="minor"/>
+          </p:style>
+          <p:txBody>
+            <a:bodyPr lIns="90000" tIns="45000" rIns="90000" bIns="45000" anchor="ctr">
+              <a:noAutofit/>
+            </a:bodyPr>
+            <a:lstStyle/>
+            <a:p>
+              <a:pPr algn="ctr"/>
+              <a:r>
+                <a:rPr lang="en-IN" sz="1200" spc="-2" dirty="0">
+                  <a:solidFill>
+                    <a:srgbClr val="000000"/>
+                  </a:solidFill>
+                  <a:latin typeface="Arial"/>
+                </a:rPr>
+                <a:t>EnDat</a:t>
+              </a:r>
+            </a:p>
+          </p:txBody>
+        </p:sp>
+        <p:sp>
+          <p:nvSpPr>
+            <p:cNvPr id="76" name="CustomShape 8">
+              <a:extLst>
+                <a:ext uri="{FF2B5EF4-FFF2-40B4-BE49-F238E27FC236}">
+                  <a16:creationId xmlns:a16="http://schemas.microsoft.com/office/drawing/2014/main" id="{666C0C31-20D4-4DA5-BBF8-7351CC90AE0A}"/>
+                </a:ext>
+              </a:extLst>
+            </p:cNvPr>
+            <p:cNvSpPr/>
+            <p:nvPr/>
+          </p:nvSpPr>
+          <p:spPr>
+            <a:xfrm>
+              <a:off x="7962195" y="1930422"/>
+              <a:ext cx="1114418" cy="370347"/>
+            </a:xfrm>
+            <a:prstGeom prst="rect">
+              <a:avLst/>
+            </a:prstGeom>
+            <a:solidFill>
+              <a:srgbClr val="00B0F0"/>
+            </a:solidFill>
+            <a:ln>
+              <a:noFill/>
+            </a:ln>
+            <a:effectLst>
+              <a:outerShdw blurRad="50760" dist="37674" dir="2700000" algn="tl" rotWithShape="0">
+                <a:srgbClr val="000000">
+                  <a:alpha val="40000"/>
+                </a:srgbClr>
+              </a:outerShdw>
+            </a:effectLst>
+          </p:spPr>
+          <p:style>
+            <a:lnRef idx="2">
+              <a:schemeClr val="accent1">
+                <a:shade val="50000"/>
+              </a:schemeClr>
+            </a:lnRef>
+            <a:fillRef idx="1">
+              <a:schemeClr val="accent1"/>
+            </a:fillRef>
+            <a:effectRef idx="0">
+              <a:schemeClr val="accent1"/>
+            </a:effectRef>
+            <a:fontRef idx="minor"/>
+          </p:style>
+          <p:txBody>
+            <a:bodyPr lIns="90000" tIns="45000" rIns="90000" bIns="45000" anchor="ctr">
+              <a:noAutofit/>
+            </a:bodyPr>
+            <a:lstStyle/>
+            <a:p>
+              <a:pPr algn="ctr"/>
+              <a:r>
+                <a:rPr lang="en-IN" sz="1200" spc="-2" dirty="0">
+                  <a:solidFill>
+                    <a:srgbClr val="000000"/>
+                  </a:solidFill>
+                  <a:latin typeface="Arial"/>
+                </a:rPr>
+                <a:t>BiSS-C</a:t>
+              </a:r>
             </a:p>
           </p:txBody>
         </p:sp>

</xml_diff>